<commit_message>
Refocus SIH presentation on technical objectives and validation
</commit_message>
<xml_diff>
--- a/ppt/Spectra-Scheduler-SIH2026.pptx
+++ b/ppt/Spectra-Scheduler-SIH2026.pptx
@@ -758,7 +758,7 @@
           <a:lstStyle/>
           <a:p>
             <a:r>
-              <a:t>Built: simulator, receiver, tracker, 13 strategy comparisons and repeatable JSON/CSV reports. Proposed: HDF5 adapter, ML baselines, trained scheduler and later interface. Training labels may supervise association models on training files; they must not enter inference features or held-out decisions. Dataset emitter IDs are local to each file, not global classification targets. Recorded scan pulses are already censored by a fixed receiver schedule, so they cannot alone validate unobserved alternative tuning actions. Use scan data for association evaluation and simulator interaction for scheduling. Benchmark the periodic-scan special case separately against a constrained reference; do not claim optimality. Current waveform generator is an abstract model, not a calibrated spatial antenna simulator. Reference links on slide 6.</a:t>
+              <a:t>Architecture status: simulator, receiver abstraction, feature-based tracking, baseline policies and reproducible reports are implemented. Dataset ingestion and the contextual-bandit scheduler are planned. The learning objective is to improve the interception–latency trade-off while preserving discovery coverage and accounting for receiver transition costs. Candidate model complexity will be selected using validation evidence rather than assumed in advance. Training labels may supervise association on training files but cannot enter inference features. Dataset IDs are local to pulse-train files. Scan recordings support deinterleaving benchmarks; interactive simulation is required to compare alternative scheduling decisions. The periodic-scan case will receive a separate reference analysis. Rust acceleration is conditional on profiling; the architecture remains a small set of replaceable modules, not a microservice system.</a:t>
             </a:r>
           </a:p>
         </p:txBody>
@@ -872,7 +872,7 @@
           <a:lstStyle/>
           <a:p>
             <a:r>
-              <a:t>Evidence: PYTHONPATH=src python3 -m unittest discover -s tests -q completed with 123 passing tests. Counts checked against the comparison runner and scenario presets. The current mixed scenario, 100 seeds, gives 8.2% interception for adaptive dwell and 8.1% for track-aware: the more complex strategy is not yet a demonstrated improvement. This is why ML must beat the strongest baseline, not only a naive sweep. Performance optimizations already implemented: shared generated truth and independent worker processes. HDF5 streaming and Rust are proposals, not completed work. No hardware or GPU purchase is necessary for the current simulator; future model requirements must be measured.</a:t>
+              <a:t>Existing assurance methods include unit tests for emitter, receiver and tracking behaviour; integration tests for scenarios, command execution and reports; schema validation; deterministic replay; and sequential/parallel equivalence checks. Repeated seeded comparisons provide a statistical evaluation foundation. Planned validation extends this with distribution-shift stress tests, policy ablations, parameter sensitivity analysis and dataset-scale memory/latency benchmarks. Unit tests establish software correctness, not operational effectiveness. Development gates: validate HDF5 schema and units; establish pulse-association baselines; train and evaluate a contextual policy; profile and selectively accelerate; expose results through an API and analyst dashboard. Retain a periodic-scan reference case. Field validation is a separate future activity.</a:t>
             </a:r>
           </a:p>
         </p:txBody>
@@ -1045,7 +1045,7 @@
           <a:lstStyle/>
           <a:p>
             <a:r>
-              <a:t>Benefits are intended outcomes, not established field gains. Receiver detection probability is distinct from end-to-end interception: choosing the wrong band can miss a strong signal. Existing reports cover interception, discovery, delay, sensitivity loss, retuning and association. Explicit reward/cost and forecast-correctness/timing metrics remain to be added for full statement coverage. Compare policies on identical seeded events, fixed receiver budgets and held-out scenarios. Also evaluate the periodic-scan reference case separately. Do not infer threat identity or intent from anonymous pulse clusters. No monetary, energy-saving or operational accuracy claims are made.</a:t>
+              <a:t>The intended outcome is a reproducible platform that improves receiver-resource allocation and reduces policy-development effort. These are programme objectives, not already measured operational benefits. Acceptance requires comparison against the strongest baseline, not just a naive sweep, using identical events, receiver bandwidth, retuning constraints and held-out scenarios. Report uncertainty and scenario-specific trade-offs. Establish the decision-latency budget from the configured receiver dwell requirement and track tail latency as well as averages. Establish memory limits from available deployment resources rather than inventing a capacity claim. Improved pulse association and improved scheduling must be evaluated separately. The full metrics plan includes reward/cost, forecast correctness and intercept-time error in addition to existing interception and association reporting.</a:t>
             </a:r>
           </a:p>
         </p:txBody>
@@ -5733,7 +5733,7 @@
                 </a:solidFill>
                 <a:latin typeface="Liberation Sans"/>
               </a:rPr>
-              <a:t>Adaptive spectrum scanning</a:t>
+              <a:t>Cognitive spectrum management</a:t>
             </a:r>
           </a:p>
           <a:p>
@@ -5755,7 +5755,7 @@
                 </a:solidFill>
                 <a:latin typeface="Liberation Sans"/>
               </a:rPr>
-              <a:t>A simulation-first software prototype</a:t>
+              <a:t>ML-driven receiver scheduling — proposed</a:t>
             </a:r>
           </a:p>
         </p:txBody>
@@ -6502,23 +6502,23 @@
           <a:p>
             <a:pPr>
               <a:lnSpc>
-                <a:spcPts val="3172"/>
-              </a:lnSpc>
-              <a:spcBef>
-                <a:spcPts val="0"/>
-              </a:spcBef>
-              <a:spcAft>
-                <a:spcPts val="0"/>
-              </a:spcAft>
-            </a:pPr>
-            <a:r>
-              <a:rPr sz="2600" b="1">
+                <a:spcPts val="3050"/>
+              </a:lnSpc>
+              <a:spcBef>
+                <a:spcPts val="0"/>
+              </a:spcBef>
+              <a:spcAft>
+                <a:spcPts val="0"/>
+              </a:spcAft>
+            </a:pPr>
+            <a:r>
+              <a:rPr sz="2500" b="1">
                 <a:solidFill>
                   <a:srgbClr val="17344B"/>
                 </a:solidFill>
                 <a:latin typeface="Liberation Sans"/>
               </a:rPr>
-              <a:t>Spectra Scheduler: learn where and when to listen</a:t>
+              <a:t>Spectra Scheduler: confidence-aware adaptive scanning</a:t>
             </a:r>
           </a:p>
         </p:txBody>
@@ -6563,7 +6563,7 @@
                 </a:solidFill>
                 <a:latin typeface="Liberation Sans"/>
               </a:rPr>
-              <a:t>Proposed solution: a feedback-driven scheduler for a receiver that can observe</a:t>
+              <a:t>Proposed solution: closed-loop spectrum scheduling that combines online learning,</a:t>
             </a:r>
           </a:p>
           <a:p>
@@ -6585,7 +6585,7 @@
                 </a:solidFill>
                 <a:latin typeface="Liberation Sans"/>
               </a:rPr>
-              <a:t>only a small part of the spectrum at once.</a:t>
+              <a:t>pulse association and receiver constraints to optimise frequency–time allocation.</a:t>
             </a:r>
           </a:p>
         </p:txBody>
@@ -6767,89 +6767,89 @@
           <a:p>
             <a:pPr>
               <a:lnSpc>
-                <a:spcPts val="2074"/>
-              </a:lnSpc>
-              <a:spcBef>
-                <a:spcPts val="0"/>
-              </a:spcBef>
-              <a:spcAft>
-                <a:spcPts val="0"/>
-              </a:spcAft>
-            </a:pPr>
-            <a:r>
-              <a:rPr sz="1700" b="0">
+                <a:spcPts val="1952"/>
+              </a:lnSpc>
+              <a:spcBef>
+                <a:spcPts val="0"/>
+              </a:spcBef>
+              <a:spcAft>
+                <a:spcPts val="0"/>
+              </a:spcAft>
+            </a:pPr>
+            <a:r>
+              <a:rPr sz="1600" b="0">
                 <a:solidFill>
                   <a:srgbClr val="17344B"/>
                 </a:solidFill>
                 <a:latin typeface="Liberation Sans"/>
               </a:rPr>
-              <a:t>Simulate changing emitters.</a:t>
-            </a:r>
-          </a:p>
-          <a:p>
-            <a:pPr>
-              <a:lnSpc>
-                <a:spcPts val="2074"/>
-              </a:lnSpc>
-              <a:spcBef>
-                <a:spcPts val="0"/>
-              </a:spcBef>
-              <a:spcAft>
-                <a:spcPts val="0"/>
-              </a:spcAft>
-            </a:pPr>
-            <a:r>
-              <a:rPr sz="1700" b="0">
+              <a:t>Stochastic RF environment model.</a:t>
+            </a:r>
+          </a:p>
+          <a:p>
+            <a:pPr>
+              <a:lnSpc>
+                <a:spcPts val="1952"/>
+              </a:lnSpc>
+              <a:spcBef>
+                <a:spcPts val="0"/>
+              </a:spcBef>
+              <a:spcAft>
+                <a:spcPts val="0"/>
+              </a:spcAft>
+            </a:pPr>
+            <a:r>
+              <a:rPr sz="1600" b="0">
                 <a:solidFill>
                   <a:srgbClr val="17344B"/>
                 </a:solidFill>
                 <a:latin typeface="Liberation Sans"/>
               </a:rPr>
-              <a:t>Observe noisy hits and misses.</a:t>
-            </a:r>
-          </a:p>
-          <a:p>
-            <a:pPr>
-              <a:lnSpc>
-                <a:spcPts val="2074"/>
-              </a:lnSpc>
-              <a:spcBef>
-                <a:spcPts val="0"/>
-              </a:spcBef>
-              <a:spcAft>
-                <a:spcPts val="0"/>
-              </a:spcAft>
-            </a:pPr>
-            <a:r>
-              <a:rPr sz="1700" b="0">
+              <a:t>Pulse descriptor association.</a:t>
+            </a:r>
+          </a:p>
+          <a:p>
+            <a:pPr>
+              <a:lnSpc>
+                <a:spcPts val="1952"/>
+              </a:lnSpc>
+              <a:spcBef>
+                <a:spcPts val="0"/>
+              </a:spcBef>
+              <a:spcAft>
+                <a:spcPts val="0"/>
+              </a:spcAft>
+            </a:pPr>
+            <a:r>
+              <a:rPr sz="1600" b="0">
                 <a:solidFill>
                   <a:srgbClr val="17344B"/>
                 </a:solidFill>
                 <a:latin typeface="Liberation Sans"/>
               </a:rPr>
-              <a:t>Associate pulses into tracks.</a:t>
-            </a:r>
-          </a:p>
-          <a:p>
-            <a:pPr>
-              <a:lnSpc>
-                <a:spcPts val="2074"/>
-              </a:lnSpc>
-              <a:spcBef>
-                <a:spcPts val="0"/>
-              </a:spcBef>
-              <a:spcAft>
-                <a:spcPts val="0"/>
-              </a:spcAft>
-            </a:pPr>
-            <a:r>
-              <a:rPr sz="1700" b="0">
+              <a:t>Contextual learning from feedback.</a:t>
+            </a:r>
+          </a:p>
+          <a:p>
+            <a:pPr>
+              <a:lnSpc>
+                <a:spcPts val="1952"/>
+              </a:lnSpc>
+              <a:spcBef>
+                <a:spcPts val="0"/>
+              </a:spcBef>
+              <a:spcAft>
+                <a:spcPts val="0"/>
+              </a:spcAft>
+            </a:pPr>
+            <a:r>
+              <a:rPr sz="1600" b="0">
                 <a:solidFill>
                   <a:srgbClr val="17344B"/>
                 </a:solidFill>
                 <a:latin typeface="Liberation Sans"/>
               </a:rPr>
-              <a:t>Choose the next band and dwell.</a:t>
+              <a:t>Adaptive band and dwell selection.</a:t>
             </a:r>
           </a:p>
         </p:txBody>
@@ -7031,89 +7031,89 @@
           <a:p>
             <a:pPr>
               <a:lnSpc>
-                <a:spcPts val="2074"/>
-              </a:lnSpc>
-              <a:spcBef>
-                <a:spcPts val="0"/>
-              </a:spcBef>
-              <a:spcAft>
-                <a:spcPts val="0"/>
-              </a:spcAft>
-            </a:pPr>
-            <a:r>
-              <a:rPr sz="1700" b="0">
+                <a:spcPts val="1952"/>
+              </a:lnSpc>
+              <a:spcBef>
+                <a:spcPts val="0"/>
+              </a:spcBef>
+              <a:spcAft>
+                <a:spcPts val="0"/>
+              </a:spcAft>
+            </a:pPr>
+            <a:r>
+              <a:rPr sz="1600" b="0">
                 <a:solidFill>
                   <a:srgbClr val="17344B"/>
                 </a:solidFill>
                 <a:latin typeface="Liberation Sans"/>
               </a:rPr>
-              <a:t>Update from new observations.</a:t>
-            </a:r>
-          </a:p>
-          <a:p>
-            <a:pPr>
-              <a:lnSpc>
-                <a:spcPts val="2074"/>
-              </a:lnSpc>
-              <a:spcBef>
-                <a:spcPts val="0"/>
-              </a:spcBef>
-              <a:spcAft>
-                <a:spcPts val="0"/>
-              </a:spcAft>
-            </a:pPr>
-            <a:r>
-              <a:rPr sz="1700" b="0">
+              <a:t>Reduce time to first interception.</a:t>
+            </a:r>
+          </a:p>
+          <a:p>
+            <a:pPr>
+              <a:lnSpc>
+                <a:spcPts val="1952"/>
+              </a:lnSpc>
+              <a:spcBef>
+                <a:spcPts val="0"/>
+              </a:spcBef>
+              <a:spcAft>
+                <a:spcPts val="0"/>
+              </a:spcAft>
+            </a:pPr>
+            <a:r>
+              <a:rPr sz="1600" b="0">
                 <a:solidFill>
                   <a:srgbClr val="17344B"/>
                 </a:solidFill>
                 <a:latin typeface="Liberation Sans"/>
               </a:rPr>
-              <a:t>Revisit likely signal activity.</a:t>
-            </a:r>
-          </a:p>
-          <a:p>
-            <a:pPr>
-              <a:lnSpc>
-                <a:spcPts val="2074"/>
-              </a:lnSpc>
-              <a:spcBef>
-                <a:spcPts val="0"/>
-              </a:spcBef>
-              <a:spcAft>
-                <a:spcPts val="0"/>
-              </a:spcAft>
-            </a:pPr>
-            <a:r>
-              <a:rPr sz="1700" b="0">
+              <a:t>Adapt to non-stationary activity.</a:t>
+            </a:r>
+          </a:p>
+          <a:p>
+            <a:pPr>
+              <a:lnSpc>
+                <a:spcPts val="1952"/>
+              </a:lnSpc>
+              <a:spcBef>
+                <a:spcPts val="0"/>
+              </a:spcBef>
+              <a:spcAft>
+                <a:spcPts val="0"/>
+              </a:spcAft>
+            </a:pPr>
+            <a:r>
+              <a:rPr sz="1600" b="0">
                 <a:solidFill>
                   <a:srgbClr val="17344B"/>
                 </a:solidFill>
                 <a:latin typeface="Liberation Sans"/>
               </a:rPr>
-              <a:t>Retain broad-band discovery.</a:t>
-            </a:r>
-          </a:p>
-          <a:p>
-            <a:pPr>
-              <a:lnSpc>
-                <a:spcPts val="2074"/>
-              </a:lnSpc>
-              <a:spcBef>
-                <a:spcPts val="0"/>
-              </a:spcBef>
-              <a:spcAft>
-                <a:spcPts val="0"/>
-              </a:spcAft>
-            </a:pPr>
-            <a:r>
-              <a:rPr sz="1700" b="0">
+              <a:t>Limit spectrum coverage gaps.</a:t>
+            </a:r>
+          </a:p>
+          <a:p>
+            <a:pPr>
+              <a:lnSpc>
+                <a:spcPts val="1952"/>
+              </a:lnSpc>
+              <a:spcBef>
+                <a:spcPts val="0"/>
+              </a:spcBef>
+              <a:spcAft>
+                <a:spcPts val="0"/>
+              </a:spcAft>
+            </a:pPr>
+            <a:r>
+              <a:rPr sz="1600" b="0">
                 <a:solidFill>
                   <a:srgbClr val="17344B"/>
                 </a:solidFill>
                 <a:latin typeface="Liberation Sans"/>
               </a:rPr>
-              <a:t>Include receiver retuning cost.</a:t>
+              <a:t>Account for retuning overhead.</a:t>
             </a:r>
           </a:p>
         </p:txBody>
@@ -7295,89 +7295,89 @@
           <a:p>
             <a:pPr>
               <a:lnSpc>
-                <a:spcPts val="2074"/>
-              </a:lnSpc>
-              <a:spcBef>
-                <a:spcPts val="0"/>
-              </a:spcBef>
-              <a:spcAft>
-                <a:spcPts val="0"/>
-              </a:spcAft>
-            </a:pPr>
-            <a:r>
-              <a:rPr sz="1700" b="0">
+                <a:spcPts val="1952"/>
+              </a:lnSpc>
+              <a:spcBef>
+                <a:spcPts val="0"/>
+              </a:spcBef>
+              <a:spcAft>
+                <a:spcPts val="0"/>
+              </a:spcAft>
+            </a:pPr>
+            <a:r>
+              <a:rPr sz="1600" b="0">
                 <a:solidFill>
                   <a:srgbClr val="17344B"/>
                 </a:solidFill>
                 <a:latin typeface="Liberation Sans"/>
               </a:rPr>
-              <a:t>Combine track confidence,</a:t>
-            </a:r>
-          </a:p>
-          <a:p>
-            <a:pPr>
-              <a:lnSpc>
-                <a:spcPts val="2074"/>
-              </a:lnSpc>
-              <a:spcBef>
-                <a:spcPts val="0"/>
-              </a:spcBef>
-              <a:spcAft>
-                <a:spcPts val="0"/>
-              </a:spcAft>
-            </a:pPr>
-            <a:r>
-              <a:rPr sz="1700" b="0">
+              <a:t>Confidence-aware scheduling.</a:t>
+            </a:r>
+          </a:p>
+          <a:p>
+            <a:pPr>
+              <a:lnSpc>
+                <a:spcPts val="1952"/>
+              </a:lnSpc>
+              <a:spcBef>
+                <a:spcPts val="0"/>
+              </a:spcBef>
+              <a:spcAft>
+                <a:spcPts val="0"/>
+              </a:spcAft>
+            </a:pPr>
+            <a:r>
+              <a:rPr sz="1600" b="0">
                 <a:solidFill>
                   <a:srgbClr val="17344B"/>
                 </a:solidFill>
                 <a:latin typeface="Liberation Sans"/>
               </a:rPr>
-              <a:t>change response and coverage.</a:t>
-            </a:r>
-          </a:p>
-          <a:p>
-            <a:pPr>
-              <a:lnSpc>
-                <a:spcPts val="2074"/>
-              </a:lnSpc>
-              <a:spcBef>
-                <a:spcPts val="0"/>
-              </a:spcBef>
-              <a:spcAft>
-                <a:spcPts val="0"/>
-              </a:spcAft>
-            </a:pPr>
-            <a:r>
-              <a:rPr sz="1700" b="0">
+              <a:t>Joint discovery and revisit control.</a:t>
+            </a:r>
+          </a:p>
+          <a:p>
+            <a:pPr>
+              <a:lnSpc>
+                <a:spcPts val="1952"/>
+              </a:lnSpc>
+              <a:spcBef>
+                <a:spcPts val="0"/>
+              </a:spcBef>
+              <a:spcAft>
+                <a:spcPts val="0"/>
+              </a:spcAft>
+            </a:pPr>
+            <a:r>
+              <a:rPr sz="1600" b="0">
                 <a:solidFill>
                   <a:srgbClr val="17344B"/>
                 </a:solidFill>
                 <a:latin typeface="Liberation Sans"/>
               </a:rPr>
-              <a:t>Test each part against baselines.</a:t>
-            </a:r>
-          </a:p>
-          <a:p>
-            <a:pPr>
-              <a:lnSpc>
-                <a:spcPts val="2074"/>
-              </a:lnSpc>
-              <a:spcBef>
-                <a:spcPts val="0"/>
-              </a:spcBef>
-              <a:spcAft>
-                <a:spcPts val="0"/>
-              </a:spcAft>
-            </a:pPr>
-            <a:r>
-              <a:rPr sz="1700" b="0">
+              <a:t>Change-responsive track memory.</a:t>
+            </a:r>
+          </a:p>
+          <a:p>
+            <a:pPr>
+              <a:lnSpc>
+                <a:spcPts val="1952"/>
+              </a:lnSpc>
+              <a:spcBef>
+                <a:spcPts val="0"/>
+              </a:spcBef>
+              <a:spcAft>
+                <a:spcPts val="0"/>
+              </a:spcAft>
+            </a:pPr>
+            <a:r>
+              <a:rPr sz="1600" b="0">
                 <a:solidFill>
                   <a:srgbClr val="17344B"/>
                 </a:solidFill>
                 <a:latin typeface="Liberation Sans"/>
               </a:rPr>
-              <a:t>Keep decisions inspectable.</a:t>
+              <a:t>Traceable policy evaluation.</a:t>
             </a:r>
           </a:p>
         </p:txBody>
@@ -7449,23 +7449,23 @@
           <a:p>
             <a:pPr>
               <a:lnSpc>
-                <a:spcPts val="2684"/>
-              </a:lnSpc>
-              <a:spcBef>
-                <a:spcPts val="0"/>
-              </a:spcBef>
-              <a:spcAft>
-                <a:spcPts val="0"/>
-              </a:spcAft>
-            </a:pPr>
-            <a:r>
-              <a:rPr sz="2200" b="1">
+                <a:spcPts val="2318"/>
+              </a:lnSpc>
+              <a:spcBef>
+                <a:spcPts val="0"/>
+              </a:spcBef>
+              <a:spcAft>
+                <a:spcPts val="0"/>
+              </a:spcAft>
+            </a:pPr>
+            <a:r>
+              <a:rPr sz="1900" b="1">
                 <a:solidFill>
                   <a:srgbClr val="0070C0"/>
                 </a:solidFill>
                 <a:latin typeface="Liberation Sans"/>
               </a:rPr>
-              <a:t>OBSERVE  &gt;  ASSOCIATE  &gt;  SCHEDULE  &gt;  UPDATE</a:t>
+              <a:t>DESIGN OBJECTIVE: HIGHER INTERCEPTION, LOWER SEARCH LATENCY</a:t>
             </a:r>
           </a:p>
         </p:txBody>
@@ -7987,7 +7987,7 @@
                 </a:solidFill>
                 <a:latin typeface="Liberation Sans"/>
               </a:rPr>
-              <a:t>RF simulator</a:t>
+              <a:t>RF environment</a:t>
             </a:r>
           </a:p>
         </p:txBody>
@@ -8032,7 +8032,7 @@
                 </a:solidFill>
                 <a:latin typeface="Liberation Sans"/>
               </a:rPr>
-              <a:t>Periodic, hopping and</a:t>
+              <a:t>Stochastic emissions;</a:t>
             </a:r>
           </a:p>
           <a:p>
@@ -8054,7 +8054,7 @@
                 </a:solidFill>
                 <a:latin typeface="Liberation Sans"/>
               </a:rPr>
-              <a:t>changing emitters</a:t>
+              <a:t>frequency-agile sources</a:t>
             </a:r>
           </a:p>
         </p:txBody>
@@ -8234,7 +8234,7 @@
                 </a:solidFill>
                 <a:latin typeface="Liberation Sans"/>
               </a:rPr>
-              <a:t>Band + dwell; noise,</a:t>
+              <a:t>Partial observations;</a:t>
             </a:r>
           </a:p>
           <a:p>
@@ -8256,7 +8256,7 @@
                 </a:solidFill>
                 <a:latin typeface="Liberation Sans"/>
               </a:rPr>
-              <a:t>sensitivity and retuning</a:t>
+              <a:t>noise and retuning cost</a:t>
             </a:r>
           </a:p>
         </p:txBody>
@@ -8391,7 +8391,7 @@
                 </a:solidFill>
                 <a:latin typeface="Liberation Sans"/>
               </a:rPr>
-              <a:t>Track association</a:t>
+              <a:t>Pulse association</a:t>
             </a:r>
           </a:p>
         </p:txBody>
@@ -8436,7 +8436,7 @@
                 </a:solidFill>
                 <a:latin typeface="Liberation Sans"/>
               </a:rPr>
-              <a:t>Anonymous pulse</a:t>
+              <a:t>Feature-based tracks;</a:t>
             </a:r>
           </a:p>
           <a:p>
@@ -8458,7 +8458,7 @@
                 </a:solidFill>
                 <a:latin typeface="Liberation Sans"/>
               </a:rPr>
-              <a:t>measurements and history</a:t>
+              <a:t>confidence estimation</a:t>
             </a:r>
           </a:p>
         </p:txBody>
@@ -8593,7 +8593,7 @@
                 </a:solidFill>
                 <a:latin typeface="Liberation Sans"/>
               </a:rPr>
-              <a:t>Scheduler</a:t>
+              <a:t>Adaptive policy</a:t>
             </a:r>
           </a:p>
         </p:txBody>
@@ -8638,7 +8638,7 @@
                 </a:solidFill>
                 <a:latin typeface="Liberation Sans"/>
               </a:rPr>
-              <a:t>Baselines now;</a:t>
+              <a:t>Contextual bandit</a:t>
             </a:r>
           </a:p>
           <a:p>
@@ -8660,7 +8660,7 @@
                 </a:solidFill>
                 <a:latin typeface="Liberation Sans"/>
               </a:rPr>
-              <a:t>ML policy planned</a:t>
+              <a:t>with coverage constraints</a:t>
             </a:r>
           </a:p>
         </p:txBody>
@@ -8810,7 +8810,7 @@
                 </a:solidFill>
                 <a:latin typeface="Liberation Sans"/>
               </a:rPr>
-              <a:t>Next tuning action; learn only from observed feedback</a:t>
+              <a:t>Closed-loop feedback: observations update the next scheduling decision</a:t>
             </a:r>
           </a:p>
         </p:txBody>
@@ -8900,7 +8900,7 @@
                 </a:solidFill>
                 <a:latin typeface="Liberation Sans"/>
               </a:rPr>
-              <a:t>Python + NumPy; simple package modules.</a:t>
+              <a:t>Python / NumPy: modular simulation and evaluation.</a:t>
             </a:r>
           </a:p>
           <a:p>
@@ -8922,7 +8922,7 @@
                 </a:solidFill>
                 <a:latin typeface="Liberation Sans"/>
               </a:rPr>
-              <a:t>HDF5 / h5py for bounded data batches (next).</a:t>
+              <a:t>HDF5 / h5py: planned bounded-memory ingestion.</a:t>
             </a:r>
           </a:p>
           <a:p>
@@ -8944,7 +8944,7 @@
                 </a:solidFill>
                 <a:latin typeface="Liberation Sans"/>
               </a:rPr>
-              <a:t>scikit-learn baseline; PyTorch if justified (next).</a:t>
+              <a:t>scikit-learn / PyTorch: proposed learning stack.</a:t>
             </a:r>
           </a:p>
           <a:p>
@@ -8966,7 +8966,7 @@
                 </a:solidFill>
                 <a:latin typeface="Liberation Sans"/>
               </a:rPr>
-              <a:t>Rust / PyO3 only for profiled bottlenecks (later).</a:t>
+              <a:t>Rust / PyO3: selective acceleration after profiling.</a:t>
             </a:r>
           </a:p>
         </p:txBody>
@@ -9056,7 +9056,7 @@
                 </a:solidFill>
                 <a:latin typeface="Liberation Sans"/>
               </a:rPr>
-              <a:t>TSRD: arrival time, frequency, width, angle, amplitude.</a:t>
+              <a:t>TSRD features: ToA, frequency, width, angle, amplitude.</a:t>
             </a:r>
           </a:p>
           <a:p>
@@ -9078,7 +9078,7 @@
                 </a:solidFill>
                 <a:latin typeface="Liberation Sans"/>
               </a:rPr>
-              <a:t>Keep train / validation / test files separate.</a:t>
+              <a:t>Pipeline: schema validation &gt; clustering &gt; policy training.</a:t>
             </a:r>
           </a:p>
           <a:p>
@@ -9100,7 +9100,7 @@
                 </a:solidFill>
                 <a:latin typeface="Liberation Sans"/>
               </a:rPr>
-              <a:t>First: pulse-clustering baseline on a small subset.</a:t>
+              <a:t>Learn from simulator hits/misses; hold out scenarios.</a:t>
             </a:r>
           </a:p>
           <a:p>
@@ -9122,7 +9122,7 @@
                 </a:solidFill>
                 <a:latin typeface="Liberation Sans"/>
               </a:rPr>
-              <a:t>Next: contextual-bandit scheduler trained on</a:t>
+              <a:t>Use file-level train / validation / test separation.</a:t>
             </a:r>
           </a:p>
           <a:p>
@@ -9144,7 +9144,7 @@
                 </a:solidFill>
                 <a:latin typeface="Liberation Sans"/>
               </a:rPr>
-              <a:t>simulator hits/misses; test on held-out scenarios.</a:t>
+              <a:t>Keep emitter identities outside inference features.</a:t>
             </a:r>
           </a:p>
         </p:txBody>
@@ -9173,23 +9173,23 @@
           <a:p>
             <a:pPr>
               <a:lnSpc>
-                <a:spcPts val="1707"/>
-              </a:lnSpc>
-              <a:spcBef>
-                <a:spcPts val="0"/>
-              </a:spcBef>
-              <a:spcAft>
-                <a:spcPts val="0"/>
-              </a:spcAft>
-            </a:pPr>
-            <a:r>
-              <a:rPr sz="1400" b="0">
+                <a:spcPts val="1647"/>
+              </a:lnSpc>
+              <a:spcBef>
+                <a:spcPts val="0"/>
+              </a:spcBef>
+              <a:spcAft>
+                <a:spcPts val="0"/>
+              </a:spcAft>
+            </a:pPr>
+            <a:r>
+              <a:rPr sz="1350" b="0">
                 <a:solidFill>
                   <a:srgbClr val="526574"/>
                 </a:solidFill>
                 <a:latin typeface="Liberation Sans"/>
               </a:rPr>
-              <a:t>Truth labels go to evaluation only at inference.  |  Reports first; API and GUI later.  [1–3]</a:t>
+              <a:t>Proposed end-to-end architecture; simulation and heuristic evaluation form the existing foundation.  [1–3]</a:t>
             </a:r>
           </a:p>
         </p:txBody>
@@ -9636,7 +9636,7 @@
                 </a:solidFill>
                 <a:latin typeface="Liberation Sans"/>
               </a:rPr>
-              <a:t>Analysis of the feasibility of the idea</a:t>
+              <a:t>Technical feasibility and validation methodology</a:t>
             </a:r>
           </a:p>
         </p:txBody>
@@ -9650,7 +9650,7 @@
         <p:spPr>
           <a:xfrm>
             <a:off x="548640" y="1828800"/>
-            <a:ext cx="3520440" cy="923544"/>
+            <a:ext cx="3520440" cy="1005840"/>
           </a:xfrm>
           <a:prstGeom prst="rect">
             <a:avLst/>
@@ -9693,7 +9693,7 @@
         <p:spPr>
           <a:xfrm>
             <a:off x="704088" y="1965960"/>
-            <a:ext cx="804672" cy="530352"/>
+            <a:ext cx="3209544" cy="292608"/>
           </a:xfrm>
           <a:prstGeom prst="rect">
             <a:avLst/>
@@ -9708,23 +9708,23 @@
           <a:p>
             <a:pPr>
               <a:lnSpc>
-                <a:spcPts val="3660"/>
-              </a:lnSpc>
-              <a:spcBef>
-                <a:spcPts val="0"/>
-              </a:spcBef>
-              <a:spcAft>
-                <a:spcPts val="0"/>
-              </a:spcAft>
-            </a:pPr>
-            <a:r>
-              <a:rPr sz="3000" b="1">
+                <a:spcPts val="2074"/>
+              </a:lnSpc>
+              <a:spcBef>
+                <a:spcPts val="0"/>
+              </a:spcBef>
+              <a:spcAft>
+                <a:spcPts val="0"/>
+              </a:spcAft>
+            </a:pPr>
+            <a:r>
+              <a:rPr sz="1700" b="1">
                 <a:solidFill>
                   <a:srgbClr val="0070C0"/>
                 </a:solidFill>
                 <a:latin typeface="Liberation Sans"/>
               </a:rPr>
-              <a:t>123</a:t>
+              <a:t>Functional verification</a:t>
             </a:r>
           </a:p>
         </p:txBody>
@@ -9737,8 +9737,8 @@
         </p:nvSpPr>
         <p:spPr>
           <a:xfrm>
-            <a:off x="1581912" y="2139696"/>
-            <a:ext cx="2350008" cy="292608"/>
+            <a:off x="704088" y="2359152"/>
+            <a:ext cx="3209544" cy="448056"/>
           </a:xfrm>
           <a:prstGeom prst="rect">
             <a:avLst/>
@@ -9753,23 +9753,45 @@
           <a:p>
             <a:pPr>
               <a:lnSpc>
-                <a:spcPts val="1769"/>
-              </a:lnSpc>
-              <a:spcBef>
-                <a:spcPts val="0"/>
-              </a:spcBef>
-              <a:spcAft>
-                <a:spcPts val="0"/>
-              </a:spcAft>
-            </a:pPr>
-            <a:r>
-              <a:rPr sz="1450" b="0">
+                <a:spcPts val="1707"/>
+              </a:lnSpc>
+              <a:spcBef>
+                <a:spcPts val="0"/>
+              </a:spcBef>
+              <a:spcAft>
+                <a:spcPts val="0"/>
+              </a:spcAft>
+            </a:pPr>
+            <a:r>
+              <a:rPr sz="1400" b="0">
                 <a:solidFill>
                   <a:srgbClr val="17344B"/>
                 </a:solidFill>
                 <a:latin typeface="Liberation Sans"/>
               </a:rPr>
-              <a:t>automated tests passing</a:t>
+              <a:t>Unit and integration testing</a:t>
+            </a:r>
+          </a:p>
+          <a:p>
+            <a:pPr>
+              <a:lnSpc>
+                <a:spcPts val="1707"/>
+              </a:lnSpc>
+              <a:spcBef>
+                <a:spcPts val="0"/>
+              </a:spcBef>
+              <a:spcAft>
+                <a:spcPts val="0"/>
+              </a:spcAft>
+            </a:pPr>
+            <a:r>
+              <a:rPr sz="1400" b="0">
+                <a:solidFill>
+                  <a:srgbClr val="17344B"/>
+                </a:solidFill>
+                <a:latin typeface="Liberation Sans"/>
+              </a:rPr>
+              <a:t>Schema and regression checks</a:t>
             </a:r>
           </a:p>
         </p:txBody>
@@ -9783,7 +9805,7 @@
         <p:spPr>
           <a:xfrm>
             <a:off x="4325112" y="1828800"/>
-            <a:ext cx="3520440" cy="923544"/>
+            <a:ext cx="3520440" cy="1005840"/>
           </a:xfrm>
           <a:prstGeom prst="rect">
             <a:avLst/>
@@ -9826,7 +9848,7 @@
         <p:spPr>
           <a:xfrm>
             <a:off x="4480560" y="1965960"/>
-            <a:ext cx="804672" cy="530352"/>
+            <a:ext cx="3209544" cy="292608"/>
           </a:xfrm>
           <a:prstGeom prst="rect">
             <a:avLst/>
@@ -9841,23 +9863,23 @@
           <a:p>
             <a:pPr>
               <a:lnSpc>
-                <a:spcPts val="3660"/>
-              </a:lnSpc>
-              <a:spcBef>
-                <a:spcPts val="0"/>
-              </a:spcBef>
-              <a:spcAft>
-                <a:spcPts val="0"/>
-              </a:spcAft>
-            </a:pPr>
-            <a:r>
-              <a:rPr sz="3000" b="1">
+                <a:spcPts val="2074"/>
+              </a:lnSpc>
+              <a:spcBef>
+                <a:spcPts val="0"/>
+              </a:spcBef>
+              <a:spcAft>
+                <a:spcPts val="0"/>
+              </a:spcAft>
+            </a:pPr>
+            <a:r>
+              <a:rPr sz="1700" b="1">
                 <a:solidFill>
                   <a:srgbClr val="0070C0"/>
                 </a:solidFill>
                 <a:latin typeface="Liberation Sans"/>
               </a:rPr>
-              <a:t>13</a:t>
+              <a:t>Statistical evaluation</a:t>
             </a:r>
           </a:p>
         </p:txBody>
@@ -9870,8 +9892,8 @@
         </p:nvSpPr>
         <p:spPr>
           <a:xfrm>
-            <a:off x="5358384" y="2139696"/>
-            <a:ext cx="2350008" cy="292608"/>
+            <a:off x="4480560" y="2359152"/>
+            <a:ext cx="3209544" cy="448056"/>
           </a:xfrm>
           <a:prstGeom prst="rect">
             <a:avLst/>
@@ -9886,23 +9908,45 @@
           <a:p>
             <a:pPr>
               <a:lnSpc>
-                <a:spcPts val="1769"/>
-              </a:lnSpc>
-              <a:spcBef>
-                <a:spcPts val="0"/>
-              </a:spcBef>
-              <a:spcAft>
-                <a:spcPts val="0"/>
-              </a:spcAft>
-            </a:pPr>
-            <a:r>
-              <a:rPr sz="1450" b="0">
+                <a:spcPts val="1707"/>
+              </a:lnSpc>
+              <a:spcBef>
+                <a:spcPts val="0"/>
+              </a:spcBef>
+              <a:spcAft>
+                <a:spcPts val="0"/>
+              </a:spcAft>
+            </a:pPr>
+            <a:r>
+              <a:rPr sz="1400" b="0">
                 <a:solidFill>
                   <a:srgbClr val="17344B"/>
                 </a:solidFill>
                 <a:latin typeface="Liberation Sans"/>
               </a:rPr>
-              <a:t>comparison strategies</a:t>
+              <a:t>Seeded Monte Carlo experiments</a:t>
+            </a:r>
+          </a:p>
+          <a:p>
+            <a:pPr>
+              <a:lnSpc>
+                <a:spcPts val="1707"/>
+              </a:lnSpc>
+              <a:spcBef>
+                <a:spcPts val="0"/>
+              </a:spcBef>
+              <a:spcAft>
+                <a:spcPts val="0"/>
+              </a:spcAft>
+            </a:pPr>
+            <a:r>
+              <a:rPr sz="1400" b="0">
+                <a:solidFill>
+                  <a:srgbClr val="17344B"/>
+                </a:solidFill>
+                <a:latin typeface="Liberation Sans"/>
+              </a:rPr>
+              <a:t>Paired baseline comparisons</a:t>
             </a:r>
           </a:p>
         </p:txBody>
@@ -9916,7 +9960,7 @@
         <p:spPr>
           <a:xfrm>
             <a:off x="8101583" y="1828800"/>
-            <a:ext cx="3520440" cy="923544"/>
+            <a:ext cx="3520440" cy="1005840"/>
           </a:xfrm>
           <a:prstGeom prst="rect">
             <a:avLst/>
@@ -9959,7 +10003,7 @@
         <p:spPr>
           <a:xfrm>
             <a:off x="8257031" y="1965960"/>
-            <a:ext cx="804672" cy="530352"/>
+            <a:ext cx="3209544" cy="292608"/>
           </a:xfrm>
           <a:prstGeom prst="rect">
             <a:avLst/>
@@ -9974,23 +10018,23 @@
           <a:p>
             <a:pPr>
               <a:lnSpc>
-                <a:spcPts val="3660"/>
-              </a:lnSpc>
-              <a:spcBef>
-                <a:spcPts val="0"/>
-              </a:spcBef>
-              <a:spcAft>
-                <a:spcPts val="0"/>
-              </a:spcAft>
-            </a:pPr>
-            <a:r>
-              <a:rPr sz="3000" b="1">
+                <a:spcPts val="2074"/>
+              </a:lnSpc>
+              <a:spcBef>
+                <a:spcPts val="0"/>
+              </a:spcBef>
+              <a:spcAft>
+                <a:spcPts val="0"/>
+              </a:spcAft>
+            </a:pPr>
+            <a:r>
+              <a:rPr sz="1700" b="1">
                 <a:solidFill>
                   <a:srgbClr val="0070C0"/>
                 </a:solidFill>
                 <a:latin typeface="Liberation Sans"/>
               </a:rPr>
-              <a:t>5</a:t>
+              <a:t>Planned stress testing</a:t>
             </a:r>
           </a:p>
         </p:txBody>
@@ -10003,8 +10047,8 @@
         </p:nvSpPr>
         <p:spPr>
           <a:xfrm>
-            <a:off x="9134855" y="2139696"/>
-            <a:ext cx="2350008" cy="292608"/>
+            <a:off x="8257031" y="2359152"/>
+            <a:ext cx="3209544" cy="448056"/>
           </a:xfrm>
           <a:prstGeom prst="rect">
             <a:avLst/>
@@ -10019,23 +10063,45 @@
           <a:p>
             <a:pPr>
               <a:lnSpc>
-                <a:spcPts val="1769"/>
-              </a:lnSpc>
-              <a:spcBef>
-                <a:spcPts val="0"/>
-              </a:spcBef>
-              <a:spcAft>
-                <a:spcPts val="0"/>
-              </a:spcAft>
-            </a:pPr>
-            <a:r>
-              <a:rPr sz="1450" b="0">
+                <a:spcPts val="1707"/>
+              </a:lnSpc>
+              <a:spcBef>
+                <a:spcPts val="0"/>
+              </a:spcBef>
+              <a:spcAft>
+                <a:spcPts val="0"/>
+              </a:spcAft>
+            </a:pPr>
+            <a:r>
+              <a:rPr sz="1400" b="0">
                 <a:solidFill>
                   <a:srgbClr val="17344B"/>
                 </a:solidFill>
                 <a:latin typeface="Liberation Sans"/>
               </a:rPr>
-              <a:t>seeded scenario presets</a:t>
+              <a:t>Noise and distribution-shift tests</a:t>
+            </a:r>
+          </a:p>
+          <a:p>
+            <a:pPr>
+              <a:lnSpc>
+                <a:spcPts val="1707"/>
+              </a:lnSpc>
+              <a:spcBef>
+                <a:spcPts val="0"/>
+              </a:spcBef>
+              <a:spcAft>
+                <a:spcPts val="0"/>
+              </a:spcAft>
+            </a:pPr>
+            <a:r>
+              <a:rPr sz="1400" b="0">
+                <a:solidFill>
+                  <a:srgbClr val="17344B"/>
+                </a:solidFill>
+                <a:latin typeface="Liberation Sans"/>
+              </a:rPr>
+              <a:t>Latency and memory profiling</a:t>
             </a:r>
           </a:p>
         </p:txBody>
@@ -10048,8 +10114,8 @@
         </p:nvSpPr>
         <p:spPr>
           <a:xfrm>
-            <a:off x="548640" y="2953512"/>
-            <a:ext cx="11064240" cy="438912"/>
+            <a:off x="548640" y="3044952"/>
+            <a:ext cx="11064240" cy="329184"/>
           </a:xfrm>
           <a:prstGeom prst="rect">
             <a:avLst/>
@@ -10064,23 +10130,23 @@
           <a:p>
             <a:pPr>
               <a:lnSpc>
-                <a:spcPts val="2074"/>
-              </a:lnSpc>
-              <a:spcBef>
-                <a:spcPts val="0"/>
-              </a:spcBef>
-              <a:spcAft>
-                <a:spcPts val="0"/>
-              </a:spcAft>
-            </a:pPr>
-            <a:r>
-              <a:rPr sz="1700" b="0">
+                <a:spcPts val="2013"/>
+              </a:lnSpc>
+              <a:spcBef>
+                <a:spcPts val="0"/>
+              </a:spcBef>
+              <a:spcAft>
+                <a:spcPts val="0"/>
+              </a:spcAft>
+            </a:pPr>
+            <a:r>
+              <a:rPr sz="1650" b="0">
                 <a:solidFill>
                   <a:srgbClr val="17344B"/>
                 </a:solidFill>
                 <a:latin typeface="Liberation Sans"/>
               </a:rPr>
-              <a:t>Working now: simulation, tracking, parallel runs, custom scenarios and JSON/CSV reports.</a:t>
+              <a:t>Engineering foundation: modular receiver simulation, deterministic replay and parallel evaluation.</a:t>
             </a:r>
           </a:p>
         </p:txBody>
@@ -10301,7 +10367,7 @@
                 </a:solidFill>
                 <a:latin typeface="Liberation Sans"/>
               </a:rPr>
-              <a:t>Large pulse files exceed available memory</a:t>
+              <a:t>Dataset scale and memory pressure</a:t>
             </a:r>
           </a:p>
         </p:txBody>
@@ -10346,7 +10412,7 @@
                 </a:solidFill>
                 <a:latin typeface="Liberation Sans"/>
               </a:rPr>
-              <a:t>Read bounded HDF5 batches; profile before native code.</a:t>
+              <a:t>Chunked HDF5 ingestion; profiling-led native acceleration.</a:t>
             </a:r>
           </a:p>
         </p:txBody>
@@ -10434,7 +10500,7 @@
                 </a:solidFill>
                 <a:latin typeface="Liberation Sans"/>
               </a:rPr>
-              <a:t>Similar signatures cause false joins or splits</a:t>
+              <a:t>Ambiguous pulse signatures and fragmentation</a:t>
             </a:r>
           </a:p>
         </p:txBody>
@@ -10479,7 +10545,7 @@
                 </a:solidFill>
                 <a:latin typeface="Liberation Sans"/>
               </a:rPr>
-              <a:t>Measure pairwise F1 and V-measure; test noisy overlaps.</a:t>
+              <a:t>Multi-feature association; pairwise F1 and V-measure analysis.</a:t>
             </a:r>
           </a:p>
         </p:txBody>
@@ -10567,7 +10633,7 @@
                 </a:solidFill>
                 <a:latin typeface="Liberation Sans"/>
               </a:rPr>
-              <a:t>Simulation bias or changing emitter behaviour</a:t>
+              <a:t>Concept drift and simulator overfitting</a:t>
             </a:r>
           </a:p>
         </p:txBody>
@@ -10612,7 +10678,7 @@
                 </a:solidFill>
                 <a:latin typeface="Liberation Sans"/>
               </a:rPr>
-              <a:t>Hold out scenarios; vary noise and modes; keep baselines.</a:t>
+              <a:t>Held-out scenarios, sensitivity analysis and policy ablations.</a:t>
             </a:r>
           </a:p>
         </p:txBody>
@@ -10700,7 +10766,7 @@
                 </a:solidFill>
                 <a:latin typeface="Liberation Sans"/>
               </a:rPr>
-              <a:t>Recorded scans cannot reveal missed alternatives</a:t>
+              <a:t>Observation bias in recorded scan data</a:t>
             </a:r>
           </a:p>
         </p:txBody>
@@ -10745,7 +10811,7 @@
                 </a:solidFill>
                 <a:latin typeface="Liberation Sans"/>
               </a:rPr>
-              <a:t>Evaluate scheduling in simulation; replay data for association.</a:t>
+              <a:t>Separate offline association from closed-loop policy evaluation.</a:t>
             </a:r>
           </a:p>
         </p:txBody>
@@ -10786,11 +10852,11 @@
             <a:r>
               <a:rPr sz="1350" b="1">
                 <a:solidFill>
-                  <a:srgbClr val="B55A16"/>
+                  <a:srgbClr val="0070C0"/>
                 </a:solidFill>
                 <a:latin typeface="Liberation Sans"/>
               </a:rPr>
-              <a:t>Next: dataset evaluation, learned policy, reward/prediction metrics and a periodic-scan reference.</a:t>
+              <a:t>Delivery plan: data pipeline &gt; association benchmark &gt; learned scheduler &gt; optimisation &gt; API / dashboard.</a:t>
             </a:r>
           </a:p>
           <a:p>
@@ -10808,11 +10874,11 @@
             <a:r>
               <a:rPr sz="1350" b="1">
                 <a:solidFill>
-                  <a:srgbClr val="B55A16"/>
+                  <a:srgbClr val="0070C0"/>
                 </a:solidFill>
                 <a:latin typeface="Liberation Sans"/>
               </a:rPr>
-              <a:t>Simulation evidence only; hardware integration and field validation remain outside this prototype.</a:t>
+              <a:t>Validation gate: held-out gains over the strongest baseline, bounded memory and measured decision latency.</a:t>
             </a:r>
           </a:p>
         </p:txBody>
@@ -11309,7 +11375,7 @@
                 </a:solidFill>
                 <a:latin typeface="Liberation Sans"/>
               </a:rPr>
-              <a:t>For electronic-support researchers, receiver developers and student RF labs:</a:t>
+              <a:t>For electronic-support R&amp;D teams, receiver-system developers and RF research laboratories:</a:t>
             </a:r>
           </a:p>
           <a:p>
@@ -11331,7 +11397,7 @@
                 </a:solidFill>
                 <a:latin typeface="Liberation Sans"/>
               </a:rPr>
-              <a:t>a repeatable way to compare scan policies before considering hardware integration.</a:t>
+              <a:t>a software-defined evaluation platform for adaptive spectrum-management strategies.</a:t>
             </a:r>
           </a:p>
         </p:txBody>
@@ -11491,67 +11557,67 @@
           <a:p>
             <a:pPr>
               <a:lnSpc>
-                <a:spcPts val="2074"/>
-              </a:lnSpc>
-              <a:spcBef>
-                <a:spcPts val="0"/>
-              </a:spcBef>
-              <a:spcAft>
-                <a:spcPts val="0"/>
-              </a:spcAft>
-            </a:pPr>
-            <a:r>
-              <a:rPr sz="1700" b="0">
+                <a:spcPts val="1952"/>
+              </a:lnSpc>
+              <a:spcBef>
+                <a:spcPts val="0"/>
+              </a:spcBef>
+              <a:spcAft>
+                <a:spcPts val="0"/>
+              </a:spcAft>
+            </a:pPr>
+            <a:r>
+              <a:rPr sz="1600" b="0">
                 <a:solidFill>
                   <a:srgbClr val="17344B"/>
                 </a:solidFill>
                 <a:latin typeface="Liberation Sans"/>
               </a:rPr>
-              <a:t>Aim for faster signal discovery.</a:t>
-            </a:r>
-          </a:p>
-          <a:p>
-            <a:pPr>
-              <a:lnSpc>
-                <a:spcPts val="2074"/>
-              </a:lnSpc>
-              <a:spcBef>
-                <a:spcPts val="0"/>
-              </a:spcBef>
-              <a:spcAft>
-                <a:spcPts val="0"/>
-              </a:spcAft>
-            </a:pPr>
-            <a:r>
-              <a:rPr sz="1700" b="0">
+              <a:t>Lower time to first interception.</a:t>
+            </a:r>
+          </a:p>
+          <a:p>
+            <a:pPr>
+              <a:lnSpc>
+                <a:spcPts val="1952"/>
+              </a:lnSpc>
+              <a:spcBef>
+                <a:spcPts val="0"/>
+              </a:spcBef>
+              <a:spcAft>
+                <a:spcPts val="0"/>
+              </a:spcAft>
+            </a:pPr>
+            <a:r>
+              <a:rPr sz="1600" b="0">
                 <a:solidFill>
                   <a:srgbClr val="17344B"/>
                 </a:solidFill>
                 <a:latin typeface="Liberation Sans"/>
               </a:rPr>
-              <a:t>Balance revisits with coverage.</a:t>
-            </a:r>
-          </a:p>
-          <a:p>
-            <a:pPr>
-              <a:lnSpc>
-                <a:spcPts val="2074"/>
-              </a:lnSpc>
-              <a:spcBef>
-                <a:spcPts val="0"/>
-              </a:spcBef>
-              <a:spcAft>
-                <a:spcPts val="0"/>
-              </a:spcAft>
-            </a:pPr>
-            <a:r>
-              <a:rPr sz="1700" b="0">
+              <a:t>Improve interception probability.</a:t>
+            </a:r>
+          </a:p>
+          <a:p>
+            <a:pPr>
+              <a:lnSpc>
+                <a:spcPts val="1952"/>
+              </a:lnSpc>
+              <a:spcBef>
+                <a:spcPts val="0"/>
+              </a:spcBef>
+              <a:spcAft>
+                <a:spcPts val="0"/>
+              </a:spcAft>
+            </a:pPr>
+            <a:r>
+              <a:rPr sz="1600" b="0">
                 <a:solidFill>
                   <a:srgbClr val="17344B"/>
                 </a:solidFill>
                 <a:latin typeface="Liberation Sans"/>
               </a:rPr>
-              <a:t>Explain misses and track errors.</a:t>
+              <a:t>Preserve wide-spectrum coverage.</a:t>
             </a:r>
           </a:p>
         </p:txBody>
@@ -11711,67 +11777,67 @@
           <a:p>
             <a:pPr>
               <a:lnSpc>
-                <a:spcPts val="2074"/>
-              </a:lnSpc>
-              <a:spcBef>
-                <a:spcPts val="0"/>
-              </a:spcBef>
-              <a:spcAft>
-                <a:spcPts val="0"/>
-              </a:spcAft>
-            </a:pPr>
-            <a:r>
-              <a:rPr sz="1700" b="0">
+                <a:spcPts val="1952"/>
+              </a:lnSpc>
+              <a:spcBef>
+                <a:spcPts val="0"/>
+              </a:spcBef>
+              <a:spcAft>
+                <a:spcPts val="0"/>
+              </a:spcAft>
+            </a:pPr>
+            <a:r>
+              <a:rPr sz="1600" b="0">
                 <a:solidFill>
                   <a:srgbClr val="17344B"/>
                 </a:solidFill>
                 <a:latin typeface="Liberation Sans"/>
               </a:rPr>
-              <a:t>Start on existing computers.</a:t>
-            </a:r>
-          </a:p>
-          <a:p>
-            <a:pPr>
-              <a:lnSpc>
-                <a:spcPts val="2074"/>
-              </a:lnSpc>
-              <a:spcBef>
-                <a:spcPts val="0"/>
-              </a:spcBef>
-              <a:spcAft>
-                <a:spcPts val="0"/>
-              </a:spcAft>
-            </a:pPr>
-            <a:r>
-              <a:rPr sz="1700" b="0">
+              <a:t>Reduce reliance on RF testbeds.</a:t>
+            </a:r>
+          </a:p>
+          <a:p>
+            <a:pPr>
+              <a:lnSpc>
+                <a:spcPts val="1952"/>
+              </a:lnSpc>
+              <a:spcBef>
+                <a:spcPts val="0"/>
+              </a:spcBef>
+              <a:spcAft>
+                <a:spcPts val="0"/>
+              </a:spcAft>
+            </a:pPr>
+            <a:r>
+              <a:rPr sz="1600" b="0">
                 <a:solidFill>
                   <a:srgbClr val="17344B"/>
                 </a:solidFill>
                 <a:latin typeface="Liberation Sans"/>
               </a:rPr>
-              <a:t>Test software before RF trials.</a:t>
-            </a:r>
-          </a:p>
-          <a:p>
-            <a:pPr>
-              <a:lnSpc>
-                <a:spcPts val="2074"/>
-              </a:lnSpc>
-              <a:spcBef>
-                <a:spcPts val="0"/>
-              </a:spcBef>
-              <a:spcAft>
-                <a:spcPts val="0"/>
-              </a:spcAft>
-            </a:pPr>
-            <a:r>
-              <a:rPr sz="1700" b="0">
+              <a:t>Accelerate policy benchmarking.</a:t>
+            </a:r>
+          </a:p>
+          <a:p>
+            <a:pPr>
+              <a:lnSpc>
+                <a:spcPts val="1952"/>
+              </a:lnSpc>
+              <a:spcBef>
+                <a:spcPts val="0"/>
+              </a:spcBef>
+              <a:spcAft>
+                <a:spcPts val="0"/>
+              </a:spcAft>
+            </a:pPr>
+            <a:r>
+              <a:rPr sz="1600" b="0">
                 <a:solidFill>
                   <a:srgbClr val="17344B"/>
                 </a:solidFill>
                 <a:latin typeface="Liberation Sans"/>
               </a:rPr>
-              <a:t>Reuse scenarios and reports.</a:t>
+              <a:t>Reuse compute and test scenarios.</a:t>
             </a:r>
           </a:p>
         </p:txBody>
@@ -11902,7 +11968,7 @@
                 </a:solidFill>
                 <a:latin typeface="Liberation Sans"/>
               </a:rPr>
-              <a:t>Research and education</a:t>
+              <a:t>Planned capabilities</a:t>
             </a:r>
           </a:p>
         </p:txBody>
@@ -11931,67 +11997,67 @@
           <a:p>
             <a:pPr>
               <a:lnSpc>
-                <a:spcPts val="2074"/>
-              </a:lnSpc>
-              <a:spcBef>
-                <a:spcPts val="0"/>
-              </a:spcBef>
-              <a:spcAft>
-                <a:spcPts val="0"/>
-              </a:spcAft>
-            </a:pPr>
-            <a:r>
-              <a:rPr sz="1700" b="0">
+                <a:spcPts val="1952"/>
+              </a:lnSpc>
+              <a:spcBef>
+                <a:spcPts val="0"/>
+              </a:spcBef>
+              <a:spcAft>
+                <a:spcPts val="0"/>
+              </a:spcAft>
+            </a:pPr>
+            <a:r>
+              <a:rPr sz="1600" b="0">
                 <a:solidFill>
                   <a:srgbClr val="17344B"/>
                 </a:solidFill>
                 <a:latin typeface="Liberation Sans"/>
               </a:rPr>
-              <a:t>Reproducible, inspectable tests.</a:t>
-            </a:r>
-          </a:p>
-          <a:p>
-            <a:pPr>
-              <a:lnSpc>
-                <a:spcPts val="2074"/>
-              </a:lnSpc>
-              <a:spcBef>
-                <a:spcPts val="0"/>
-              </a:spcBef>
-              <a:spcAft>
-                <a:spcPts val="0"/>
-              </a:spcAft>
-            </a:pPr>
-            <a:r>
-              <a:rPr sz="1700" b="0">
+              <a:t>Scalable offline data processing.</a:t>
+            </a:r>
+          </a:p>
+          <a:p>
+            <a:pPr>
+              <a:lnSpc>
+                <a:spcPts val="1952"/>
+              </a:lnSpc>
+              <a:spcBef>
+                <a:spcPts val="0"/>
+              </a:spcBef>
+              <a:spcAft>
+                <a:spcPts val="0"/>
+              </a:spcAft>
+            </a:pPr>
+            <a:r>
+              <a:rPr sz="1600" b="0">
                 <a:solidFill>
                   <a:srgbClr val="17344B"/>
                 </a:solidFill>
                 <a:latin typeface="Liberation Sans"/>
               </a:rPr>
-              <a:t>Public synthetic benchmarks.</a:t>
-            </a:r>
-          </a:p>
-          <a:p>
-            <a:pPr>
-              <a:lnSpc>
-                <a:spcPts val="2074"/>
-              </a:lnSpc>
-              <a:spcBef>
-                <a:spcPts val="0"/>
-              </a:spcBef>
-              <a:spcAft>
-                <a:spcPts val="0"/>
-              </a:spcAft>
-            </a:pPr>
-            <a:r>
-              <a:rPr sz="1700" b="0">
+              <a:t>Modular receiver integration.</a:t>
+            </a:r>
+          </a:p>
+          <a:p>
+            <a:pPr>
+              <a:lnSpc>
+                <a:spcPts val="1952"/>
+              </a:lnSpc>
+              <a:spcBef>
+                <a:spcPts val="0"/>
+              </a:spcBef>
+              <a:spcAft>
+                <a:spcPts val="0"/>
+              </a:spcAft>
+            </a:pPr>
+            <a:r>
+              <a:rPr sz="1600" b="0">
                 <a:solidFill>
                   <a:srgbClr val="17344B"/>
                 </a:solidFill>
                 <a:latin typeface="Liberation Sans"/>
               </a:rPr>
-              <a:t>No live RF transmission needed.</a:t>
+              <a:t>Analyst-facing visual diagnostics.</a:t>
             </a:r>
           </a:p>
         </p:txBody>
@@ -12036,7 +12102,7 @@
                 </a:solidFill>
                 <a:latin typeface="Liberation Sans"/>
               </a:rPr>
-              <a:t>How success will be measured</a:t>
+              <a:t>Performance objectives and acceptance criteria</a:t>
             </a:r>
           </a:p>
         </p:txBody>
@@ -12050,7 +12116,7 @@
         <p:spPr>
           <a:xfrm>
             <a:off x="548640" y="5404104"/>
-            <a:ext cx="11064240" cy="694944"/>
+            <a:ext cx="11064240" cy="813816"/>
           </a:xfrm>
           <a:prstGeom prst="rect">
             <a:avLst/>
@@ -12065,45 +12131,67 @@
           <a:p>
             <a:pPr>
               <a:lnSpc>
-                <a:spcPts val="1952"/>
-              </a:lnSpc>
-              <a:spcBef>
-                <a:spcPts val="0"/>
-              </a:spcBef>
-              <a:spcAft>
-                <a:spcPts val="0"/>
-              </a:spcAft>
-            </a:pPr>
-            <a:r>
-              <a:rPr sz="1600" b="0">
+                <a:spcPts val="1830"/>
+              </a:lnSpc>
+              <a:spcBef>
+                <a:spcPts val="0"/>
+              </a:spcBef>
+              <a:spcAft>
+                <a:spcPts val="0"/>
+              </a:spcAft>
+            </a:pPr>
+            <a:r>
+              <a:rPr sz="1500" b="0">
                 <a:solidFill>
                   <a:srgbClr val="17344B"/>
                 </a:solidFill>
                 <a:latin typeface="Liberation Sans"/>
               </a:rPr>
-              <a:t>Receiver: detection / false-alarm probability and sensitivity. Scheduling: interception rate,</a:t>
-            </a:r>
-          </a:p>
-          <a:p>
-            <a:pPr>
-              <a:lnSpc>
-                <a:spcPts val="1952"/>
-              </a:lnSpc>
-              <a:spcBef>
-                <a:spcPts val="0"/>
-              </a:spcBef>
-              <a:spcAft>
-                <a:spcPts val="0"/>
-              </a:spcAft>
-            </a:pPr>
-            <a:r>
-              <a:rPr sz="1600" b="0">
+              <a:t>Target: improve the interception–latency trade-off against the strongest baseline at equal receiver budgets.</a:t>
+            </a:r>
+          </a:p>
+          <a:p>
+            <a:pPr>
+              <a:lnSpc>
+                <a:spcPts val="1830"/>
+              </a:lnSpc>
+              <a:spcBef>
+                <a:spcPts val="0"/>
+              </a:spcBef>
+              <a:spcAft>
+                <a:spcPts val="0"/>
+              </a:spcAft>
+            </a:pPr>
+            <a:r>
+              <a:rPr sz="1500" b="0">
                 <a:solidFill>
                   <a:srgbClr val="17344B"/>
                 </a:solidFill>
                 <a:latin typeface="Liberation Sans"/>
               </a:rPr>
-              <a:t>reward/cost, prediction accuracy and intercept-time error. Association: V-measure and pairwise F1.</a:t>
+              <a:t>Measure detection / false-alarm probability, sensitivity, interception rate, reward/cost and prediction accuracy.</a:t>
+            </a:r>
+          </a:p>
+          <a:p>
+            <a:pPr>
+              <a:lnSpc>
+                <a:spcPts val="1830"/>
+              </a:lnSpc>
+              <a:spcBef>
+                <a:spcPts val="0"/>
+              </a:spcBef>
+              <a:spcAft>
+                <a:spcPts val="0"/>
+              </a:spcAft>
+            </a:pPr>
+            <a:r>
+              <a:rPr sz="1500" b="0">
+                <a:solidFill>
+                  <a:srgbClr val="17344B"/>
+                </a:solidFill>
+                <a:latin typeface="Liberation Sans"/>
+              </a:rPr>
+              <a:t>Track intercept-time error, coverage gaps, association F1 / V-measure, peak memory and decision latency.</a:t>
             </a:r>
           </a:p>
         </p:txBody>
@@ -13227,7 +13315,7 @@
                 </a:solidFill>
                 <a:latin typeface="Liberation Sans"/>
               </a:rPr>
-              <a:t>Research direction for learned pulse embeddings; not implemented in this prototype.</a:t>
+              <a:t>Research basis for feature embeddings and context-aware pulse association.</a:t>
             </a:r>
           </a:p>
         </p:txBody>
@@ -13588,7 +13676,7 @@
                 </a:solidFill>
                 <a:latin typeface="Liberation Sans"/>
               </a:rPr>
-              <a:t>Literature informs the approach; published benchmark scores are not presented as our results.</a:t>
+              <a:t>Research foundation: reproducible benchmarking, contextual learning and multi-feature pulse association.</a:t>
             </a:r>
           </a:p>
         </p:txBody>

</xml_diff>

<commit_message>
Refine presentation diagrams and evidence hierarchy
</commit_message>
<xml_diff>
--- a/ppt/Spectra-Scheduler-SIH2026.pptx
+++ b/ppt/Spectra-Scheduler-SIH2026.pptx
@@ -4970,7 +4970,265 @@
       </p:sp>
       <p:sp>
         <p:nvSpPr>
-          <p:cNvPr id="8" name="TextBox 7"/>
+          <p:cNvPr id="8" name="Rectangle 7"/>
+          <p:cNvSpPr/>
+          <p:nvPr/>
+        </p:nvSpPr>
+        <p:spPr>
+          <a:xfrm>
+            <a:off x="9372600" y="6604000"/>
+            <a:ext cx="139700" cy="25400"/>
+          </a:xfrm>
+          <a:prstGeom prst="rect">
+            <a:avLst/>
+          </a:prstGeom>
+          <a:solidFill>
+            <a:srgbClr val="245CDE"/>
+          </a:solidFill>
+          <a:ln>
+            <a:noFill/>
+          </a:ln>
+        </p:spPr>
+        <p:style>
+          <a:lnRef idx="1">
+            <a:schemeClr val="accent1"/>
+          </a:lnRef>
+          <a:fillRef idx="3">
+            <a:schemeClr val="accent1"/>
+          </a:fillRef>
+          <a:effectRef idx="2">
+            <a:schemeClr val="accent1"/>
+          </a:effectRef>
+          <a:fontRef idx="minor">
+            <a:schemeClr val="lt1"/>
+          </a:fontRef>
+        </p:style>
+        <p:txBody>
+          <a:bodyPr rtlCol="0" anchor="ctr"/>
+          <a:lstStyle/>
+          <a:p>
+            <a:pPr algn="ctr"/>
+          </a:p>
+        </p:txBody>
+      </p:sp>
+      <p:sp>
+        <p:nvSpPr>
+          <p:cNvPr id="9" name="Rectangle 8"/>
+          <p:cNvSpPr/>
+          <p:nvPr/>
+        </p:nvSpPr>
+        <p:spPr>
+          <a:xfrm>
+            <a:off x="9588500" y="6604000"/>
+            <a:ext cx="139700" cy="25400"/>
+          </a:xfrm>
+          <a:prstGeom prst="rect">
+            <a:avLst/>
+          </a:prstGeom>
+          <a:solidFill>
+            <a:srgbClr val="D9E2ED"/>
+          </a:solidFill>
+          <a:ln>
+            <a:noFill/>
+          </a:ln>
+        </p:spPr>
+        <p:style>
+          <a:lnRef idx="1">
+            <a:schemeClr val="accent1"/>
+          </a:lnRef>
+          <a:fillRef idx="3">
+            <a:schemeClr val="accent1"/>
+          </a:fillRef>
+          <a:effectRef idx="2">
+            <a:schemeClr val="accent1"/>
+          </a:effectRef>
+          <a:fontRef idx="minor">
+            <a:schemeClr val="lt1"/>
+          </a:fontRef>
+        </p:style>
+        <p:txBody>
+          <a:bodyPr rtlCol="0" anchor="ctr"/>
+          <a:lstStyle/>
+          <a:p>
+            <a:pPr algn="ctr"/>
+          </a:p>
+        </p:txBody>
+      </p:sp>
+      <p:sp>
+        <p:nvSpPr>
+          <p:cNvPr id="10" name="Rectangle 9"/>
+          <p:cNvSpPr/>
+          <p:nvPr/>
+        </p:nvSpPr>
+        <p:spPr>
+          <a:xfrm>
+            <a:off x="9804400" y="6604000"/>
+            <a:ext cx="139700" cy="25400"/>
+          </a:xfrm>
+          <a:prstGeom prst="rect">
+            <a:avLst/>
+          </a:prstGeom>
+          <a:solidFill>
+            <a:srgbClr val="D9E2ED"/>
+          </a:solidFill>
+          <a:ln>
+            <a:noFill/>
+          </a:ln>
+        </p:spPr>
+        <p:style>
+          <a:lnRef idx="1">
+            <a:schemeClr val="accent1"/>
+          </a:lnRef>
+          <a:fillRef idx="3">
+            <a:schemeClr val="accent1"/>
+          </a:fillRef>
+          <a:effectRef idx="2">
+            <a:schemeClr val="accent1"/>
+          </a:effectRef>
+          <a:fontRef idx="minor">
+            <a:schemeClr val="lt1"/>
+          </a:fontRef>
+        </p:style>
+        <p:txBody>
+          <a:bodyPr rtlCol="0" anchor="ctr"/>
+          <a:lstStyle/>
+          <a:p>
+            <a:pPr algn="ctr"/>
+          </a:p>
+        </p:txBody>
+      </p:sp>
+      <p:sp>
+        <p:nvSpPr>
+          <p:cNvPr id="11" name="Rectangle 10"/>
+          <p:cNvSpPr/>
+          <p:nvPr/>
+        </p:nvSpPr>
+        <p:spPr>
+          <a:xfrm>
+            <a:off x="10020300" y="6604000"/>
+            <a:ext cx="139700" cy="25400"/>
+          </a:xfrm>
+          <a:prstGeom prst="rect">
+            <a:avLst/>
+          </a:prstGeom>
+          <a:solidFill>
+            <a:srgbClr val="D9E2ED"/>
+          </a:solidFill>
+          <a:ln>
+            <a:noFill/>
+          </a:ln>
+        </p:spPr>
+        <p:style>
+          <a:lnRef idx="1">
+            <a:schemeClr val="accent1"/>
+          </a:lnRef>
+          <a:fillRef idx="3">
+            <a:schemeClr val="accent1"/>
+          </a:fillRef>
+          <a:effectRef idx="2">
+            <a:schemeClr val="accent1"/>
+          </a:effectRef>
+          <a:fontRef idx="minor">
+            <a:schemeClr val="lt1"/>
+          </a:fontRef>
+        </p:style>
+        <p:txBody>
+          <a:bodyPr rtlCol="0" anchor="ctr"/>
+          <a:lstStyle/>
+          <a:p>
+            <a:pPr algn="ctr"/>
+          </a:p>
+        </p:txBody>
+      </p:sp>
+      <p:sp>
+        <p:nvSpPr>
+          <p:cNvPr id="12" name="Rectangle 11"/>
+          <p:cNvSpPr/>
+          <p:nvPr/>
+        </p:nvSpPr>
+        <p:spPr>
+          <a:xfrm>
+            <a:off x="10236200" y="6604000"/>
+            <a:ext cx="139700" cy="25400"/>
+          </a:xfrm>
+          <a:prstGeom prst="rect">
+            <a:avLst/>
+          </a:prstGeom>
+          <a:solidFill>
+            <a:srgbClr val="D9E2ED"/>
+          </a:solidFill>
+          <a:ln>
+            <a:noFill/>
+          </a:ln>
+        </p:spPr>
+        <p:style>
+          <a:lnRef idx="1">
+            <a:schemeClr val="accent1"/>
+          </a:lnRef>
+          <a:fillRef idx="3">
+            <a:schemeClr val="accent1"/>
+          </a:fillRef>
+          <a:effectRef idx="2">
+            <a:schemeClr val="accent1"/>
+          </a:effectRef>
+          <a:fontRef idx="minor">
+            <a:schemeClr val="lt1"/>
+          </a:fontRef>
+        </p:style>
+        <p:txBody>
+          <a:bodyPr rtlCol="0" anchor="ctr"/>
+          <a:lstStyle/>
+          <a:p>
+            <a:pPr algn="ctr"/>
+          </a:p>
+        </p:txBody>
+      </p:sp>
+      <p:sp>
+        <p:nvSpPr>
+          <p:cNvPr id="13" name="Rectangle 12"/>
+          <p:cNvSpPr/>
+          <p:nvPr/>
+        </p:nvSpPr>
+        <p:spPr>
+          <a:xfrm>
+            <a:off x="10452100" y="6604000"/>
+            <a:ext cx="139700" cy="25400"/>
+          </a:xfrm>
+          <a:prstGeom prst="rect">
+            <a:avLst/>
+          </a:prstGeom>
+          <a:solidFill>
+            <a:srgbClr val="D9E2ED"/>
+          </a:solidFill>
+          <a:ln>
+            <a:noFill/>
+          </a:ln>
+        </p:spPr>
+        <p:style>
+          <a:lnRef idx="1">
+            <a:schemeClr val="accent1"/>
+          </a:lnRef>
+          <a:fillRef idx="3">
+            <a:schemeClr val="accent1"/>
+          </a:fillRef>
+          <a:effectRef idx="2">
+            <a:schemeClr val="accent1"/>
+          </a:effectRef>
+          <a:fontRef idx="minor">
+            <a:schemeClr val="lt1"/>
+          </a:fontRef>
+        </p:style>
+        <p:txBody>
+          <a:bodyPr rtlCol="0" anchor="ctr"/>
+          <a:lstStyle/>
+          <a:p>
+            <a:pPr algn="ctr"/>
+          </a:p>
+        </p:txBody>
+      </p:sp>
+      <p:sp>
+        <p:nvSpPr>
+          <p:cNvPr id="14" name="TextBox 13"/>
           <p:cNvSpPr txBox="1"/>
           <p:nvPr/>
         </p:nvSpPr>
@@ -5037,7 +5295,7 @@
       </p:sp>
       <p:sp>
         <p:nvSpPr>
-          <p:cNvPr id="9" name="TextBox 8"/>
+          <p:cNvPr id="15" name="TextBox 14"/>
           <p:cNvSpPr txBox="1"/>
           <p:nvPr/>
         </p:nvSpPr>
@@ -5104,7 +5362,7 @@
       </p:sp>
       <p:sp>
         <p:nvSpPr>
-          <p:cNvPr id="10" name="TextBox 9"/>
+          <p:cNvPr id="16" name="TextBox 15"/>
           <p:cNvSpPr txBox="1"/>
           <p:nvPr/>
         </p:nvSpPr>
@@ -5149,7 +5407,7 @@
       </p:sp>
       <p:sp>
         <p:nvSpPr>
-          <p:cNvPr id="11" name="TextBox 10"/>
+          <p:cNvPr id="17" name="TextBox 16"/>
           <p:cNvSpPr txBox="1"/>
           <p:nvPr/>
         </p:nvSpPr>
@@ -5194,7 +5452,7 @@
       </p:sp>
       <p:sp>
         <p:nvSpPr>
-          <p:cNvPr id="12" name="TextBox 11"/>
+          <p:cNvPr id="18" name="TextBox 17"/>
           <p:cNvSpPr txBox="1"/>
           <p:nvPr/>
         </p:nvSpPr>
@@ -5239,7 +5497,7 @@
       </p:sp>
       <p:sp>
         <p:nvSpPr>
-          <p:cNvPr id="13" name="TextBox 12"/>
+          <p:cNvPr id="19" name="TextBox 18"/>
           <p:cNvSpPr txBox="1"/>
           <p:nvPr/>
         </p:nvSpPr>
@@ -5284,7 +5542,7 @@
       </p:sp>
       <p:sp>
         <p:nvSpPr>
-          <p:cNvPr id="14" name="TextBox 13"/>
+          <p:cNvPr id="20" name="TextBox 19"/>
           <p:cNvSpPr txBox="1"/>
           <p:nvPr/>
         </p:nvSpPr>
@@ -5329,7 +5587,52 @@
       </p:sp>
       <p:sp>
         <p:nvSpPr>
-          <p:cNvPr id="15" name="Rectangle 14"/>
+          <p:cNvPr id="21" name="TextBox 20"/>
+          <p:cNvSpPr txBox="1"/>
+          <p:nvPr/>
+        </p:nvSpPr>
+        <p:spPr>
+          <a:xfrm>
+            <a:off x="7188200" y="1028700"/>
+            <a:ext cx="4381500" cy="212090"/>
+          </a:xfrm>
+          <a:prstGeom prst="rect">
+            <a:avLst/>
+          </a:prstGeom>
+          <a:noFill/>
+        </p:spPr>
+        <p:txBody>
+          <a:bodyPr wrap="none" lIns="0" rIns="0" tIns="0" bIns="0">
+            <a:spAutoFit/>
+          </a:bodyPr>
+          <a:lstStyle/>
+          <a:p>
+            <a:pPr>
+              <a:lnSpc>
+                <a:spcPts val="1170"/>
+              </a:lnSpc>
+              <a:spcBef>
+                <a:spcPts val="0"/>
+              </a:spcBef>
+              <a:spcAft>
+                <a:spcPts val="0"/>
+              </a:spcAft>
+            </a:pPr>
+            <a:r>
+              <a:rPr sz="900" b="1">
+                <a:solidFill>
+                  <a:srgbClr val="245CDE"/>
+                </a:solidFill>
+                <a:latin typeface="Noto Sans"/>
+              </a:rPr>
+              <a:t>THE BANDWIDTH BOTTLENECK</a:t>
+            </a:r>
+          </a:p>
+        </p:txBody>
+      </p:sp>
+      <p:sp>
+        <p:nvSpPr>
+          <p:cNvPr id="22" name="Rectangle 21"/>
           <p:cNvSpPr/>
           <p:nvPr/>
         </p:nvSpPr>
@@ -5372,7 +5675,7 @@
       </p:sp>
       <p:sp>
         <p:nvSpPr>
-          <p:cNvPr id="16" name="Rectangle 15"/>
+          <p:cNvPr id="23" name="Rectangle 22"/>
           <p:cNvSpPr/>
           <p:nvPr/>
         </p:nvSpPr>
@@ -5415,7 +5718,7 @@
       </p:sp>
       <p:sp>
         <p:nvSpPr>
-          <p:cNvPr id="17" name="Rectangle 16"/>
+          <p:cNvPr id="24" name="Rectangle 23"/>
           <p:cNvSpPr/>
           <p:nvPr/>
         </p:nvSpPr>
@@ -5458,7 +5761,7 @@
       </p:sp>
       <p:sp>
         <p:nvSpPr>
-          <p:cNvPr id="18" name="Rectangle 17"/>
+          <p:cNvPr id="25" name="Rectangle 24"/>
           <p:cNvSpPr/>
           <p:nvPr/>
         </p:nvSpPr>
@@ -5501,7 +5804,7 @@
       </p:sp>
       <p:sp>
         <p:nvSpPr>
-          <p:cNvPr id="19" name="Rectangle 18"/>
+          <p:cNvPr id="26" name="Rectangle 25"/>
           <p:cNvSpPr/>
           <p:nvPr/>
         </p:nvSpPr>
@@ -5544,7 +5847,7 @@
       </p:sp>
       <p:sp>
         <p:nvSpPr>
-          <p:cNvPr id="20" name="Rectangle 19"/>
+          <p:cNvPr id="27" name="Rectangle 26"/>
           <p:cNvSpPr/>
           <p:nvPr/>
         </p:nvSpPr>
@@ -5587,7 +5890,7 @@
       </p:sp>
       <p:sp>
         <p:nvSpPr>
-          <p:cNvPr id="21" name="Rectangle 20"/>
+          <p:cNvPr id="28" name="Rectangle 27"/>
           <p:cNvSpPr/>
           <p:nvPr/>
         </p:nvSpPr>
@@ -5630,7 +5933,7 @@
       </p:sp>
       <p:sp>
         <p:nvSpPr>
-          <p:cNvPr id="22" name="Rectangle 21"/>
+          <p:cNvPr id="29" name="Rectangle 28"/>
           <p:cNvSpPr/>
           <p:nvPr/>
         </p:nvSpPr>
@@ -5673,7 +5976,7 @@
       </p:sp>
       <p:sp>
         <p:nvSpPr>
-          <p:cNvPr id="23" name="Rectangle 22"/>
+          <p:cNvPr id="30" name="Rectangle 29"/>
           <p:cNvSpPr/>
           <p:nvPr/>
         </p:nvSpPr>
@@ -5716,7 +6019,7 @@
       </p:sp>
       <p:sp>
         <p:nvSpPr>
-          <p:cNvPr id="24" name="Rectangle 23"/>
+          <p:cNvPr id="31" name="Rectangle 30"/>
           <p:cNvSpPr/>
           <p:nvPr/>
         </p:nvSpPr>
@@ -5759,7 +6062,7 @@
       </p:sp>
       <p:sp>
         <p:nvSpPr>
-          <p:cNvPr id="25" name="Rectangle 24"/>
+          <p:cNvPr id="32" name="Rectangle 31"/>
           <p:cNvSpPr/>
           <p:nvPr/>
         </p:nvSpPr>
@@ -5802,7 +6105,7 @@
       </p:sp>
       <p:sp>
         <p:nvSpPr>
-          <p:cNvPr id="26" name="Rectangle 25"/>
+          <p:cNvPr id="33" name="Rectangle 32"/>
           <p:cNvSpPr/>
           <p:nvPr/>
         </p:nvSpPr>
@@ -5845,7 +6148,7 @@
       </p:sp>
       <p:sp>
         <p:nvSpPr>
-          <p:cNvPr id="27" name="Rectangle 26"/>
+          <p:cNvPr id="34" name="Rectangle 33"/>
           <p:cNvSpPr/>
           <p:nvPr/>
         </p:nvSpPr>
@@ -5888,7 +6191,7 @@
       </p:sp>
       <p:sp>
         <p:nvSpPr>
-          <p:cNvPr id="28" name="Rectangle 27"/>
+          <p:cNvPr id="35" name="Rectangle 34"/>
           <p:cNvSpPr/>
           <p:nvPr/>
         </p:nvSpPr>
@@ -5931,7 +6234,7 @@
       </p:sp>
       <p:sp>
         <p:nvSpPr>
-          <p:cNvPr id="29" name="Rectangle 28"/>
+          <p:cNvPr id="36" name="Rectangle 35"/>
           <p:cNvSpPr/>
           <p:nvPr/>
         </p:nvSpPr>
@@ -5974,7 +6277,7 @@
       </p:sp>
       <p:cxnSp>
         <p:nvCxnSpPr>
-          <p:cNvPr id="30" name="Connector 29"/>
+          <p:cNvPr id="37" name="Connector 36"/>
           <p:cNvCxnSpPr/>
           <p:nvPr/>
         </p:nvCxnSpPr>
@@ -6009,7 +6312,7 @@
       </p:cxnSp>
       <p:cxnSp>
         <p:nvCxnSpPr>
-          <p:cNvPr id="31" name="Connector 30"/>
+          <p:cNvPr id="38" name="Connector 37"/>
           <p:cNvCxnSpPr/>
           <p:nvPr/>
         </p:nvCxnSpPr>
@@ -6044,7 +6347,7 @@
       </p:cxnSp>
       <p:cxnSp>
         <p:nvCxnSpPr>
-          <p:cNvPr id="32" name="Connector 31"/>
+          <p:cNvPr id="39" name="Connector 38"/>
           <p:cNvCxnSpPr/>
           <p:nvPr/>
         </p:nvCxnSpPr>
@@ -6077,9 +6380,159 @@
           </a:fontRef>
         </p:style>
       </p:cxnSp>
-      <p:sp>
-        <p:nvSpPr>
-          <p:cNvPr id="33" name="TextBox 32"/>
+      <p:cxnSp>
+        <p:nvCxnSpPr>
+          <p:cNvPr id="40" name="Connector 39"/>
+          <p:cNvCxnSpPr/>
+          <p:nvPr/>
+        </p:nvCxnSpPr>
+        <p:spPr>
+          <a:xfrm>
+            <a:off x="7988300" y="1638300"/>
+            <a:ext cx="965200" cy="0"/>
+          </a:xfrm>
+          <a:prstGeom prst="line">
+            <a:avLst/>
+          </a:prstGeom>
+          <a:ln w="12700">
+            <a:solidFill>
+              <a:srgbClr val="245CDE"/>
+            </a:solidFill>
+          </a:ln>
+        </p:spPr>
+        <p:style>
+          <a:lnRef idx="2">
+            <a:schemeClr val="accent1"/>
+          </a:lnRef>
+          <a:fillRef idx="0">
+            <a:schemeClr val="accent1"/>
+          </a:fillRef>
+          <a:effectRef idx="1">
+            <a:schemeClr val="accent1"/>
+          </a:effectRef>
+          <a:fontRef idx="minor">
+            <a:schemeClr val="tx1"/>
+          </a:fontRef>
+        </p:style>
+      </p:cxnSp>
+      <p:cxnSp>
+        <p:nvCxnSpPr>
+          <p:cNvPr id="41" name="Connector 40"/>
+          <p:cNvCxnSpPr/>
+          <p:nvPr/>
+        </p:nvCxnSpPr>
+        <p:spPr>
+          <a:xfrm>
+            <a:off x="7988300" y="1600200"/>
+            <a:ext cx="0" cy="88900"/>
+          </a:xfrm>
+          <a:prstGeom prst="line">
+            <a:avLst/>
+          </a:prstGeom>
+          <a:ln w="12700">
+            <a:solidFill>
+              <a:srgbClr val="245CDE"/>
+            </a:solidFill>
+          </a:ln>
+        </p:spPr>
+        <p:style>
+          <a:lnRef idx="2">
+            <a:schemeClr val="accent1"/>
+          </a:lnRef>
+          <a:fillRef idx="0">
+            <a:schemeClr val="accent1"/>
+          </a:fillRef>
+          <a:effectRef idx="1">
+            <a:schemeClr val="accent1"/>
+          </a:effectRef>
+          <a:fontRef idx="minor">
+            <a:schemeClr val="tx1"/>
+          </a:fontRef>
+        </p:style>
+      </p:cxnSp>
+      <p:cxnSp>
+        <p:nvCxnSpPr>
+          <p:cNvPr id="42" name="Connector 41"/>
+          <p:cNvCxnSpPr/>
+          <p:nvPr/>
+        </p:nvCxnSpPr>
+        <p:spPr>
+          <a:xfrm>
+            <a:off x="8953500" y="1600200"/>
+            <a:ext cx="0" cy="88900"/>
+          </a:xfrm>
+          <a:prstGeom prst="line">
+            <a:avLst/>
+          </a:prstGeom>
+          <a:ln w="12700">
+            <a:solidFill>
+              <a:srgbClr val="245CDE"/>
+            </a:solidFill>
+          </a:ln>
+        </p:spPr>
+        <p:style>
+          <a:lnRef idx="2">
+            <a:schemeClr val="accent1"/>
+          </a:lnRef>
+          <a:fillRef idx="0">
+            <a:schemeClr val="accent1"/>
+          </a:fillRef>
+          <a:effectRef idx="1">
+            <a:schemeClr val="accent1"/>
+          </a:effectRef>
+          <a:fontRef idx="minor">
+            <a:schemeClr val="tx1"/>
+          </a:fontRef>
+        </p:style>
+      </p:cxnSp>
+      <p:sp>
+        <p:nvSpPr>
+          <p:cNvPr id="43" name="TextBox 42"/>
+          <p:cNvSpPr txBox="1"/>
+          <p:nvPr/>
+        </p:nvSpPr>
+        <p:spPr>
+          <a:xfrm>
+            <a:off x="9144000" y="1574800"/>
+            <a:ext cx="2286000" cy="212090"/>
+          </a:xfrm>
+          <a:prstGeom prst="rect">
+            <a:avLst/>
+          </a:prstGeom>
+          <a:noFill/>
+        </p:spPr>
+        <p:txBody>
+          <a:bodyPr wrap="none" lIns="0" rIns="0" tIns="0" bIns="0">
+            <a:spAutoFit/>
+          </a:bodyPr>
+          <a:lstStyle/>
+          <a:p>
+            <a:pPr>
+              <a:lnSpc>
+                <a:spcPts val="1170"/>
+              </a:lnSpc>
+              <a:spcBef>
+                <a:spcPts val="0"/>
+              </a:spcBef>
+              <a:spcAft>
+                <a:spcPts val="0"/>
+              </a:spcAft>
+            </a:pPr>
+            <a:r>
+              <a:rPr sz="900" b="0">
+                <a:solidFill>
+                  <a:srgbClr val="245CDE"/>
+                </a:solidFill>
+                <a:latin typeface="Noto Sans"/>
+              </a:rPr>
+              <a:t>Instantaneous bandwidth</a:t>
+            </a:r>
+          </a:p>
+        </p:txBody>
+      </p:sp>
+      <p:sp>
+        <p:nvSpPr>
+          <p:cNvPr id="44" name="TextBox 43"/>
           <p:cNvSpPr txBox="1"/>
           <p:nvPr/>
         </p:nvSpPr>
@@ -6124,7 +6577,7 @@
       </p:sp>
       <p:cxnSp>
         <p:nvCxnSpPr>
-          <p:cNvPr id="34" name="Connector 33"/>
+          <p:cNvPr id="45" name="Connector 44"/>
           <p:cNvCxnSpPr/>
           <p:nvPr/>
         </p:nvCxnSpPr>
@@ -6160,7 +6613,7 @@
       </p:cxnSp>
       <p:sp>
         <p:nvSpPr>
-          <p:cNvPr id="35" name="Rounded Rectangle 34"/>
+          <p:cNvPr id="46" name="Rounded Rectangle 45"/>
           <p:cNvSpPr/>
           <p:nvPr/>
         </p:nvSpPr>
@@ -6207,7 +6660,7 @@
       </p:sp>
       <p:sp>
         <p:nvSpPr>
-          <p:cNvPr id="36" name="Rectangle 35"/>
+          <p:cNvPr id="47" name="Rectangle 46"/>
           <p:cNvSpPr/>
           <p:nvPr/>
         </p:nvSpPr>
@@ -6250,7 +6703,7 @@
       </p:sp>
       <p:sp>
         <p:nvSpPr>
-          <p:cNvPr id="37" name="TextBox 36"/>
+          <p:cNvPr id="48" name="TextBox 47"/>
           <p:cNvSpPr txBox="1"/>
           <p:nvPr/>
         </p:nvSpPr>
@@ -6295,7 +6748,7 @@
       </p:sp>
       <p:sp>
         <p:nvSpPr>
-          <p:cNvPr id="38" name="TextBox 37"/>
+          <p:cNvPr id="49" name="TextBox 48"/>
           <p:cNvSpPr txBox="1"/>
           <p:nvPr/>
         </p:nvSpPr>
@@ -6340,7 +6793,7 @@
       </p:sp>
       <p:sp>
         <p:nvSpPr>
-          <p:cNvPr id="39" name="TextBox 38"/>
+          <p:cNvPr id="50" name="TextBox 49"/>
           <p:cNvSpPr txBox="1"/>
           <p:nvPr/>
         </p:nvSpPr>
@@ -6780,7 +7233,265 @@
       </p:sp>
       <p:sp>
         <p:nvSpPr>
-          <p:cNvPr id="10" name="Rounded Rectangle 9"/>
+          <p:cNvPr id="10" name="Rectangle 9"/>
+          <p:cNvSpPr/>
+          <p:nvPr/>
+        </p:nvSpPr>
+        <p:spPr>
+          <a:xfrm>
+            <a:off x="9372600" y="6604000"/>
+            <a:ext cx="139700" cy="25400"/>
+          </a:xfrm>
+          <a:prstGeom prst="rect">
+            <a:avLst/>
+          </a:prstGeom>
+          <a:solidFill>
+            <a:srgbClr val="D9E2ED"/>
+          </a:solidFill>
+          <a:ln>
+            <a:noFill/>
+          </a:ln>
+        </p:spPr>
+        <p:style>
+          <a:lnRef idx="1">
+            <a:schemeClr val="accent1"/>
+          </a:lnRef>
+          <a:fillRef idx="3">
+            <a:schemeClr val="accent1"/>
+          </a:fillRef>
+          <a:effectRef idx="2">
+            <a:schemeClr val="accent1"/>
+          </a:effectRef>
+          <a:fontRef idx="minor">
+            <a:schemeClr val="lt1"/>
+          </a:fontRef>
+        </p:style>
+        <p:txBody>
+          <a:bodyPr rtlCol="0" anchor="ctr"/>
+          <a:lstStyle/>
+          <a:p>
+            <a:pPr algn="ctr"/>
+          </a:p>
+        </p:txBody>
+      </p:sp>
+      <p:sp>
+        <p:nvSpPr>
+          <p:cNvPr id="11" name="Rectangle 10"/>
+          <p:cNvSpPr/>
+          <p:nvPr/>
+        </p:nvSpPr>
+        <p:spPr>
+          <a:xfrm>
+            <a:off x="9588500" y="6604000"/>
+            <a:ext cx="139700" cy="25400"/>
+          </a:xfrm>
+          <a:prstGeom prst="rect">
+            <a:avLst/>
+          </a:prstGeom>
+          <a:solidFill>
+            <a:srgbClr val="245CDE"/>
+          </a:solidFill>
+          <a:ln>
+            <a:noFill/>
+          </a:ln>
+        </p:spPr>
+        <p:style>
+          <a:lnRef idx="1">
+            <a:schemeClr val="accent1"/>
+          </a:lnRef>
+          <a:fillRef idx="3">
+            <a:schemeClr val="accent1"/>
+          </a:fillRef>
+          <a:effectRef idx="2">
+            <a:schemeClr val="accent1"/>
+          </a:effectRef>
+          <a:fontRef idx="minor">
+            <a:schemeClr val="lt1"/>
+          </a:fontRef>
+        </p:style>
+        <p:txBody>
+          <a:bodyPr rtlCol="0" anchor="ctr"/>
+          <a:lstStyle/>
+          <a:p>
+            <a:pPr algn="ctr"/>
+          </a:p>
+        </p:txBody>
+      </p:sp>
+      <p:sp>
+        <p:nvSpPr>
+          <p:cNvPr id="12" name="Rectangle 11"/>
+          <p:cNvSpPr/>
+          <p:nvPr/>
+        </p:nvSpPr>
+        <p:spPr>
+          <a:xfrm>
+            <a:off x="9804400" y="6604000"/>
+            <a:ext cx="139700" cy="25400"/>
+          </a:xfrm>
+          <a:prstGeom prst="rect">
+            <a:avLst/>
+          </a:prstGeom>
+          <a:solidFill>
+            <a:srgbClr val="D9E2ED"/>
+          </a:solidFill>
+          <a:ln>
+            <a:noFill/>
+          </a:ln>
+        </p:spPr>
+        <p:style>
+          <a:lnRef idx="1">
+            <a:schemeClr val="accent1"/>
+          </a:lnRef>
+          <a:fillRef idx="3">
+            <a:schemeClr val="accent1"/>
+          </a:fillRef>
+          <a:effectRef idx="2">
+            <a:schemeClr val="accent1"/>
+          </a:effectRef>
+          <a:fontRef idx="minor">
+            <a:schemeClr val="lt1"/>
+          </a:fontRef>
+        </p:style>
+        <p:txBody>
+          <a:bodyPr rtlCol="0" anchor="ctr"/>
+          <a:lstStyle/>
+          <a:p>
+            <a:pPr algn="ctr"/>
+          </a:p>
+        </p:txBody>
+      </p:sp>
+      <p:sp>
+        <p:nvSpPr>
+          <p:cNvPr id="13" name="Rectangle 12"/>
+          <p:cNvSpPr/>
+          <p:nvPr/>
+        </p:nvSpPr>
+        <p:spPr>
+          <a:xfrm>
+            <a:off x="10020300" y="6604000"/>
+            <a:ext cx="139700" cy="25400"/>
+          </a:xfrm>
+          <a:prstGeom prst="rect">
+            <a:avLst/>
+          </a:prstGeom>
+          <a:solidFill>
+            <a:srgbClr val="D9E2ED"/>
+          </a:solidFill>
+          <a:ln>
+            <a:noFill/>
+          </a:ln>
+        </p:spPr>
+        <p:style>
+          <a:lnRef idx="1">
+            <a:schemeClr val="accent1"/>
+          </a:lnRef>
+          <a:fillRef idx="3">
+            <a:schemeClr val="accent1"/>
+          </a:fillRef>
+          <a:effectRef idx="2">
+            <a:schemeClr val="accent1"/>
+          </a:effectRef>
+          <a:fontRef idx="minor">
+            <a:schemeClr val="lt1"/>
+          </a:fontRef>
+        </p:style>
+        <p:txBody>
+          <a:bodyPr rtlCol="0" anchor="ctr"/>
+          <a:lstStyle/>
+          <a:p>
+            <a:pPr algn="ctr"/>
+          </a:p>
+        </p:txBody>
+      </p:sp>
+      <p:sp>
+        <p:nvSpPr>
+          <p:cNvPr id="14" name="Rectangle 13"/>
+          <p:cNvSpPr/>
+          <p:nvPr/>
+        </p:nvSpPr>
+        <p:spPr>
+          <a:xfrm>
+            <a:off x="10236200" y="6604000"/>
+            <a:ext cx="139700" cy="25400"/>
+          </a:xfrm>
+          <a:prstGeom prst="rect">
+            <a:avLst/>
+          </a:prstGeom>
+          <a:solidFill>
+            <a:srgbClr val="D9E2ED"/>
+          </a:solidFill>
+          <a:ln>
+            <a:noFill/>
+          </a:ln>
+        </p:spPr>
+        <p:style>
+          <a:lnRef idx="1">
+            <a:schemeClr val="accent1"/>
+          </a:lnRef>
+          <a:fillRef idx="3">
+            <a:schemeClr val="accent1"/>
+          </a:fillRef>
+          <a:effectRef idx="2">
+            <a:schemeClr val="accent1"/>
+          </a:effectRef>
+          <a:fontRef idx="minor">
+            <a:schemeClr val="lt1"/>
+          </a:fontRef>
+        </p:style>
+        <p:txBody>
+          <a:bodyPr rtlCol="0" anchor="ctr"/>
+          <a:lstStyle/>
+          <a:p>
+            <a:pPr algn="ctr"/>
+          </a:p>
+        </p:txBody>
+      </p:sp>
+      <p:sp>
+        <p:nvSpPr>
+          <p:cNvPr id="15" name="Rectangle 14"/>
+          <p:cNvSpPr/>
+          <p:nvPr/>
+        </p:nvSpPr>
+        <p:spPr>
+          <a:xfrm>
+            <a:off x="10452100" y="6604000"/>
+            <a:ext cx="139700" cy="25400"/>
+          </a:xfrm>
+          <a:prstGeom prst="rect">
+            <a:avLst/>
+          </a:prstGeom>
+          <a:solidFill>
+            <a:srgbClr val="D9E2ED"/>
+          </a:solidFill>
+          <a:ln>
+            <a:noFill/>
+          </a:ln>
+        </p:spPr>
+        <p:style>
+          <a:lnRef idx="1">
+            <a:schemeClr val="accent1"/>
+          </a:lnRef>
+          <a:fillRef idx="3">
+            <a:schemeClr val="accent1"/>
+          </a:fillRef>
+          <a:effectRef idx="2">
+            <a:schemeClr val="accent1"/>
+          </a:effectRef>
+          <a:fontRef idx="minor">
+            <a:schemeClr val="lt1"/>
+          </a:fontRef>
+        </p:style>
+        <p:txBody>
+          <a:bodyPr rtlCol="0" anchor="ctr"/>
+          <a:lstStyle/>
+          <a:p>
+            <a:pPr algn="ctr"/>
+          </a:p>
+        </p:txBody>
+      </p:sp>
+      <p:sp>
+        <p:nvSpPr>
+          <p:cNvPr id="16" name="Rounded Rectangle 15"/>
           <p:cNvSpPr/>
           <p:nvPr/>
         </p:nvSpPr>
@@ -6827,7 +7538,7 @@
       </p:sp>
       <p:sp>
         <p:nvSpPr>
-          <p:cNvPr id="11" name="Rectangle 10"/>
+          <p:cNvPr id="17" name="Rectangle 16"/>
           <p:cNvSpPr/>
           <p:nvPr/>
         </p:nvSpPr>
@@ -6870,7 +7581,7 @@
       </p:sp>
       <p:sp>
         <p:nvSpPr>
-          <p:cNvPr id="12" name="TextBox 11"/>
+          <p:cNvPr id="18" name="TextBox 17"/>
           <p:cNvSpPr txBox="1"/>
           <p:nvPr/>
         </p:nvSpPr>
@@ -6915,7 +7626,7 @@
       </p:sp>
       <p:sp>
         <p:nvSpPr>
-          <p:cNvPr id="13" name="TextBox 12"/>
+          <p:cNvPr id="19" name="TextBox 18"/>
           <p:cNvSpPr txBox="1"/>
           <p:nvPr/>
         </p:nvSpPr>
@@ -6960,7 +7671,7 @@
       </p:sp>
       <p:sp>
         <p:nvSpPr>
-          <p:cNvPr id="14" name="Rounded Rectangle 13"/>
+          <p:cNvPr id="20" name="Rounded Rectangle 19"/>
           <p:cNvSpPr/>
           <p:nvPr/>
         </p:nvSpPr>
@@ -7007,7 +7718,7 @@
       </p:sp>
       <p:sp>
         <p:nvSpPr>
-          <p:cNvPr id="15" name="Rectangle 14"/>
+          <p:cNvPr id="21" name="Rectangle 20"/>
           <p:cNvSpPr/>
           <p:nvPr/>
         </p:nvSpPr>
@@ -7050,7 +7761,7 @@
       </p:sp>
       <p:sp>
         <p:nvSpPr>
-          <p:cNvPr id="16" name="TextBox 15"/>
+          <p:cNvPr id="22" name="TextBox 21"/>
           <p:cNvSpPr txBox="1"/>
           <p:nvPr/>
         </p:nvSpPr>
@@ -7095,7 +7806,7 @@
       </p:sp>
       <p:sp>
         <p:nvSpPr>
-          <p:cNvPr id="17" name="TextBox 16"/>
+          <p:cNvPr id="23" name="TextBox 22"/>
           <p:cNvSpPr txBox="1"/>
           <p:nvPr/>
         </p:nvSpPr>
@@ -7133,14 +7844,14 @@
                 </a:solidFill>
                 <a:latin typeface="Noto Sans"/>
               </a:rPr>
-              <a:t>Activity history + track confidence</a:t>
-            </a:r>
-          </a:p>
-        </p:txBody>
-      </p:sp>
-      <p:sp>
-        <p:nvSpPr>
-          <p:cNvPr id="18" name="Rounded Rectangle 17"/>
+              <a:t>Hit probability / confirmed tracks</a:t>
+            </a:r>
+          </a:p>
+        </p:txBody>
+      </p:sp>
+      <p:sp>
+        <p:nvSpPr>
+          <p:cNvPr id="24" name="Rounded Rectangle 23"/>
           <p:cNvSpPr/>
           <p:nvPr/>
         </p:nvSpPr>
@@ -7187,7 +7898,7 @@
       </p:sp>
       <p:sp>
         <p:nvSpPr>
-          <p:cNvPr id="19" name="Rectangle 18"/>
+          <p:cNvPr id="25" name="Rectangle 24"/>
           <p:cNvSpPr/>
           <p:nvPr/>
         </p:nvSpPr>
@@ -7230,7 +7941,7 @@
       </p:sp>
       <p:sp>
         <p:nvSpPr>
-          <p:cNvPr id="20" name="TextBox 19"/>
+          <p:cNvPr id="26" name="TextBox 25"/>
           <p:cNvSpPr txBox="1"/>
           <p:nvPr/>
         </p:nvSpPr>
@@ -7275,7 +7986,7 @@
       </p:sp>
       <p:sp>
         <p:nvSpPr>
-          <p:cNvPr id="21" name="TextBox 20"/>
+          <p:cNvPr id="27" name="TextBox 26"/>
           <p:cNvSpPr txBox="1"/>
           <p:nvPr/>
         </p:nvSpPr>
@@ -7320,7 +8031,7 @@
       </p:sp>
       <p:sp>
         <p:nvSpPr>
-          <p:cNvPr id="22" name="Rounded Rectangle 21"/>
+          <p:cNvPr id="28" name="Rounded Rectangle 27"/>
           <p:cNvSpPr/>
           <p:nvPr/>
         </p:nvSpPr>
@@ -7367,7 +8078,7 @@
       </p:sp>
       <p:sp>
         <p:nvSpPr>
-          <p:cNvPr id="23" name="Rectangle 22"/>
+          <p:cNvPr id="29" name="Rectangle 28"/>
           <p:cNvSpPr/>
           <p:nvPr/>
         </p:nvSpPr>
@@ -7410,7 +8121,7 @@
       </p:sp>
       <p:sp>
         <p:nvSpPr>
-          <p:cNvPr id="24" name="TextBox 23"/>
+          <p:cNvPr id="30" name="TextBox 29"/>
           <p:cNvSpPr txBox="1"/>
           <p:nvPr/>
         </p:nvSpPr>
@@ -7455,7 +8166,7 @@
       </p:sp>
       <p:sp>
         <p:nvSpPr>
-          <p:cNvPr id="25" name="TextBox 24"/>
+          <p:cNvPr id="31" name="TextBox 30"/>
           <p:cNvSpPr txBox="1"/>
           <p:nvPr/>
         </p:nvSpPr>
@@ -7500,7 +8211,7 @@
       </p:sp>
       <p:cxnSp>
         <p:nvCxnSpPr>
-          <p:cNvPr id="26" name="Connector 25"/>
+          <p:cNvPr id="32" name="Connector 31"/>
           <p:cNvCxnSpPr/>
           <p:nvPr/>
         </p:nvCxnSpPr>
@@ -7536,7 +8247,7 @@
       </p:cxnSp>
       <p:sp>
         <p:nvSpPr>
-          <p:cNvPr id="27" name="TextBox 26"/>
+          <p:cNvPr id="33" name="TextBox 32"/>
           <p:cNvSpPr txBox="1"/>
           <p:nvPr/>
         </p:nvSpPr>
@@ -7581,7 +8292,7 @@
       </p:sp>
       <p:cxnSp>
         <p:nvCxnSpPr>
-          <p:cNvPr id="28" name="Connector 27"/>
+          <p:cNvPr id="34" name="Connector 33"/>
           <p:cNvCxnSpPr/>
           <p:nvPr/>
         </p:nvCxnSpPr>
@@ -7617,7 +8328,7 @@
       </p:cxnSp>
       <p:sp>
         <p:nvSpPr>
-          <p:cNvPr id="29" name="TextBox 28"/>
+          <p:cNvPr id="35" name="TextBox 34"/>
           <p:cNvSpPr txBox="1"/>
           <p:nvPr/>
         </p:nvSpPr>
@@ -7655,14 +8366,14 @@
                 </a:solidFill>
                 <a:latin typeface="Noto Sans"/>
               </a:rPr>
-              <a:t>decision</a:t>
+              <a:t>predicted utility</a:t>
             </a:r>
           </a:p>
         </p:txBody>
       </p:sp>
       <p:cxnSp>
         <p:nvCxnSpPr>
-          <p:cNvPr id="30" name="Connector 29"/>
+          <p:cNvPr id="36" name="Connector 35"/>
           <p:cNvCxnSpPr/>
           <p:nvPr/>
         </p:nvCxnSpPr>
@@ -7698,7 +8409,7 @@
       </p:cxnSp>
       <p:sp>
         <p:nvSpPr>
-          <p:cNvPr id="31" name="TextBox 30"/>
+          <p:cNvPr id="37" name="TextBox 36"/>
           <p:cNvSpPr txBox="1"/>
           <p:nvPr/>
         </p:nvSpPr>
@@ -7736,14 +8447,14 @@
                 </a:solidFill>
                 <a:latin typeface="Noto Sans"/>
               </a:rPr>
-              <a:t>action</a:t>
+              <a:t>band + dwell</a:t>
             </a:r>
           </a:p>
         </p:txBody>
       </p:sp>
       <p:cxnSp>
         <p:nvCxnSpPr>
-          <p:cNvPr id="32" name="Connector 31"/>
+          <p:cNvPr id="38" name="Connector 37"/>
           <p:cNvCxnSpPr/>
           <p:nvPr/>
         </p:nvCxnSpPr>
@@ -7779,7 +8490,7 @@
       </p:cxnSp>
       <p:sp>
         <p:nvSpPr>
-          <p:cNvPr id="33" name="TextBox 32"/>
+          <p:cNvPr id="39" name="TextBox 38"/>
           <p:cNvSpPr txBox="1"/>
           <p:nvPr/>
         </p:nvSpPr>
@@ -7824,13 +8535,13 @@
       </p:sp>
       <p:sp>
         <p:nvSpPr>
-          <p:cNvPr id="34" name="TextBox 33"/>
+          <p:cNvPr id="40" name="TextBox 39"/>
           <p:cNvSpPr txBox="1"/>
           <p:nvPr/>
         </p:nvSpPr>
         <p:spPr>
           <a:xfrm>
-            <a:off x="4648200" y="3733800"/>
+            <a:off x="4737100" y="3632200"/>
             <a:ext cx="2997200" cy="426720"/>
           </a:xfrm>
           <a:prstGeom prst="rect">
@@ -7869,14 +8580,14 @@
       </p:sp>
       <p:sp>
         <p:nvSpPr>
-          <p:cNvPr id="35" name="TextBox 34"/>
+          <p:cNvPr id="41" name="TextBox 40"/>
           <p:cNvSpPr txBox="1"/>
           <p:nvPr/>
         </p:nvSpPr>
         <p:spPr>
           <a:xfrm>
-            <a:off x="4762500" y="4178300"/>
-            <a:ext cx="2844800" cy="261620"/>
+            <a:off x="4864100" y="4114800"/>
+            <a:ext cx="2844800" cy="245110"/>
           </a:xfrm>
           <a:prstGeom prst="rect">
             <a:avLst/>
@@ -7891,7 +8602,7 @@
           <a:p>
             <a:pPr>
               <a:lnSpc>
-                <a:spcPts val="1560"/>
+                <a:spcPts val="1430"/>
               </a:lnSpc>
               <a:spcBef>
                 <a:spcPts val="0"/>
@@ -7901,20 +8612,65 @@
               </a:spcAft>
             </a:pPr>
             <a:r>
-              <a:rPr sz="1200" b="0">
+              <a:rPr sz="1100" b="0">
                 <a:solidFill>
                   <a:srgbClr val="637487"/>
                 </a:solidFill>
                 <a:latin typeface="Noto Sans"/>
               </a:rPr>
-              <a:t>Coverage + switching cost</a:t>
-            </a:r>
-          </a:p>
-        </p:txBody>
-      </p:sp>
-      <p:sp>
-        <p:nvSpPr>
-          <p:cNvPr id="36" name="TextBox 35"/>
+              <a:t>Minimum listening dwell</a:t>
+            </a:r>
+          </a:p>
+        </p:txBody>
+      </p:sp>
+      <p:sp>
+        <p:nvSpPr>
+          <p:cNvPr id="42" name="TextBox 41"/>
+          <p:cNvSpPr txBox="1"/>
+          <p:nvPr/>
+        </p:nvSpPr>
+        <p:spPr>
+          <a:xfrm>
+            <a:off x="4864100" y="4368800"/>
+            <a:ext cx="2844800" cy="245110"/>
+          </a:xfrm>
+          <a:prstGeom prst="rect">
+            <a:avLst/>
+          </a:prstGeom>
+          <a:noFill/>
+        </p:spPr>
+        <p:txBody>
+          <a:bodyPr wrap="none" lIns="0" rIns="0" tIns="0" bIns="0">
+            <a:spAutoFit/>
+          </a:bodyPr>
+          <a:lstStyle/>
+          <a:p>
+            <a:pPr>
+              <a:lnSpc>
+                <a:spcPts val="1430"/>
+              </a:lnSpc>
+              <a:spcBef>
+                <a:spcPts val="0"/>
+              </a:spcBef>
+              <a:spcAft>
+                <a:spcPts val="0"/>
+              </a:spcAft>
+            </a:pPr>
+            <a:r>
+              <a:rPr sz="1100" b="0">
+                <a:solidFill>
+                  <a:srgbClr val="637487"/>
+                </a:solidFill>
+                <a:latin typeface="Noto Sans"/>
+              </a:rPr>
+              <a:t>Overdue-band priority</a:t>
+            </a:r>
+          </a:p>
+        </p:txBody>
+      </p:sp>
+      <p:sp>
+        <p:nvSpPr>
+          <p:cNvPr id="43" name="TextBox 42"/>
           <p:cNvSpPr txBox="1"/>
           <p:nvPr/>
         </p:nvSpPr>
@@ -8332,13 +9088,271 @@
       </p:sp>
       <p:sp>
         <p:nvSpPr>
-          <p:cNvPr id="10" name="TextBox 9"/>
+          <p:cNvPr id="10" name="Rectangle 9"/>
+          <p:cNvSpPr/>
+          <p:nvPr/>
+        </p:nvSpPr>
+        <p:spPr>
+          <a:xfrm>
+            <a:off x="9372600" y="6604000"/>
+            <a:ext cx="139700" cy="25400"/>
+          </a:xfrm>
+          <a:prstGeom prst="rect">
+            <a:avLst/>
+          </a:prstGeom>
+          <a:solidFill>
+            <a:srgbClr val="D9E2ED"/>
+          </a:solidFill>
+          <a:ln>
+            <a:noFill/>
+          </a:ln>
+        </p:spPr>
+        <p:style>
+          <a:lnRef idx="1">
+            <a:schemeClr val="accent1"/>
+          </a:lnRef>
+          <a:fillRef idx="3">
+            <a:schemeClr val="accent1"/>
+          </a:fillRef>
+          <a:effectRef idx="2">
+            <a:schemeClr val="accent1"/>
+          </a:effectRef>
+          <a:fontRef idx="minor">
+            <a:schemeClr val="lt1"/>
+          </a:fontRef>
+        </p:style>
+        <p:txBody>
+          <a:bodyPr rtlCol="0" anchor="ctr"/>
+          <a:lstStyle/>
+          <a:p>
+            <a:pPr algn="ctr"/>
+          </a:p>
+        </p:txBody>
+      </p:sp>
+      <p:sp>
+        <p:nvSpPr>
+          <p:cNvPr id="11" name="Rectangle 10"/>
+          <p:cNvSpPr/>
+          <p:nvPr/>
+        </p:nvSpPr>
+        <p:spPr>
+          <a:xfrm>
+            <a:off x="9588500" y="6604000"/>
+            <a:ext cx="139700" cy="25400"/>
+          </a:xfrm>
+          <a:prstGeom prst="rect">
+            <a:avLst/>
+          </a:prstGeom>
+          <a:solidFill>
+            <a:srgbClr val="D9E2ED"/>
+          </a:solidFill>
+          <a:ln>
+            <a:noFill/>
+          </a:ln>
+        </p:spPr>
+        <p:style>
+          <a:lnRef idx="1">
+            <a:schemeClr val="accent1"/>
+          </a:lnRef>
+          <a:fillRef idx="3">
+            <a:schemeClr val="accent1"/>
+          </a:fillRef>
+          <a:effectRef idx="2">
+            <a:schemeClr val="accent1"/>
+          </a:effectRef>
+          <a:fontRef idx="minor">
+            <a:schemeClr val="lt1"/>
+          </a:fontRef>
+        </p:style>
+        <p:txBody>
+          <a:bodyPr rtlCol="0" anchor="ctr"/>
+          <a:lstStyle/>
+          <a:p>
+            <a:pPr algn="ctr"/>
+          </a:p>
+        </p:txBody>
+      </p:sp>
+      <p:sp>
+        <p:nvSpPr>
+          <p:cNvPr id="12" name="Rectangle 11"/>
+          <p:cNvSpPr/>
+          <p:nvPr/>
+        </p:nvSpPr>
+        <p:spPr>
+          <a:xfrm>
+            <a:off x="9804400" y="6604000"/>
+            <a:ext cx="139700" cy="25400"/>
+          </a:xfrm>
+          <a:prstGeom prst="rect">
+            <a:avLst/>
+          </a:prstGeom>
+          <a:solidFill>
+            <a:srgbClr val="245CDE"/>
+          </a:solidFill>
+          <a:ln>
+            <a:noFill/>
+          </a:ln>
+        </p:spPr>
+        <p:style>
+          <a:lnRef idx="1">
+            <a:schemeClr val="accent1"/>
+          </a:lnRef>
+          <a:fillRef idx="3">
+            <a:schemeClr val="accent1"/>
+          </a:fillRef>
+          <a:effectRef idx="2">
+            <a:schemeClr val="accent1"/>
+          </a:effectRef>
+          <a:fontRef idx="minor">
+            <a:schemeClr val="lt1"/>
+          </a:fontRef>
+        </p:style>
+        <p:txBody>
+          <a:bodyPr rtlCol="0" anchor="ctr"/>
+          <a:lstStyle/>
+          <a:p>
+            <a:pPr algn="ctr"/>
+          </a:p>
+        </p:txBody>
+      </p:sp>
+      <p:sp>
+        <p:nvSpPr>
+          <p:cNvPr id="13" name="Rectangle 12"/>
+          <p:cNvSpPr/>
+          <p:nvPr/>
+        </p:nvSpPr>
+        <p:spPr>
+          <a:xfrm>
+            <a:off x="10020300" y="6604000"/>
+            <a:ext cx="139700" cy="25400"/>
+          </a:xfrm>
+          <a:prstGeom prst="rect">
+            <a:avLst/>
+          </a:prstGeom>
+          <a:solidFill>
+            <a:srgbClr val="D9E2ED"/>
+          </a:solidFill>
+          <a:ln>
+            <a:noFill/>
+          </a:ln>
+        </p:spPr>
+        <p:style>
+          <a:lnRef idx="1">
+            <a:schemeClr val="accent1"/>
+          </a:lnRef>
+          <a:fillRef idx="3">
+            <a:schemeClr val="accent1"/>
+          </a:fillRef>
+          <a:effectRef idx="2">
+            <a:schemeClr val="accent1"/>
+          </a:effectRef>
+          <a:fontRef idx="minor">
+            <a:schemeClr val="lt1"/>
+          </a:fontRef>
+        </p:style>
+        <p:txBody>
+          <a:bodyPr rtlCol="0" anchor="ctr"/>
+          <a:lstStyle/>
+          <a:p>
+            <a:pPr algn="ctr"/>
+          </a:p>
+        </p:txBody>
+      </p:sp>
+      <p:sp>
+        <p:nvSpPr>
+          <p:cNvPr id="14" name="Rectangle 13"/>
+          <p:cNvSpPr/>
+          <p:nvPr/>
+        </p:nvSpPr>
+        <p:spPr>
+          <a:xfrm>
+            <a:off x="10236200" y="6604000"/>
+            <a:ext cx="139700" cy="25400"/>
+          </a:xfrm>
+          <a:prstGeom prst="rect">
+            <a:avLst/>
+          </a:prstGeom>
+          <a:solidFill>
+            <a:srgbClr val="D9E2ED"/>
+          </a:solidFill>
+          <a:ln>
+            <a:noFill/>
+          </a:ln>
+        </p:spPr>
+        <p:style>
+          <a:lnRef idx="1">
+            <a:schemeClr val="accent1"/>
+          </a:lnRef>
+          <a:fillRef idx="3">
+            <a:schemeClr val="accent1"/>
+          </a:fillRef>
+          <a:effectRef idx="2">
+            <a:schemeClr val="accent1"/>
+          </a:effectRef>
+          <a:fontRef idx="minor">
+            <a:schemeClr val="lt1"/>
+          </a:fontRef>
+        </p:style>
+        <p:txBody>
+          <a:bodyPr rtlCol="0" anchor="ctr"/>
+          <a:lstStyle/>
+          <a:p>
+            <a:pPr algn="ctr"/>
+          </a:p>
+        </p:txBody>
+      </p:sp>
+      <p:sp>
+        <p:nvSpPr>
+          <p:cNvPr id="15" name="Rectangle 14"/>
+          <p:cNvSpPr/>
+          <p:nvPr/>
+        </p:nvSpPr>
+        <p:spPr>
+          <a:xfrm>
+            <a:off x="10452100" y="6604000"/>
+            <a:ext cx="139700" cy="25400"/>
+          </a:xfrm>
+          <a:prstGeom prst="rect">
+            <a:avLst/>
+          </a:prstGeom>
+          <a:solidFill>
+            <a:srgbClr val="D9E2ED"/>
+          </a:solidFill>
+          <a:ln>
+            <a:noFill/>
+          </a:ln>
+        </p:spPr>
+        <p:style>
+          <a:lnRef idx="1">
+            <a:schemeClr val="accent1"/>
+          </a:lnRef>
+          <a:fillRef idx="3">
+            <a:schemeClr val="accent1"/>
+          </a:fillRef>
+          <a:effectRef idx="2">
+            <a:schemeClr val="accent1"/>
+          </a:effectRef>
+          <a:fontRef idx="minor">
+            <a:schemeClr val="lt1"/>
+          </a:fontRef>
+        </p:style>
+        <p:txBody>
+          <a:bodyPr rtlCol="0" anchor="ctr"/>
+          <a:lstStyle/>
+          <a:p>
+            <a:pPr algn="ctr"/>
+          </a:p>
+        </p:txBody>
+      </p:sp>
+      <p:sp>
+        <p:nvSpPr>
+          <p:cNvPr id="16" name="TextBox 15"/>
           <p:cNvSpPr txBox="1"/>
           <p:nvPr/>
         </p:nvSpPr>
         <p:spPr>
           <a:xfrm>
-            <a:off x="558800" y="2247900"/>
+            <a:off x="558800" y="2095500"/>
             <a:ext cx="11049000" cy="245110"/>
           </a:xfrm>
           <a:prstGeom prst="rect">
@@ -8370,20 +9384,217 @@
                 </a:solidFill>
                 <a:latin typeface="Noto Sans"/>
               </a:rPr>
-              <a:t>ONLINE SIMULATION</a:t>
-            </a:r>
-          </a:p>
-        </p:txBody>
-      </p:sp>
-      <p:sp>
-        <p:nvSpPr>
-          <p:cNvPr id="11" name="Rounded Rectangle 10"/>
+              <a:t>A / CLOSED-LOOP SIMULATION</a:t>
+            </a:r>
+          </a:p>
+        </p:txBody>
+      </p:sp>
+      <p:cxnSp>
+        <p:nvCxnSpPr>
+          <p:cNvPr id="17" name="Connector 16"/>
+          <p:cNvCxnSpPr/>
+          <p:nvPr/>
+        </p:nvCxnSpPr>
+        <p:spPr>
+          <a:xfrm flipV="1">
+            <a:off x="2286000" y="2514600"/>
+            <a:ext cx="0" cy="304800"/>
+          </a:xfrm>
+          <a:prstGeom prst="line">
+            <a:avLst/>
+          </a:prstGeom>
+          <a:ln w="12700">
+            <a:solidFill>
+              <a:srgbClr val="637487"/>
+            </a:solidFill>
+            <a:prstDash val="dash"/>
+          </a:ln>
+        </p:spPr>
+        <p:style>
+          <a:lnRef idx="2">
+            <a:schemeClr val="accent1"/>
+          </a:lnRef>
+          <a:fillRef idx="0">
+            <a:schemeClr val="accent1"/>
+          </a:fillRef>
+          <a:effectRef idx="1">
+            <a:schemeClr val="accent1"/>
+          </a:effectRef>
+          <a:fontRef idx="minor">
+            <a:schemeClr val="tx1"/>
+          </a:fontRef>
+        </p:style>
+      </p:cxnSp>
+      <p:cxnSp>
+        <p:nvCxnSpPr>
+          <p:cNvPr id="18" name="Connector 17"/>
+          <p:cNvCxnSpPr/>
+          <p:nvPr/>
+        </p:nvCxnSpPr>
+        <p:spPr>
+          <a:xfrm>
+            <a:off x="2286000" y="2514600"/>
+            <a:ext cx="7620000" cy="0"/>
+          </a:xfrm>
+          <a:prstGeom prst="line">
+            <a:avLst/>
+          </a:prstGeom>
+          <a:ln w="12700">
+            <a:solidFill>
+              <a:srgbClr val="637487"/>
+            </a:solidFill>
+            <a:prstDash val="dash"/>
+          </a:ln>
+        </p:spPr>
+        <p:style>
+          <a:lnRef idx="2">
+            <a:schemeClr val="accent1"/>
+          </a:lnRef>
+          <a:fillRef idx="0">
+            <a:schemeClr val="accent1"/>
+          </a:fillRef>
+          <a:effectRef idx="1">
+            <a:schemeClr val="accent1"/>
+          </a:effectRef>
+          <a:fontRef idx="minor">
+            <a:schemeClr val="tx1"/>
+          </a:fontRef>
+        </p:style>
+      </p:cxnSp>
+      <p:cxnSp>
+        <p:nvCxnSpPr>
+          <p:cNvPr id="19" name="Connector 18"/>
+          <p:cNvCxnSpPr/>
+          <p:nvPr/>
+        </p:nvCxnSpPr>
+        <p:spPr>
+          <a:xfrm>
+            <a:off x="9906000" y="2514600"/>
+            <a:ext cx="0" cy="304800"/>
+          </a:xfrm>
+          <a:prstGeom prst="line">
+            <a:avLst/>
+          </a:prstGeom>
+          <a:ln w="12700">
+            <a:solidFill>
+              <a:srgbClr val="637487"/>
+            </a:solidFill>
+            <a:prstDash val="dash"/>
+            <a:tailEnd type="triangle"/>
+          </a:ln>
+        </p:spPr>
+        <p:style>
+          <a:lnRef idx="2">
+            <a:schemeClr val="accent1"/>
+          </a:lnRef>
+          <a:fillRef idx="0">
+            <a:schemeClr val="accent1"/>
+          </a:fillRef>
+          <a:effectRef idx="1">
+            <a:schemeClr val="accent1"/>
+          </a:effectRef>
+          <a:fontRef idx="minor">
+            <a:schemeClr val="tx1"/>
+          </a:fontRef>
+        </p:style>
+      </p:cxnSp>
+      <p:sp>
+        <p:nvSpPr>
+          <p:cNvPr id="20" name="Rectangle 19"/>
           <p:cNvSpPr/>
           <p:nvPr/>
         </p:nvSpPr>
         <p:spPr>
           <a:xfrm>
-            <a:off x="558800" y="2603500"/>
+            <a:off x="4368800" y="2374900"/>
+            <a:ext cx="3644900" cy="254000"/>
+          </a:xfrm>
+          <a:prstGeom prst="rect">
+            <a:avLst/>
+          </a:prstGeom>
+          <a:solidFill>
+            <a:srgbClr val="FFFFFF"/>
+          </a:solidFill>
+          <a:ln>
+            <a:noFill/>
+          </a:ln>
+        </p:spPr>
+        <p:style>
+          <a:lnRef idx="1">
+            <a:schemeClr val="accent1"/>
+          </a:lnRef>
+          <a:fillRef idx="3">
+            <a:schemeClr val="accent1"/>
+          </a:fillRef>
+          <a:effectRef idx="2">
+            <a:schemeClr val="accent1"/>
+          </a:effectRef>
+          <a:fontRef idx="minor">
+            <a:schemeClr val="lt1"/>
+          </a:fontRef>
+        </p:style>
+        <p:txBody>
+          <a:bodyPr rtlCol="0" anchor="ctr"/>
+          <a:lstStyle/>
+          <a:p>
+            <a:pPr algn="ctr"/>
+          </a:p>
+        </p:txBody>
+      </p:sp>
+      <p:sp>
+        <p:nvSpPr>
+          <p:cNvPr id="21" name="TextBox 20"/>
+          <p:cNvSpPr txBox="1"/>
+          <p:nvPr/>
+        </p:nvSpPr>
+        <p:spPr>
+          <a:xfrm>
+            <a:off x="4483100" y="2400300"/>
+            <a:ext cx="3429000" cy="228600"/>
+          </a:xfrm>
+          <a:prstGeom prst="rect">
+            <a:avLst/>
+          </a:prstGeom>
+          <a:noFill/>
+        </p:spPr>
+        <p:txBody>
+          <a:bodyPr wrap="none" lIns="0" rIns="0" tIns="0" bIns="0">
+            <a:spAutoFit/>
+          </a:bodyPr>
+          <a:lstStyle/>
+          <a:p>
+            <a:pPr>
+              <a:lnSpc>
+                <a:spcPts val="1300"/>
+              </a:lnSpc>
+              <a:spcBef>
+                <a:spcPts val="0"/>
+              </a:spcBef>
+              <a:spcAft>
+                <a:spcPts val="0"/>
+              </a:spcAft>
+            </a:pPr>
+            <a:r>
+              <a:rPr sz="1000" b="0">
+                <a:solidFill>
+                  <a:srgbClr val="637487"/>
+                </a:solidFill>
+                <a:latin typeface="Noto Sans"/>
+              </a:rPr>
+              <a:t>Hidden truth: evaluation only</a:t>
+            </a:r>
+          </a:p>
+        </p:txBody>
+      </p:sp>
+      <p:sp>
+        <p:nvSpPr>
+          <p:cNvPr id="22" name="Rounded Rectangle 21"/>
+          <p:cNvSpPr/>
+          <p:nvPr/>
+        </p:nvSpPr>
+        <p:spPr>
+          <a:xfrm>
+            <a:off x="558800" y="2819400"/>
             <a:ext cx="3454400" cy="1003300"/>
           </a:xfrm>
           <a:prstGeom prst="roundRect">
@@ -8424,13 +9635,13 @@
       </p:sp>
       <p:sp>
         <p:nvSpPr>
-          <p:cNvPr id="12" name="Rectangle 11"/>
+          <p:cNvPr id="23" name="Rectangle 22"/>
           <p:cNvSpPr/>
           <p:nvPr/>
         </p:nvSpPr>
         <p:spPr>
           <a:xfrm>
-            <a:off x="558800" y="2832100"/>
+            <a:off x="558800" y="3048000"/>
             <a:ext cx="38100" cy="533400"/>
           </a:xfrm>
           <a:prstGeom prst="rect">
@@ -8467,13 +9678,13 @@
       </p:sp>
       <p:sp>
         <p:nvSpPr>
-          <p:cNvPr id="13" name="TextBox 12"/>
+          <p:cNvPr id="24" name="TextBox 23"/>
           <p:cNvSpPr txBox="1"/>
           <p:nvPr/>
         </p:nvSpPr>
         <p:spPr>
           <a:xfrm>
-            <a:off x="774700" y="2768600"/>
+            <a:off x="774700" y="2984500"/>
             <a:ext cx="3073400" cy="344170"/>
           </a:xfrm>
           <a:prstGeom prst="rect">
@@ -8512,13 +9723,13 @@
       </p:sp>
       <p:sp>
         <p:nvSpPr>
-          <p:cNvPr id="14" name="TextBox 13"/>
+          <p:cNvPr id="25" name="TextBox 24"/>
           <p:cNvSpPr txBox="1"/>
           <p:nvPr/>
         </p:nvSpPr>
         <p:spPr>
           <a:xfrm>
-            <a:off x="774700" y="3149600"/>
+            <a:off x="774700" y="3365500"/>
             <a:ext cx="3073400" cy="261620"/>
           </a:xfrm>
           <a:prstGeom prst="rect">
@@ -8557,13 +9768,13 @@
       </p:sp>
       <p:sp>
         <p:nvSpPr>
-          <p:cNvPr id="15" name="Rounded Rectangle 14"/>
+          <p:cNvPr id="26" name="Rounded Rectangle 25"/>
           <p:cNvSpPr/>
           <p:nvPr/>
         </p:nvSpPr>
         <p:spPr>
           <a:xfrm>
-            <a:off x="4368800" y="2603500"/>
+            <a:off x="4368800" y="2819400"/>
             <a:ext cx="3454400" cy="1003300"/>
           </a:xfrm>
           <a:prstGeom prst="roundRect">
@@ -8604,13 +9815,13 @@
       </p:sp>
       <p:sp>
         <p:nvSpPr>
-          <p:cNvPr id="16" name="Rectangle 15"/>
+          <p:cNvPr id="27" name="Rectangle 26"/>
           <p:cNvSpPr/>
           <p:nvPr/>
         </p:nvSpPr>
         <p:spPr>
           <a:xfrm>
-            <a:off x="4368800" y="2832100"/>
+            <a:off x="4368800" y="3048000"/>
             <a:ext cx="38100" cy="533400"/>
           </a:xfrm>
           <a:prstGeom prst="rect">
@@ -8647,13 +9858,13 @@
       </p:sp>
       <p:sp>
         <p:nvSpPr>
-          <p:cNvPr id="17" name="TextBox 16"/>
+          <p:cNvPr id="28" name="TextBox 27"/>
           <p:cNvSpPr txBox="1"/>
           <p:nvPr/>
         </p:nvSpPr>
         <p:spPr>
           <a:xfrm>
-            <a:off x="4584700" y="2768600"/>
+            <a:off x="4584700" y="2984500"/>
             <a:ext cx="3073400" cy="344170"/>
           </a:xfrm>
           <a:prstGeom prst="rect">
@@ -8692,13 +9903,13 @@
       </p:sp>
       <p:sp>
         <p:nvSpPr>
-          <p:cNvPr id="18" name="TextBox 17"/>
+          <p:cNvPr id="29" name="TextBox 28"/>
           <p:cNvSpPr txBox="1"/>
           <p:nvPr/>
         </p:nvSpPr>
         <p:spPr>
           <a:xfrm>
-            <a:off x="4584700" y="3149600"/>
+            <a:off x="4584700" y="3365500"/>
             <a:ext cx="3073400" cy="261620"/>
           </a:xfrm>
           <a:prstGeom prst="rect">
@@ -8737,13 +9948,13 @@
       </p:sp>
       <p:sp>
         <p:nvSpPr>
-          <p:cNvPr id="19" name="Rounded Rectangle 18"/>
+          <p:cNvPr id="30" name="Rounded Rectangle 29"/>
           <p:cNvSpPr/>
           <p:nvPr/>
         </p:nvSpPr>
         <p:spPr>
           <a:xfrm>
-            <a:off x="8178800" y="2603500"/>
+            <a:off x="8178800" y="2819400"/>
             <a:ext cx="3454400" cy="1003300"/>
           </a:xfrm>
           <a:prstGeom prst="roundRect">
@@ -8784,13 +9995,13 @@
       </p:sp>
       <p:sp>
         <p:nvSpPr>
-          <p:cNvPr id="20" name="Rectangle 19"/>
+          <p:cNvPr id="31" name="Rectangle 30"/>
           <p:cNvSpPr/>
           <p:nvPr/>
         </p:nvSpPr>
         <p:spPr>
           <a:xfrm>
-            <a:off x="8178800" y="2832100"/>
+            <a:off x="8178800" y="3048000"/>
             <a:ext cx="38100" cy="533400"/>
           </a:xfrm>
           <a:prstGeom prst="rect">
@@ -8827,13 +10038,13 @@
       </p:sp>
       <p:sp>
         <p:nvSpPr>
-          <p:cNvPr id="21" name="TextBox 20"/>
+          <p:cNvPr id="32" name="TextBox 31"/>
           <p:cNvSpPr txBox="1"/>
           <p:nvPr/>
         </p:nvSpPr>
         <p:spPr>
           <a:xfrm>
-            <a:off x="8394700" y="2768600"/>
+            <a:off x="8394700" y="2984500"/>
             <a:ext cx="3073400" cy="344170"/>
           </a:xfrm>
           <a:prstGeom prst="rect">
@@ -8872,13 +10083,13 @@
       </p:sp>
       <p:sp>
         <p:nvSpPr>
-          <p:cNvPr id="22" name="TextBox 21"/>
+          <p:cNvPr id="33" name="TextBox 32"/>
           <p:cNvSpPr txBox="1"/>
           <p:nvPr/>
         </p:nvSpPr>
         <p:spPr>
           <a:xfrm>
-            <a:off x="8394700" y="3149600"/>
+            <a:off x="8394700" y="3365500"/>
             <a:ext cx="3073400" cy="261620"/>
           </a:xfrm>
           <a:prstGeom prst="rect">
@@ -8917,13 +10128,13 @@
       </p:sp>
       <p:cxnSp>
         <p:nvCxnSpPr>
-          <p:cNvPr id="23" name="Connector 22"/>
+          <p:cNvPr id="34" name="Connector 33"/>
           <p:cNvCxnSpPr/>
           <p:nvPr/>
         </p:nvCxnSpPr>
         <p:spPr>
           <a:xfrm>
-            <a:off x="4025900" y="3111500"/>
+            <a:off x="4025900" y="3327400"/>
             <a:ext cx="304800" cy="0"/>
           </a:xfrm>
           <a:prstGeom prst="line">
@@ -8953,13 +10164,13 @@
       </p:cxnSp>
       <p:cxnSp>
         <p:nvCxnSpPr>
-          <p:cNvPr id="24" name="Connector 23"/>
+          <p:cNvPr id="35" name="Connector 34"/>
           <p:cNvCxnSpPr/>
           <p:nvPr/>
         </p:nvCxnSpPr>
         <p:spPr>
           <a:xfrm>
-            <a:off x="7835900" y="3111500"/>
+            <a:off x="7835900" y="3327400"/>
             <a:ext cx="304800" cy="0"/>
           </a:xfrm>
           <a:prstGeom prst="line">
@@ -8989,13 +10200,13 @@
       </p:cxnSp>
       <p:sp>
         <p:nvSpPr>
-          <p:cNvPr id="25" name="TextBox 24"/>
+          <p:cNvPr id="36" name="TextBox 35"/>
           <p:cNvSpPr txBox="1"/>
           <p:nvPr/>
         </p:nvSpPr>
         <p:spPr>
           <a:xfrm>
-            <a:off x="4368800" y="3708400"/>
+            <a:off x="4368800" y="3911600"/>
             <a:ext cx="7048500" cy="236854"/>
           </a:xfrm>
           <a:prstGeom prst="rect">
@@ -9027,20 +10238,20 @@
                 </a:solidFill>
                 <a:latin typeface="Noto Sans"/>
               </a:rPr>
-              <a:t>13 baselines + logistic hit predictor; truth hidden from policies</a:t>
-            </a:r>
-          </a:p>
-        </p:txBody>
-      </p:sp>
-      <p:sp>
-        <p:nvSpPr>
-          <p:cNvPr id="26" name="TextBox 25"/>
+              <a:t>13 baselines + logistic hit predictor; identical seeded receiver conditions</a:t>
+            </a:r>
+          </a:p>
+        </p:txBody>
+      </p:sp>
+      <p:sp>
+        <p:nvSpPr>
+          <p:cNvPr id="37" name="TextBox 36"/>
           <p:cNvSpPr txBox="1"/>
           <p:nvPr/>
         </p:nvSpPr>
         <p:spPr>
           <a:xfrm>
-            <a:off x="558800" y="4178300"/>
+            <a:off x="558800" y="4330700"/>
             <a:ext cx="11049000" cy="245110"/>
           </a:xfrm>
           <a:prstGeom prst="rect">
@@ -9072,20 +10283,20 @@
                 </a:solidFill>
                 <a:latin typeface="Noto Sans"/>
               </a:rPr>
-              <a:t>OFFLINE PULSE ASSOCIATION</a:t>
-            </a:r>
-          </a:p>
-        </p:txBody>
-      </p:sp>
-      <p:sp>
-        <p:nvSpPr>
-          <p:cNvPr id="27" name="Rounded Rectangle 26"/>
+              <a:t>B / OFFLINE PULSE ASSOCIATION</a:t>
+            </a:r>
+          </a:p>
+        </p:txBody>
+      </p:sp>
+      <p:sp>
+        <p:nvSpPr>
+          <p:cNvPr id="38" name="Rounded Rectangle 37"/>
           <p:cNvSpPr/>
           <p:nvPr/>
         </p:nvSpPr>
         <p:spPr>
           <a:xfrm>
-            <a:off x="558800" y="4508500"/>
+            <a:off x="558800" y="4635500"/>
             <a:ext cx="3454400" cy="1003300"/>
           </a:xfrm>
           <a:prstGeom prst="roundRect">
@@ -9126,13 +10337,13 @@
       </p:sp>
       <p:sp>
         <p:nvSpPr>
-          <p:cNvPr id="28" name="Rectangle 27"/>
+          <p:cNvPr id="39" name="Rectangle 38"/>
           <p:cNvSpPr/>
           <p:nvPr/>
         </p:nvSpPr>
         <p:spPr>
           <a:xfrm>
-            <a:off x="558800" y="4737100"/>
+            <a:off x="558800" y="4864100"/>
             <a:ext cx="38100" cy="533400"/>
           </a:xfrm>
           <a:prstGeom prst="rect">
@@ -9169,13 +10380,13 @@
       </p:sp>
       <p:sp>
         <p:nvSpPr>
-          <p:cNvPr id="29" name="TextBox 28"/>
+          <p:cNvPr id="40" name="TextBox 39"/>
           <p:cNvSpPr txBox="1"/>
           <p:nvPr/>
         </p:nvSpPr>
         <p:spPr>
           <a:xfrm>
-            <a:off x="774700" y="4673600"/>
+            <a:off x="774700" y="4800600"/>
             <a:ext cx="3073400" cy="344170"/>
           </a:xfrm>
           <a:prstGeom prst="rect">
@@ -9214,13 +10425,13 @@
       </p:sp>
       <p:sp>
         <p:nvSpPr>
-          <p:cNvPr id="30" name="TextBox 29"/>
+          <p:cNvPr id="41" name="TextBox 40"/>
           <p:cNvSpPr txBox="1"/>
           <p:nvPr/>
         </p:nvSpPr>
         <p:spPr>
           <a:xfrm>
-            <a:off x="774700" y="5054600"/>
+            <a:off x="774700" y="5181600"/>
             <a:ext cx="3073400" cy="261620"/>
           </a:xfrm>
           <a:prstGeom prst="rect">
@@ -9259,13 +10470,13 @@
       </p:sp>
       <p:sp>
         <p:nvSpPr>
-          <p:cNvPr id="31" name="Rounded Rectangle 30"/>
+          <p:cNvPr id="42" name="Rounded Rectangle 41"/>
           <p:cNvSpPr/>
           <p:nvPr/>
         </p:nvSpPr>
         <p:spPr>
           <a:xfrm>
-            <a:off x="4368800" y="4508500"/>
+            <a:off x="4368800" y="4635500"/>
             <a:ext cx="3454400" cy="1003300"/>
           </a:xfrm>
           <a:prstGeom prst="roundRect">
@@ -9306,13 +10517,13 @@
       </p:sp>
       <p:sp>
         <p:nvSpPr>
-          <p:cNvPr id="32" name="Rectangle 31"/>
+          <p:cNvPr id="43" name="Rectangle 42"/>
           <p:cNvSpPr/>
           <p:nvPr/>
         </p:nvSpPr>
         <p:spPr>
           <a:xfrm>
-            <a:off x="4368800" y="4737100"/>
+            <a:off x="4368800" y="4864100"/>
             <a:ext cx="38100" cy="533400"/>
           </a:xfrm>
           <a:prstGeom prst="rect">
@@ -9349,13 +10560,13 @@
       </p:sp>
       <p:sp>
         <p:nvSpPr>
-          <p:cNvPr id="33" name="TextBox 32"/>
+          <p:cNvPr id="44" name="TextBox 43"/>
           <p:cNvSpPr txBox="1"/>
           <p:nvPr/>
         </p:nvSpPr>
         <p:spPr>
           <a:xfrm>
-            <a:off x="4584700" y="4673600"/>
+            <a:off x="4584700" y="4800600"/>
             <a:ext cx="3073400" cy="344170"/>
           </a:xfrm>
           <a:prstGeom prst="rect">
@@ -9394,13 +10605,13 @@
       </p:sp>
       <p:sp>
         <p:nvSpPr>
-          <p:cNvPr id="34" name="TextBox 33"/>
+          <p:cNvPr id="45" name="TextBox 44"/>
           <p:cNvSpPr txBox="1"/>
           <p:nvPr/>
         </p:nvSpPr>
         <p:spPr>
           <a:xfrm>
-            <a:off x="4584700" y="5054600"/>
+            <a:off x="4584700" y="5181600"/>
             <a:ext cx="3073400" cy="261620"/>
           </a:xfrm>
           <a:prstGeom prst="rect">
@@ -9439,13 +10650,13 @@
       </p:sp>
       <p:sp>
         <p:nvSpPr>
-          <p:cNvPr id="35" name="Rounded Rectangle 34"/>
+          <p:cNvPr id="46" name="Rounded Rectangle 45"/>
           <p:cNvSpPr/>
           <p:nvPr/>
         </p:nvSpPr>
         <p:spPr>
           <a:xfrm>
-            <a:off x="8178800" y="4508500"/>
+            <a:off x="8178800" y="4635500"/>
             <a:ext cx="3454400" cy="1003300"/>
           </a:xfrm>
           <a:prstGeom prst="roundRect">
@@ -9486,13 +10697,13 @@
       </p:sp>
       <p:sp>
         <p:nvSpPr>
-          <p:cNvPr id="36" name="Rectangle 35"/>
+          <p:cNvPr id="47" name="Rectangle 46"/>
           <p:cNvSpPr/>
           <p:nvPr/>
         </p:nvSpPr>
         <p:spPr>
           <a:xfrm>
-            <a:off x="8178800" y="4737100"/>
+            <a:off x="8178800" y="4864100"/>
             <a:ext cx="38100" cy="533400"/>
           </a:xfrm>
           <a:prstGeom prst="rect">
@@ -9529,13 +10740,13 @@
       </p:sp>
       <p:sp>
         <p:nvSpPr>
-          <p:cNvPr id="37" name="TextBox 36"/>
+          <p:cNvPr id="48" name="TextBox 47"/>
           <p:cNvSpPr txBox="1"/>
           <p:nvPr/>
         </p:nvSpPr>
         <p:spPr>
           <a:xfrm>
-            <a:off x="8394700" y="4673600"/>
+            <a:off x="8394700" y="4800600"/>
             <a:ext cx="3073400" cy="344170"/>
           </a:xfrm>
           <a:prstGeom prst="rect">
@@ -9574,13 +10785,13 @@
       </p:sp>
       <p:sp>
         <p:nvSpPr>
-          <p:cNvPr id="38" name="TextBox 37"/>
+          <p:cNvPr id="49" name="TextBox 48"/>
           <p:cNvSpPr txBox="1"/>
           <p:nvPr/>
         </p:nvSpPr>
         <p:spPr>
           <a:xfrm>
-            <a:off x="8394700" y="5054600"/>
+            <a:off x="8394700" y="5181600"/>
             <a:ext cx="3073400" cy="261620"/>
           </a:xfrm>
           <a:prstGeom prst="rect">
@@ -9619,13 +10830,13 @@
       </p:sp>
       <p:cxnSp>
         <p:nvCxnSpPr>
-          <p:cNvPr id="39" name="Connector 38"/>
+          <p:cNvPr id="50" name="Connector 49"/>
           <p:cNvCxnSpPr/>
           <p:nvPr/>
         </p:nvCxnSpPr>
         <p:spPr>
           <a:xfrm>
-            <a:off x="4025900" y="5016500"/>
+            <a:off x="4025900" y="5143500"/>
             <a:ext cx="304800" cy="0"/>
           </a:xfrm>
           <a:prstGeom prst="line">
@@ -9655,13 +10866,13 @@
       </p:cxnSp>
       <p:cxnSp>
         <p:nvCxnSpPr>
-          <p:cNvPr id="40" name="Connector 39"/>
+          <p:cNvPr id="51" name="Connector 50"/>
           <p:cNvCxnSpPr/>
           <p:nvPr/>
         </p:nvCxnSpPr>
         <p:spPr>
           <a:xfrm>
-            <a:off x="7835900" y="5016500"/>
+            <a:off x="7835900" y="5143500"/>
             <a:ext cx="304800" cy="0"/>
           </a:xfrm>
           <a:prstGeom prst="line">
@@ -9691,14 +10902,14 @@
       </p:cxnSp>
       <p:cxnSp>
         <p:nvCxnSpPr>
-          <p:cNvPr id="41" name="Connector 40"/>
+          <p:cNvPr id="52" name="Connector 51"/>
           <p:cNvCxnSpPr/>
           <p:nvPr/>
         </p:nvCxnSpPr>
         <p:spPr>
           <a:xfrm>
-            <a:off x="736600" y="5537200"/>
-            <a:ext cx="0" cy="444500"/>
+            <a:off x="736600" y="5664200"/>
+            <a:ext cx="0" cy="317500"/>
           </a:xfrm>
           <a:prstGeom prst="line">
             <a:avLst/>
@@ -9727,7 +10938,7 @@
       </p:cxnSp>
       <p:cxnSp>
         <p:nvCxnSpPr>
-          <p:cNvPr id="42" name="Connector 41"/>
+          <p:cNvPr id="53" name="Connector 52"/>
           <p:cNvCxnSpPr/>
           <p:nvPr/>
         </p:nvCxnSpPr>
@@ -9764,7 +10975,7 @@
       </p:cxnSp>
       <p:sp>
         <p:nvSpPr>
-          <p:cNvPr id="43" name="TextBox 42"/>
+          <p:cNvPr id="54" name="TextBox 53"/>
           <p:cNvSpPr txBox="1"/>
           <p:nvPr/>
         </p:nvSpPr>
@@ -9809,7 +11020,7 @@
       </p:sp>
       <p:sp>
         <p:nvSpPr>
-          <p:cNvPr id="44" name="TextBox 43"/>
+          <p:cNvPr id="55" name="TextBox 54"/>
           <p:cNvSpPr txBox="1"/>
           <p:nvPr/>
         </p:nvSpPr>
@@ -10227,7 +11438,265 @@
       </p:sp>
       <p:sp>
         <p:nvSpPr>
-          <p:cNvPr id="10" name="TextBox 9"/>
+          <p:cNvPr id="10" name="Rectangle 9"/>
+          <p:cNvSpPr/>
+          <p:nvPr/>
+        </p:nvSpPr>
+        <p:spPr>
+          <a:xfrm>
+            <a:off x="9372600" y="6604000"/>
+            <a:ext cx="139700" cy="25400"/>
+          </a:xfrm>
+          <a:prstGeom prst="rect">
+            <a:avLst/>
+          </a:prstGeom>
+          <a:solidFill>
+            <a:srgbClr val="D9E2ED"/>
+          </a:solidFill>
+          <a:ln>
+            <a:noFill/>
+          </a:ln>
+        </p:spPr>
+        <p:style>
+          <a:lnRef idx="1">
+            <a:schemeClr val="accent1"/>
+          </a:lnRef>
+          <a:fillRef idx="3">
+            <a:schemeClr val="accent1"/>
+          </a:fillRef>
+          <a:effectRef idx="2">
+            <a:schemeClr val="accent1"/>
+          </a:effectRef>
+          <a:fontRef idx="minor">
+            <a:schemeClr val="lt1"/>
+          </a:fontRef>
+        </p:style>
+        <p:txBody>
+          <a:bodyPr rtlCol="0" anchor="ctr"/>
+          <a:lstStyle/>
+          <a:p>
+            <a:pPr algn="ctr"/>
+          </a:p>
+        </p:txBody>
+      </p:sp>
+      <p:sp>
+        <p:nvSpPr>
+          <p:cNvPr id="11" name="Rectangle 10"/>
+          <p:cNvSpPr/>
+          <p:nvPr/>
+        </p:nvSpPr>
+        <p:spPr>
+          <a:xfrm>
+            <a:off x="9588500" y="6604000"/>
+            <a:ext cx="139700" cy="25400"/>
+          </a:xfrm>
+          <a:prstGeom prst="rect">
+            <a:avLst/>
+          </a:prstGeom>
+          <a:solidFill>
+            <a:srgbClr val="D9E2ED"/>
+          </a:solidFill>
+          <a:ln>
+            <a:noFill/>
+          </a:ln>
+        </p:spPr>
+        <p:style>
+          <a:lnRef idx="1">
+            <a:schemeClr val="accent1"/>
+          </a:lnRef>
+          <a:fillRef idx="3">
+            <a:schemeClr val="accent1"/>
+          </a:fillRef>
+          <a:effectRef idx="2">
+            <a:schemeClr val="accent1"/>
+          </a:effectRef>
+          <a:fontRef idx="minor">
+            <a:schemeClr val="lt1"/>
+          </a:fontRef>
+        </p:style>
+        <p:txBody>
+          <a:bodyPr rtlCol="0" anchor="ctr"/>
+          <a:lstStyle/>
+          <a:p>
+            <a:pPr algn="ctr"/>
+          </a:p>
+        </p:txBody>
+      </p:sp>
+      <p:sp>
+        <p:nvSpPr>
+          <p:cNvPr id="12" name="Rectangle 11"/>
+          <p:cNvSpPr/>
+          <p:nvPr/>
+        </p:nvSpPr>
+        <p:spPr>
+          <a:xfrm>
+            <a:off x="9804400" y="6604000"/>
+            <a:ext cx="139700" cy="25400"/>
+          </a:xfrm>
+          <a:prstGeom prst="rect">
+            <a:avLst/>
+          </a:prstGeom>
+          <a:solidFill>
+            <a:srgbClr val="D9E2ED"/>
+          </a:solidFill>
+          <a:ln>
+            <a:noFill/>
+          </a:ln>
+        </p:spPr>
+        <p:style>
+          <a:lnRef idx="1">
+            <a:schemeClr val="accent1"/>
+          </a:lnRef>
+          <a:fillRef idx="3">
+            <a:schemeClr val="accent1"/>
+          </a:fillRef>
+          <a:effectRef idx="2">
+            <a:schemeClr val="accent1"/>
+          </a:effectRef>
+          <a:fontRef idx="minor">
+            <a:schemeClr val="lt1"/>
+          </a:fontRef>
+        </p:style>
+        <p:txBody>
+          <a:bodyPr rtlCol="0" anchor="ctr"/>
+          <a:lstStyle/>
+          <a:p>
+            <a:pPr algn="ctr"/>
+          </a:p>
+        </p:txBody>
+      </p:sp>
+      <p:sp>
+        <p:nvSpPr>
+          <p:cNvPr id="13" name="Rectangle 12"/>
+          <p:cNvSpPr/>
+          <p:nvPr/>
+        </p:nvSpPr>
+        <p:spPr>
+          <a:xfrm>
+            <a:off x="10020300" y="6604000"/>
+            <a:ext cx="139700" cy="25400"/>
+          </a:xfrm>
+          <a:prstGeom prst="rect">
+            <a:avLst/>
+          </a:prstGeom>
+          <a:solidFill>
+            <a:srgbClr val="245CDE"/>
+          </a:solidFill>
+          <a:ln>
+            <a:noFill/>
+          </a:ln>
+        </p:spPr>
+        <p:style>
+          <a:lnRef idx="1">
+            <a:schemeClr val="accent1"/>
+          </a:lnRef>
+          <a:fillRef idx="3">
+            <a:schemeClr val="accent1"/>
+          </a:fillRef>
+          <a:effectRef idx="2">
+            <a:schemeClr val="accent1"/>
+          </a:effectRef>
+          <a:fontRef idx="minor">
+            <a:schemeClr val="lt1"/>
+          </a:fontRef>
+        </p:style>
+        <p:txBody>
+          <a:bodyPr rtlCol="0" anchor="ctr"/>
+          <a:lstStyle/>
+          <a:p>
+            <a:pPr algn="ctr"/>
+          </a:p>
+        </p:txBody>
+      </p:sp>
+      <p:sp>
+        <p:nvSpPr>
+          <p:cNvPr id="14" name="Rectangle 13"/>
+          <p:cNvSpPr/>
+          <p:nvPr/>
+        </p:nvSpPr>
+        <p:spPr>
+          <a:xfrm>
+            <a:off x="10236200" y="6604000"/>
+            <a:ext cx="139700" cy="25400"/>
+          </a:xfrm>
+          <a:prstGeom prst="rect">
+            <a:avLst/>
+          </a:prstGeom>
+          <a:solidFill>
+            <a:srgbClr val="D9E2ED"/>
+          </a:solidFill>
+          <a:ln>
+            <a:noFill/>
+          </a:ln>
+        </p:spPr>
+        <p:style>
+          <a:lnRef idx="1">
+            <a:schemeClr val="accent1"/>
+          </a:lnRef>
+          <a:fillRef idx="3">
+            <a:schemeClr val="accent1"/>
+          </a:fillRef>
+          <a:effectRef idx="2">
+            <a:schemeClr val="accent1"/>
+          </a:effectRef>
+          <a:fontRef idx="minor">
+            <a:schemeClr val="lt1"/>
+          </a:fontRef>
+        </p:style>
+        <p:txBody>
+          <a:bodyPr rtlCol="0" anchor="ctr"/>
+          <a:lstStyle/>
+          <a:p>
+            <a:pPr algn="ctr"/>
+          </a:p>
+        </p:txBody>
+      </p:sp>
+      <p:sp>
+        <p:nvSpPr>
+          <p:cNvPr id="15" name="Rectangle 14"/>
+          <p:cNvSpPr/>
+          <p:nvPr/>
+        </p:nvSpPr>
+        <p:spPr>
+          <a:xfrm>
+            <a:off x="10452100" y="6604000"/>
+            <a:ext cx="139700" cy="25400"/>
+          </a:xfrm>
+          <a:prstGeom prst="rect">
+            <a:avLst/>
+          </a:prstGeom>
+          <a:solidFill>
+            <a:srgbClr val="D9E2ED"/>
+          </a:solidFill>
+          <a:ln>
+            <a:noFill/>
+          </a:ln>
+        </p:spPr>
+        <p:style>
+          <a:lnRef idx="1">
+            <a:schemeClr val="accent1"/>
+          </a:lnRef>
+          <a:fillRef idx="3">
+            <a:schemeClr val="accent1"/>
+          </a:fillRef>
+          <a:effectRef idx="2">
+            <a:schemeClr val="accent1"/>
+          </a:effectRef>
+          <a:fontRef idx="minor">
+            <a:schemeClr val="lt1"/>
+          </a:fontRef>
+        </p:style>
+        <p:txBody>
+          <a:bodyPr rtlCol="0" anchor="ctr"/>
+          <a:lstStyle/>
+          <a:p>
+            <a:pPr algn="ctr"/>
+          </a:p>
+        </p:txBody>
+      </p:sp>
+      <p:sp>
+        <p:nvSpPr>
+          <p:cNvPr id="16" name="TextBox 15"/>
           <p:cNvSpPr txBox="1"/>
           <p:nvPr/>
         </p:nvSpPr>
@@ -10272,7 +11741,7 @@
       </p:sp>
       <p:sp>
         <p:nvSpPr>
-          <p:cNvPr id="11" name="TextBox 10"/>
+          <p:cNvPr id="17" name="TextBox 16"/>
           <p:cNvSpPr txBox="1"/>
           <p:nvPr/>
         </p:nvSpPr>
@@ -10317,7 +11786,7 @@
       </p:sp>
       <p:sp>
         <p:nvSpPr>
-          <p:cNvPr id="12" name="TextBox 11"/>
+          <p:cNvPr id="18" name="TextBox 17"/>
           <p:cNvSpPr txBox="1"/>
           <p:nvPr/>
         </p:nvSpPr>
@@ -10384,7 +11853,7 @@
       </p:sp>
       <p:sp>
         <p:nvSpPr>
-          <p:cNvPr id="13" name="TextBox 12"/>
+          <p:cNvPr id="19" name="TextBox 18"/>
           <p:cNvSpPr txBox="1"/>
           <p:nvPr/>
         </p:nvSpPr>
@@ -10429,7 +11898,247 @@
       </p:sp>
       <p:sp>
         <p:nvSpPr>
-          <p:cNvPr id="14" name="TextBox 13"/>
+          <p:cNvPr id="20" name="TextBox 19"/>
+          <p:cNvSpPr txBox="1"/>
+          <p:nvPr/>
+        </p:nvSpPr>
+        <p:spPr>
+          <a:xfrm>
+            <a:off x="6032500" y="2565400"/>
+            <a:ext cx="381000" cy="195580"/>
+          </a:xfrm>
+          <a:prstGeom prst="rect">
+            <a:avLst/>
+          </a:prstGeom>
+          <a:noFill/>
+        </p:spPr>
+        <p:txBody>
+          <a:bodyPr wrap="none" lIns="0" rIns="0" tIns="0" bIns="0">
+            <a:spAutoFit/>
+          </a:bodyPr>
+          <a:lstStyle/>
+          <a:p>
+            <a:pPr>
+              <a:lnSpc>
+                <a:spcPts val="1040"/>
+              </a:lnSpc>
+              <a:spcBef>
+                <a:spcPts val="0"/>
+              </a:spcBef>
+              <a:spcAft>
+                <a:spcPts val="0"/>
+              </a:spcAft>
+            </a:pPr>
+            <a:r>
+              <a:rPr sz="800" b="0">
+                <a:solidFill>
+                  <a:srgbClr val="637487"/>
+                </a:solidFill>
+                <a:latin typeface="Noto Sans"/>
+              </a:rPr>
+              <a:t>0</a:t>
+            </a:r>
+          </a:p>
+        </p:txBody>
+      </p:sp>
+      <p:sp>
+        <p:nvSpPr>
+          <p:cNvPr id="21" name="TextBox 20"/>
+          <p:cNvSpPr txBox="1"/>
+          <p:nvPr/>
+        </p:nvSpPr>
+        <p:spPr>
+          <a:xfrm>
+            <a:off x="8255000" y="2565400"/>
+            <a:ext cx="381000" cy="195580"/>
+          </a:xfrm>
+          <a:prstGeom prst="rect">
+            <a:avLst/>
+          </a:prstGeom>
+          <a:noFill/>
+        </p:spPr>
+        <p:txBody>
+          <a:bodyPr wrap="none" lIns="0" rIns="0" tIns="0" bIns="0">
+            <a:spAutoFit/>
+          </a:bodyPr>
+          <a:lstStyle/>
+          <a:p>
+            <a:pPr>
+              <a:lnSpc>
+                <a:spcPts val="1040"/>
+              </a:lnSpc>
+              <a:spcBef>
+                <a:spcPts val="0"/>
+              </a:spcBef>
+              <a:spcAft>
+                <a:spcPts val="0"/>
+              </a:spcAft>
+            </a:pPr>
+            <a:r>
+              <a:rPr sz="800" b="0">
+                <a:solidFill>
+                  <a:srgbClr val="637487"/>
+                </a:solidFill>
+                <a:latin typeface="Noto Sans"/>
+              </a:rPr>
+              <a:t>0.5</a:t>
+            </a:r>
+          </a:p>
+        </p:txBody>
+      </p:sp>
+      <p:sp>
+        <p:nvSpPr>
+          <p:cNvPr id="22" name="TextBox 21"/>
+          <p:cNvSpPr txBox="1"/>
+          <p:nvPr/>
+        </p:nvSpPr>
+        <p:spPr>
+          <a:xfrm>
+            <a:off x="10350500" y="2565400"/>
+            <a:ext cx="381000" cy="195580"/>
+          </a:xfrm>
+          <a:prstGeom prst="rect">
+            <a:avLst/>
+          </a:prstGeom>
+          <a:noFill/>
+        </p:spPr>
+        <p:txBody>
+          <a:bodyPr wrap="none" lIns="0" rIns="0" tIns="0" bIns="0">
+            <a:spAutoFit/>
+          </a:bodyPr>
+          <a:lstStyle/>
+          <a:p>
+            <a:pPr>
+              <a:lnSpc>
+                <a:spcPts val="1040"/>
+              </a:lnSpc>
+              <a:spcBef>
+                <a:spcPts val="0"/>
+              </a:spcBef>
+              <a:spcAft>
+                <a:spcPts val="0"/>
+              </a:spcAft>
+            </a:pPr>
+            <a:r>
+              <a:rPr sz="800" b="0">
+                <a:solidFill>
+                  <a:srgbClr val="637487"/>
+                </a:solidFill>
+                <a:latin typeface="Noto Sans"/>
+              </a:rPr>
+              <a:t>1.0</a:t>
+            </a:r>
+          </a:p>
+        </p:txBody>
+      </p:sp>
+      <p:cxnSp>
+        <p:nvCxnSpPr>
+          <p:cNvPr id="23" name="Connector 22"/>
+          <p:cNvCxnSpPr/>
+          <p:nvPr/>
+        </p:nvCxnSpPr>
+        <p:spPr>
+          <a:xfrm>
+            <a:off x="6032500" y="2768600"/>
+            <a:ext cx="0" cy="1219200"/>
+          </a:xfrm>
+          <a:prstGeom prst="line">
+            <a:avLst/>
+          </a:prstGeom>
+          <a:ln w="7620">
+            <a:solidFill>
+              <a:srgbClr val="D9E2ED"/>
+            </a:solidFill>
+          </a:ln>
+        </p:spPr>
+        <p:style>
+          <a:lnRef idx="2">
+            <a:schemeClr val="accent1"/>
+          </a:lnRef>
+          <a:fillRef idx="0">
+            <a:schemeClr val="accent1"/>
+          </a:fillRef>
+          <a:effectRef idx="1">
+            <a:schemeClr val="accent1"/>
+          </a:effectRef>
+          <a:fontRef idx="minor">
+            <a:schemeClr val="tx1"/>
+          </a:fontRef>
+        </p:style>
+      </p:cxnSp>
+      <p:cxnSp>
+        <p:nvCxnSpPr>
+          <p:cNvPr id="24" name="Connector 23"/>
+          <p:cNvCxnSpPr/>
+          <p:nvPr/>
+        </p:nvCxnSpPr>
+        <p:spPr>
+          <a:xfrm>
+            <a:off x="8255000" y="2768600"/>
+            <a:ext cx="0" cy="1219200"/>
+          </a:xfrm>
+          <a:prstGeom prst="line">
+            <a:avLst/>
+          </a:prstGeom>
+          <a:ln w="7620">
+            <a:solidFill>
+              <a:srgbClr val="D9E2ED"/>
+            </a:solidFill>
+          </a:ln>
+        </p:spPr>
+        <p:style>
+          <a:lnRef idx="2">
+            <a:schemeClr val="accent1"/>
+          </a:lnRef>
+          <a:fillRef idx="0">
+            <a:schemeClr val="accent1"/>
+          </a:fillRef>
+          <a:effectRef idx="1">
+            <a:schemeClr val="accent1"/>
+          </a:effectRef>
+          <a:fontRef idx="minor">
+            <a:schemeClr val="tx1"/>
+          </a:fontRef>
+        </p:style>
+      </p:cxnSp>
+      <p:cxnSp>
+        <p:nvCxnSpPr>
+          <p:cNvPr id="25" name="Connector 24"/>
+          <p:cNvCxnSpPr/>
+          <p:nvPr/>
+        </p:nvCxnSpPr>
+        <p:spPr>
+          <a:xfrm>
+            <a:off x="10477500" y="2768600"/>
+            <a:ext cx="0" cy="1219200"/>
+          </a:xfrm>
+          <a:prstGeom prst="line">
+            <a:avLst/>
+          </a:prstGeom>
+          <a:ln w="7620">
+            <a:solidFill>
+              <a:srgbClr val="D9E2ED"/>
+            </a:solidFill>
+          </a:ln>
+        </p:spPr>
+        <p:style>
+          <a:lnRef idx="2">
+            <a:schemeClr val="accent1"/>
+          </a:lnRef>
+          <a:fillRef idx="0">
+            <a:schemeClr val="accent1"/>
+          </a:fillRef>
+          <a:effectRef idx="1">
+            <a:schemeClr val="accent1"/>
+          </a:effectRef>
+          <a:fontRef idx="minor">
+            <a:schemeClr val="tx1"/>
+          </a:fontRef>
+        </p:style>
+      </p:cxnSp>
+      <p:sp>
+        <p:nvSpPr>
+          <p:cNvPr id="26" name="TextBox 25"/>
           <p:cNvSpPr txBox="1"/>
           <p:nvPr/>
         </p:nvSpPr>
@@ -10474,7 +12183,7 @@
       </p:sp>
       <p:sp>
         <p:nvSpPr>
-          <p:cNvPr id="15" name="Rectangle 14"/>
+          <p:cNvPr id="27" name="Rectangle 26"/>
           <p:cNvSpPr/>
           <p:nvPr/>
         </p:nvSpPr>
@@ -10517,14 +12226,14 @@
       </p:sp>
       <p:sp>
         <p:nvSpPr>
-          <p:cNvPr id="16" name="TextBox 15"/>
+          <p:cNvPr id="28" name="TextBox 27"/>
           <p:cNvSpPr txBox="1"/>
           <p:nvPr/>
         </p:nvSpPr>
         <p:spPr>
           <a:xfrm>
-            <a:off x="10756900" y="2946400"/>
-            <a:ext cx="863600" cy="393700"/>
+            <a:off x="10642600" y="2946400"/>
+            <a:ext cx="990600" cy="360680"/>
           </a:xfrm>
           <a:prstGeom prst="rect">
             <a:avLst/>
@@ -10539,7 +12248,7 @@
           <a:p>
             <a:pPr>
               <a:lnSpc>
-                <a:spcPts val="2600"/>
+                <a:spcPts val="2340"/>
               </a:lnSpc>
               <a:spcBef>
                 <a:spcPts val="0"/>
@@ -10549,20 +12258,20 @@
               </a:spcAft>
             </a:pPr>
             <a:r>
-              <a:rPr sz="2000" b="1">
+              <a:rPr sz="1800" b="1">
                 <a:solidFill>
                   <a:srgbClr val="142B40"/>
                 </a:solidFill>
                 <a:latin typeface="Noto Sans"/>
               </a:rPr>
-              <a:t>0.181</a:t>
-            </a:r>
-          </a:p>
-        </p:txBody>
-      </p:sp>
-      <p:sp>
-        <p:nvSpPr>
-          <p:cNvPr id="17" name="TextBox 16"/>
+              <a:t>0.1815</a:t>
+            </a:r>
+          </a:p>
+        </p:txBody>
+      </p:sp>
+      <p:sp>
+        <p:nvSpPr>
+          <p:cNvPr id="29" name="TextBox 28"/>
           <p:cNvSpPr txBox="1"/>
           <p:nvPr/>
         </p:nvSpPr>
@@ -10607,7 +12316,7 @@
       </p:sp>
       <p:sp>
         <p:nvSpPr>
-          <p:cNvPr id="18" name="Rectangle 17"/>
+          <p:cNvPr id="30" name="Rectangle 29"/>
           <p:cNvSpPr/>
           <p:nvPr/>
         </p:nvSpPr>
@@ -10650,14 +12359,14 @@
       </p:sp>
       <p:sp>
         <p:nvSpPr>
-          <p:cNvPr id="19" name="TextBox 18"/>
+          <p:cNvPr id="31" name="TextBox 30"/>
           <p:cNvSpPr txBox="1"/>
           <p:nvPr/>
         </p:nvSpPr>
         <p:spPr>
           <a:xfrm>
-            <a:off x="10756900" y="3619500"/>
-            <a:ext cx="863600" cy="393700"/>
+            <a:off x="10642600" y="3619500"/>
+            <a:ext cx="990600" cy="360680"/>
           </a:xfrm>
           <a:prstGeom prst="rect">
             <a:avLst/>
@@ -10672,7 +12381,7 @@
           <a:p>
             <a:pPr>
               <a:lnSpc>
-                <a:spcPts val="2600"/>
+                <a:spcPts val="2340"/>
               </a:lnSpc>
               <a:spcBef>
                 <a:spcPts val="0"/>
@@ -10682,20 +12391,20 @@
               </a:spcAft>
             </a:pPr>
             <a:r>
-              <a:rPr sz="2000" b="1">
+              <a:rPr sz="1800" b="1">
                 <a:solidFill>
                   <a:srgbClr val="142B40"/>
                 </a:solidFill>
                 <a:latin typeface="Noto Sans"/>
               </a:rPr>
-              <a:t>0.812</a:t>
-            </a:r>
-          </a:p>
-        </p:txBody>
-      </p:sp>
-      <p:sp>
-        <p:nvSpPr>
-          <p:cNvPr id="20" name="TextBox 19"/>
+              <a:t>0.8121</a:t>
+            </a:r>
+          </a:p>
+        </p:txBody>
+      </p:sp>
+      <p:sp>
+        <p:nvSpPr>
+          <p:cNvPr id="32" name="TextBox 31"/>
           <p:cNvSpPr txBox="1"/>
           <p:nvPr/>
         </p:nvSpPr>
@@ -10740,7 +12449,7 @@
       </p:sp>
       <p:cxnSp>
         <p:nvCxnSpPr>
-          <p:cNvPr id="21" name="Connector 20"/>
+          <p:cNvPr id="33" name="Connector 32"/>
           <p:cNvCxnSpPr/>
           <p:nvPr/>
         </p:nvCxnSpPr>
@@ -10775,7 +12484,7 @@
       </p:cxnSp>
       <p:sp>
         <p:nvSpPr>
-          <p:cNvPr id="22" name="TextBox 21"/>
+          <p:cNvPr id="34" name="TextBox 33"/>
           <p:cNvSpPr txBox="1"/>
           <p:nvPr/>
         </p:nvSpPr>
@@ -10820,7 +12529,7 @@
       </p:sp>
       <p:sp>
         <p:nvSpPr>
-          <p:cNvPr id="23" name="TextBox 22"/>
+          <p:cNvPr id="35" name="TextBox 34"/>
           <p:cNvSpPr txBox="1"/>
           <p:nvPr/>
         </p:nvSpPr>
@@ -10887,7 +12596,7 @@
       </p:sp>
       <p:sp>
         <p:nvSpPr>
-          <p:cNvPr id="24" name="TextBox 23"/>
+          <p:cNvPr id="36" name="TextBox 35"/>
           <p:cNvSpPr txBox="1"/>
           <p:nvPr/>
         </p:nvSpPr>
@@ -10932,7 +12641,7 @@
       </p:sp>
       <p:sp>
         <p:nvSpPr>
-          <p:cNvPr id="25" name="TextBox 24"/>
+          <p:cNvPr id="37" name="TextBox 36"/>
           <p:cNvSpPr txBox="1"/>
           <p:nvPr/>
         </p:nvSpPr>
@@ -10999,7 +12708,7 @@
       </p:sp>
       <p:sp>
         <p:nvSpPr>
-          <p:cNvPr id="26" name="TextBox 25"/>
+          <p:cNvPr id="38" name="TextBox 37"/>
           <p:cNvSpPr txBox="1"/>
           <p:nvPr/>
         </p:nvSpPr>
@@ -11044,7 +12753,7 @@
       </p:sp>
       <p:sp>
         <p:nvSpPr>
-          <p:cNvPr id="27" name="TextBox 26"/>
+          <p:cNvPr id="39" name="TextBox 38"/>
           <p:cNvSpPr txBox="1"/>
           <p:nvPr/>
         </p:nvSpPr>
@@ -11111,7 +12820,7 @@
       </p:sp>
       <p:sp>
         <p:nvSpPr>
-          <p:cNvPr id="28" name="TextBox 27"/>
+          <p:cNvPr id="40" name="TextBox 39"/>
           <p:cNvSpPr txBox="1"/>
           <p:nvPr/>
         </p:nvSpPr>
@@ -11149,7 +12858,7 @@
                 </a:solidFill>
                 <a:latin typeface="Noto Sans"/>
               </a:rPr>
-              <a:t>Learning result: the fitted policy does not consistently outperform the strongest existing baseline.</a:t>
+              <a:t>VALIDATION GATE   Learned policy remains experimental; constant-model ablation isolates the learning effect.</a:t>
             </a:r>
           </a:p>
         </p:txBody>
@@ -11532,9 +13241,267 @@
           </a:p>
         </p:txBody>
       </p:sp>
+      <p:sp>
+        <p:nvSpPr>
+          <p:cNvPr id="10" name="Rectangle 9"/>
+          <p:cNvSpPr/>
+          <p:nvPr/>
+        </p:nvSpPr>
+        <p:spPr>
+          <a:xfrm>
+            <a:off x="9372600" y="6604000"/>
+            <a:ext cx="139700" cy="25400"/>
+          </a:xfrm>
+          <a:prstGeom prst="rect">
+            <a:avLst/>
+          </a:prstGeom>
+          <a:solidFill>
+            <a:srgbClr val="D9E2ED"/>
+          </a:solidFill>
+          <a:ln>
+            <a:noFill/>
+          </a:ln>
+        </p:spPr>
+        <p:style>
+          <a:lnRef idx="1">
+            <a:schemeClr val="accent1"/>
+          </a:lnRef>
+          <a:fillRef idx="3">
+            <a:schemeClr val="accent1"/>
+          </a:fillRef>
+          <a:effectRef idx="2">
+            <a:schemeClr val="accent1"/>
+          </a:effectRef>
+          <a:fontRef idx="minor">
+            <a:schemeClr val="lt1"/>
+          </a:fontRef>
+        </p:style>
+        <p:txBody>
+          <a:bodyPr rtlCol="0" anchor="ctr"/>
+          <a:lstStyle/>
+          <a:p>
+            <a:pPr algn="ctr"/>
+          </a:p>
+        </p:txBody>
+      </p:sp>
+      <p:sp>
+        <p:nvSpPr>
+          <p:cNvPr id="11" name="Rectangle 10"/>
+          <p:cNvSpPr/>
+          <p:nvPr/>
+        </p:nvSpPr>
+        <p:spPr>
+          <a:xfrm>
+            <a:off x="9588500" y="6604000"/>
+            <a:ext cx="139700" cy="25400"/>
+          </a:xfrm>
+          <a:prstGeom prst="rect">
+            <a:avLst/>
+          </a:prstGeom>
+          <a:solidFill>
+            <a:srgbClr val="D9E2ED"/>
+          </a:solidFill>
+          <a:ln>
+            <a:noFill/>
+          </a:ln>
+        </p:spPr>
+        <p:style>
+          <a:lnRef idx="1">
+            <a:schemeClr val="accent1"/>
+          </a:lnRef>
+          <a:fillRef idx="3">
+            <a:schemeClr val="accent1"/>
+          </a:fillRef>
+          <a:effectRef idx="2">
+            <a:schemeClr val="accent1"/>
+          </a:effectRef>
+          <a:fontRef idx="minor">
+            <a:schemeClr val="lt1"/>
+          </a:fontRef>
+        </p:style>
+        <p:txBody>
+          <a:bodyPr rtlCol="0" anchor="ctr"/>
+          <a:lstStyle/>
+          <a:p>
+            <a:pPr algn="ctr"/>
+          </a:p>
+        </p:txBody>
+      </p:sp>
+      <p:sp>
+        <p:nvSpPr>
+          <p:cNvPr id="12" name="Rectangle 11"/>
+          <p:cNvSpPr/>
+          <p:nvPr/>
+        </p:nvSpPr>
+        <p:spPr>
+          <a:xfrm>
+            <a:off x="9804400" y="6604000"/>
+            <a:ext cx="139700" cy="25400"/>
+          </a:xfrm>
+          <a:prstGeom prst="rect">
+            <a:avLst/>
+          </a:prstGeom>
+          <a:solidFill>
+            <a:srgbClr val="D9E2ED"/>
+          </a:solidFill>
+          <a:ln>
+            <a:noFill/>
+          </a:ln>
+        </p:spPr>
+        <p:style>
+          <a:lnRef idx="1">
+            <a:schemeClr val="accent1"/>
+          </a:lnRef>
+          <a:fillRef idx="3">
+            <a:schemeClr val="accent1"/>
+          </a:fillRef>
+          <a:effectRef idx="2">
+            <a:schemeClr val="accent1"/>
+          </a:effectRef>
+          <a:fontRef idx="minor">
+            <a:schemeClr val="lt1"/>
+          </a:fontRef>
+        </p:style>
+        <p:txBody>
+          <a:bodyPr rtlCol="0" anchor="ctr"/>
+          <a:lstStyle/>
+          <a:p>
+            <a:pPr algn="ctr"/>
+          </a:p>
+        </p:txBody>
+      </p:sp>
+      <p:sp>
+        <p:nvSpPr>
+          <p:cNvPr id="13" name="Rectangle 12"/>
+          <p:cNvSpPr/>
+          <p:nvPr/>
+        </p:nvSpPr>
+        <p:spPr>
+          <a:xfrm>
+            <a:off x="10020300" y="6604000"/>
+            <a:ext cx="139700" cy="25400"/>
+          </a:xfrm>
+          <a:prstGeom prst="rect">
+            <a:avLst/>
+          </a:prstGeom>
+          <a:solidFill>
+            <a:srgbClr val="D9E2ED"/>
+          </a:solidFill>
+          <a:ln>
+            <a:noFill/>
+          </a:ln>
+        </p:spPr>
+        <p:style>
+          <a:lnRef idx="1">
+            <a:schemeClr val="accent1"/>
+          </a:lnRef>
+          <a:fillRef idx="3">
+            <a:schemeClr val="accent1"/>
+          </a:fillRef>
+          <a:effectRef idx="2">
+            <a:schemeClr val="accent1"/>
+          </a:effectRef>
+          <a:fontRef idx="minor">
+            <a:schemeClr val="lt1"/>
+          </a:fontRef>
+        </p:style>
+        <p:txBody>
+          <a:bodyPr rtlCol="0" anchor="ctr"/>
+          <a:lstStyle/>
+          <a:p>
+            <a:pPr algn="ctr"/>
+          </a:p>
+        </p:txBody>
+      </p:sp>
+      <p:sp>
+        <p:nvSpPr>
+          <p:cNvPr id="14" name="Rectangle 13"/>
+          <p:cNvSpPr/>
+          <p:nvPr/>
+        </p:nvSpPr>
+        <p:spPr>
+          <a:xfrm>
+            <a:off x="10236200" y="6604000"/>
+            <a:ext cx="139700" cy="25400"/>
+          </a:xfrm>
+          <a:prstGeom prst="rect">
+            <a:avLst/>
+          </a:prstGeom>
+          <a:solidFill>
+            <a:srgbClr val="245CDE"/>
+          </a:solidFill>
+          <a:ln>
+            <a:noFill/>
+          </a:ln>
+        </p:spPr>
+        <p:style>
+          <a:lnRef idx="1">
+            <a:schemeClr val="accent1"/>
+          </a:lnRef>
+          <a:fillRef idx="3">
+            <a:schemeClr val="accent1"/>
+          </a:fillRef>
+          <a:effectRef idx="2">
+            <a:schemeClr val="accent1"/>
+          </a:effectRef>
+          <a:fontRef idx="minor">
+            <a:schemeClr val="lt1"/>
+          </a:fontRef>
+        </p:style>
+        <p:txBody>
+          <a:bodyPr rtlCol="0" anchor="ctr"/>
+          <a:lstStyle/>
+          <a:p>
+            <a:pPr algn="ctr"/>
+          </a:p>
+        </p:txBody>
+      </p:sp>
+      <p:sp>
+        <p:nvSpPr>
+          <p:cNvPr id="15" name="Rectangle 14"/>
+          <p:cNvSpPr/>
+          <p:nvPr/>
+        </p:nvSpPr>
+        <p:spPr>
+          <a:xfrm>
+            <a:off x="10452100" y="6604000"/>
+            <a:ext cx="139700" cy="25400"/>
+          </a:xfrm>
+          <a:prstGeom prst="rect">
+            <a:avLst/>
+          </a:prstGeom>
+          <a:solidFill>
+            <a:srgbClr val="D9E2ED"/>
+          </a:solidFill>
+          <a:ln>
+            <a:noFill/>
+          </a:ln>
+        </p:spPr>
+        <p:style>
+          <a:lnRef idx="1">
+            <a:schemeClr val="accent1"/>
+          </a:lnRef>
+          <a:fillRef idx="3">
+            <a:schemeClr val="accent1"/>
+          </a:fillRef>
+          <a:effectRef idx="2">
+            <a:schemeClr val="accent1"/>
+          </a:effectRef>
+          <a:fontRef idx="minor">
+            <a:schemeClr val="lt1"/>
+          </a:fontRef>
+        </p:style>
+        <p:txBody>
+          <a:bodyPr rtlCol="0" anchor="ctr"/>
+          <a:lstStyle/>
+          <a:p>
+            <a:pPr algn="ctr"/>
+          </a:p>
+        </p:txBody>
+      </p:sp>
       <p:cxnSp>
         <p:nvCxnSpPr>
-          <p:cNvPr id="10" name="Connector 9"/>
+          <p:cNvPr id="16" name="Connector 15"/>
           <p:cNvCxnSpPr/>
           <p:nvPr/>
         </p:nvCxnSpPr>
@@ -11569,7 +13536,7 @@
       </p:cxnSp>
       <p:cxnSp>
         <p:nvCxnSpPr>
-          <p:cNvPr id="11" name="Connector 10"/>
+          <p:cNvPr id="17" name="Connector 16"/>
           <p:cNvCxnSpPr/>
           <p:nvPr/>
         </p:nvCxnSpPr>
@@ -11604,7 +13571,7 @@
       </p:cxnSp>
       <p:cxnSp>
         <p:nvCxnSpPr>
-          <p:cNvPr id="12" name="Connector 11"/>
+          <p:cNvPr id="18" name="Connector 17"/>
           <p:cNvCxnSpPr/>
           <p:nvPr/>
         </p:nvCxnSpPr>
@@ -11639,7 +13606,7 @@
       </p:cxnSp>
       <p:sp>
         <p:nvSpPr>
-          <p:cNvPr id="13" name="Oval 12"/>
+          <p:cNvPr id="19" name="Oval 18"/>
           <p:cNvSpPr/>
           <p:nvPr/>
         </p:nvSpPr>
@@ -11682,7 +13649,7 @@
       </p:sp>
       <p:sp>
         <p:nvSpPr>
-          <p:cNvPr id="14" name="Oval 13"/>
+          <p:cNvPr id="20" name="Oval 19"/>
           <p:cNvSpPr/>
           <p:nvPr/>
         </p:nvSpPr>
@@ -11725,7 +13692,7 @@
       </p:sp>
       <p:sp>
         <p:nvSpPr>
-          <p:cNvPr id="15" name="Oval 14"/>
+          <p:cNvPr id="21" name="Oval 20"/>
           <p:cNvSpPr/>
           <p:nvPr/>
         </p:nvSpPr>
@@ -11766,9 +13733,160 @@
           </a:p>
         </p:txBody>
       </p:sp>
-      <p:sp>
-        <p:nvSpPr>
-          <p:cNvPr id="16" name="TextBox 15"/>
+      <p:cxnSp>
+        <p:nvCxnSpPr>
+          <p:cNvPr id="22" name="Connector 21"/>
+          <p:cNvCxnSpPr/>
+          <p:nvPr/>
+        </p:nvCxnSpPr>
+        <p:spPr>
+          <a:xfrm>
+            <a:off x="3276600" y="2692400"/>
+            <a:ext cx="0" cy="1498600"/>
+          </a:xfrm>
+          <a:prstGeom prst="line">
+            <a:avLst/>
+          </a:prstGeom>
+          <a:ln w="10160">
+            <a:solidFill>
+              <a:srgbClr val="D9E2ED"/>
+            </a:solidFill>
+            <a:prstDash val="dash"/>
+          </a:ln>
+        </p:spPr>
+        <p:style>
+          <a:lnRef idx="2">
+            <a:schemeClr val="accent1"/>
+          </a:lnRef>
+          <a:fillRef idx="0">
+            <a:schemeClr val="accent1"/>
+          </a:fillRef>
+          <a:effectRef idx="1">
+            <a:schemeClr val="accent1"/>
+          </a:effectRef>
+          <a:fontRef idx="minor">
+            <a:schemeClr val="tx1"/>
+          </a:fontRef>
+        </p:style>
+      </p:cxnSp>
+      <p:cxnSp>
+        <p:nvCxnSpPr>
+          <p:cNvPr id="23" name="Connector 22"/>
+          <p:cNvCxnSpPr/>
+          <p:nvPr/>
+        </p:nvCxnSpPr>
+        <p:spPr>
+          <a:xfrm flipV="1">
+            <a:off x="1206500" y="4191000"/>
+            <a:ext cx="2070100" cy="927100"/>
+          </a:xfrm>
+          <a:prstGeom prst="line">
+            <a:avLst/>
+          </a:prstGeom>
+          <a:ln w="10160">
+            <a:solidFill>
+              <a:srgbClr val="D9E2ED"/>
+            </a:solidFill>
+            <a:prstDash val="dash"/>
+          </a:ln>
+        </p:spPr>
+        <p:style>
+          <a:lnRef idx="2">
+            <a:schemeClr val="accent1"/>
+          </a:lnRef>
+          <a:fillRef idx="0">
+            <a:schemeClr val="accent1"/>
+          </a:fillRef>
+          <a:effectRef idx="1">
+            <a:schemeClr val="accent1"/>
+          </a:effectRef>
+          <a:fontRef idx="minor">
+            <a:schemeClr val="tx1"/>
+          </a:fontRef>
+        </p:style>
+      </p:cxnSp>
+      <p:cxnSp>
+        <p:nvCxnSpPr>
+          <p:cNvPr id="24" name="Connector 23"/>
+          <p:cNvCxnSpPr/>
+          <p:nvPr/>
+        </p:nvCxnSpPr>
+        <p:spPr>
+          <a:xfrm flipH="1" flipV="1">
+            <a:off x="3276600" y="4191000"/>
+            <a:ext cx="2070100" cy="927100"/>
+          </a:xfrm>
+          <a:prstGeom prst="line">
+            <a:avLst/>
+          </a:prstGeom>
+          <a:ln w="10160">
+            <a:solidFill>
+              <a:srgbClr val="D9E2ED"/>
+            </a:solidFill>
+            <a:prstDash val="dash"/>
+          </a:ln>
+        </p:spPr>
+        <p:style>
+          <a:lnRef idx="2">
+            <a:schemeClr val="accent1"/>
+          </a:lnRef>
+          <a:fillRef idx="0">
+            <a:schemeClr val="accent1"/>
+          </a:fillRef>
+          <a:effectRef idx="1">
+            <a:schemeClr val="accent1"/>
+          </a:effectRef>
+          <a:fontRef idx="minor">
+            <a:schemeClr val="tx1"/>
+          </a:fontRef>
+        </p:style>
+      </p:cxnSp>
+      <p:sp>
+        <p:nvSpPr>
+          <p:cNvPr id="25" name="Rectangle 24"/>
+          <p:cNvSpPr/>
+          <p:nvPr/>
+        </p:nvSpPr>
+        <p:spPr>
+          <a:xfrm>
+            <a:off x="2286000" y="4038600"/>
+            <a:ext cx="2095500" cy="381000"/>
+          </a:xfrm>
+          <a:prstGeom prst="rect">
+            <a:avLst/>
+          </a:prstGeom>
+          <a:solidFill>
+            <a:srgbClr val="FFFFFF"/>
+          </a:solidFill>
+          <a:ln>
+            <a:noFill/>
+          </a:ln>
+        </p:spPr>
+        <p:style>
+          <a:lnRef idx="1">
+            <a:schemeClr val="accent1"/>
+          </a:lnRef>
+          <a:fillRef idx="3">
+            <a:schemeClr val="accent1"/>
+          </a:fillRef>
+          <a:effectRef idx="2">
+            <a:schemeClr val="accent1"/>
+          </a:effectRef>
+          <a:fontRef idx="minor">
+            <a:schemeClr val="lt1"/>
+          </a:fontRef>
+        </p:style>
+        <p:txBody>
+          <a:bodyPr rtlCol="0" anchor="ctr"/>
+          <a:lstStyle/>
+          <a:p>
+            <a:pPr algn="ctr"/>
+          </a:p>
+        </p:txBody>
+      </p:sp>
+      <p:sp>
+        <p:nvSpPr>
+          <p:cNvPr id="26" name="TextBox 25"/>
           <p:cNvSpPr txBox="1"/>
           <p:nvPr/>
         </p:nvSpPr>
@@ -11813,7 +13931,52 @@
       </p:sp>
       <p:sp>
         <p:nvSpPr>
-          <p:cNvPr id="17" name="TextBox 16"/>
+          <p:cNvPr id="27" name="TextBox 26"/>
+          <p:cNvSpPr txBox="1"/>
+          <p:nvPr/>
+        </p:nvSpPr>
+        <p:spPr>
+          <a:xfrm>
+            <a:off x="2654300" y="2463800"/>
+            <a:ext cx="2286000" cy="228600"/>
+          </a:xfrm>
+          <a:prstGeom prst="rect">
+            <a:avLst/>
+          </a:prstGeom>
+          <a:noFill/>
+        </p:spPr>
+        <p:txBody>
+          <a:bodyPr wrap="none" lIns="0" rIns="0" tIns="0" bIns="0">
+            <a:spAutoFit/>
+          </a:bodyPr>
+          <a:lstStyle/>
+          <a:p>
+            <a:pPr>
+              <a:lnSpc>
+                <a:spcPts val="1300"/>
+              </a:lnSpc>
+              <a:spcBef>
+                <a:spcPts val="0"/>
+              </a:spcBef>
+              <a:spcAft>
+                <a:spcPts val="0"/>
+              </a:spcAft>
+            </a:pPr>
+            <a:r>
+              <a:rPr sz="1000" b="0">
+                <a:solidFill>
+                  <a:srgbClr val="637487"/>
+                </a:solidFill>
+                <a:latin typeface="Noto Sans"/>
+              </a:rPr>
+              <a:t>Capture more activity</a:t>
+            </a:r>
+          </a:p>
+        </p:txBody>
+      </p:sp>
+      <p:sp>
+        <p:nvSpPr>
+          <p:cNvPr id="28" name="TextBox 27"/>
           <p:cNvSpPr txBox="1"/>
           <p:nvPr/>
         </p:nvSpPr>
@@ -11858,7 +14021,52 @@
       </p:sp>
       <p:sp>
         <p:nvSpPr>
-          <p:cNvPr id="18" name="TextBox 17"/>
+          <p:cNvPr id="29" name="TextBox 28"/>
+          <p:cNvSpPr txBox="1"/>
+          <p:nvPr/>
+        </p:nvSpPr>
+        <p:spPr>
+          <a:xfrm>
+            <a:off x="558800" y="5791200"/>
+            <a:ext cx="2476500" cy="228600"/>
+          </a:xfrm>
+          <a:prstGeom prst="rect">
+            <a:avLst/>
+          </a:prstGeom>
+          <a:noFill/>
+        </p:spPr>
+        <p:txBody>
+          <a:bodyPr wrap="none" lIns="0" rIns="0" tIns="0" bIns="0">
+            <a:spAutoFit/>
+          </a:bodyPr>
+          <a:lstStyle/>
+          <a:p>
+            <a:pPr>
+              <a:lnSpc>
+                <a:spcPts val="1300"/>
+              </a:lnSpc>
+              <a:spcBef>
+                <a:spcPts val="0"/>
+              </a:spcBef>
+              <a:spcAft>
+                <a:spcPts val="0"/>
+              </a:spcAft>
+            </a:pPr>
+            <a:r>
+              <a:rPr sz="1000" b="0">
+                <a:solidFill>
+                  <a:srgbClr val="637487"/>
+                </a:solidFill>
+                <a:latin typeface="Noto Sans"/>
+              </a:rPr>
+              <a:t>Avoid neglected bands</a:t>
+            </a:r>
+          </a:p>
+        </p:txBody>
+      </p:sp>
+      <p:sp>
+        <p:nvSpPr>
+          <p:cNvPr id="30" name="TextBox 29"/>
           <p:cNvSpPr txBox="1"/>
           <p:nvPr/>
         </p:nvSpPr>
@@ -11903,7 +14111,52 @@
       </p:sp>
       <p:sp>
         <p:nvSpPr>
-          <p:cNvPr id="19" name="TextBox 18"/>
+          <p:cNvPr id="31" name="TextBox 30"/>
+          <p:cNvSpPr txBox="1"/>
+          <p:nvPr/>
+        </p:nvSpPr>
+        <p:spPr>
+          <a:xfrm>
+            <a:off x="4445000" y="5791200"/>
+            <a:ext cx="2159000" cy="228600"/>
+          </a:xfrm>
+          <a:prstGeom prst="rect">
+            <a:avLst/>
+          </a:prstGeom>
+          <a:noFill/>
+        </p:spPr>
+        <p:txBody>
+          <a:bodyPr wrap="none" lIns="0" rIns="0" tIns="0" bIns="0">
+            <a:spAutoFit/>
+          </a:bodyPr>
+          <a:lstStyle/>
+          <a:p>
+            <a:pPr>
+              <a:lnSpc>
+                <a:spcPts val="1300"/>
+              </a:lnSpc>
+              <a:spcBef>
+                <a:spcPts val="0"/>
+              </a:spcBef>
+              <a:spcAft>
+                <a:spcPts val="0"/>
+              </a:spcAft>
+            </a:pPr>
+            <a:r>
+              <a:rPr sz="1000" b="0">
+                <a:solidFill>
+                  <a:srgbClr val="637487"/>
+                </a:solidFill>
+                <a:latin typeface="Noto Sans"/>
+              </a:rPr>
+              <a:t>Preserve listening time</a:t>
+            </a:r>
+          </a:p>
+        </p:txBody>
+      </p:sp>
+      <p:sp>
+        <p:nvSpPr>
+          <p:cNvPr id="32" name="TextBox 31"/>
           <p:cNvSpPr txBox="1"/>
           <p:nvPr/>
         </p:nvSpPr>
@@ -11948,7 +14201,7 @@
       </p:sp>
       <p:sp>
         <p:nvSpPr>
-          <p:cNvPr id="20" name="TextBox 19"/>
+          <p:cNvPr id="33" name="TextBox 32"/>
           <p:cNvSpPr txBox="1"/>
           <p:nvPr/>
         </p:nvSpPr>
@@ -11993,7 +14246,7 @@
       </p:sp>
       <p:sp>
         <p:nvSpPr>
-          <p:cNvPr id="21" name="TextBox 20"/>
+          <p:cNvPr id="34" name="TextBox 33"/>
           <p:cNvSpPr txBox="1"/>
           <p:nvPr/>
         </p:nvSpPr>
@@ -12038,7 +14291,7 @@
       </p:sp>
       <p:sp>
         <p:nvSpPr>
-          <p:cNvPr id="22" name="TextBox 21"/>
+          <p:cNvPr id="35" name="TextBox 34"/>
           <p:cNvSpPr txBox="1"/>
           <p:nvPr/>
         </p:nvSpPr>
@@ -12083,7 +14336,7 @@
       </p:sp>
       <p:sp>
         <p:nvSpPr>
-          <p:cNvPr id="23" name="TextBox 22"/>
+          <p:cNvPr id="36" name="TextBox 35"/>
           <p:cNvSpPr txBox="1"/>
           <p:nvPr/>
         </p:nvSpPr>
@@ -12128,7 +14381,7 @@
       </p:sp>
       <p:sp>
         <p:nvSpPr>
-          <p:cNvPr id="24" name="TextBox 23"/>
+          <p:cNvPr id="37" name="TextBox 36"/>
           <p:cNvSpPr txBox="1"/>
           <p:nvPr/>
         </p:nvSpPr>
@@ -12173,7 +14426,7 @@
       </p:sp>
       <p:sp>
         <p:nvSpPr>
-          <p:cNvPr id="25" name="TextBox 24"/>
+          <p:cNvPr id="38" name="TextBox 37"/>
           <p:cNvSpPr txBox="1"/>
           <p:nvPr/>
         </p:nvSpPr>
@@ -12218,7 +14471,7 @@
       </p:sp>
       <p:sp>
         <p:nvSpPr>
-          <p:cNvPr id="26" name="TextBox 25"/>
+          <p:cNvPr id="39" name="TextBox 38"/>
           <p:cNvSpPr txBox="1"/>
           <p:nvPr/>
         </p:nvSpPr>
@@ -12641,7 +14894,265 @@
       </p:sp>
       <p:sp>
         <p:nvSpPr>
-          <p:cNvPr id="10" name="TextBox 9"/>
+          <p:cNvPr id="10" name="Rectangle 9"/>
+          <p:cNvSpPr/>
+          <p:nvPr/>
+        </p:nvSpPr>
+        <p:spPr>
+          <a:xfrm>
+            <a:off x="9372600" y="6604000"/>
+            <a:ext cx="139700" cy="25400"/>
+          </a:xfrm>
+          <a:prstGeom prst="rect">
+            <a:avLst/>
+          </a:prstGeom>
+          <a:solidFill>
+            <a:srgbClr val="D9E2ED"/>
+          </a:solidFill>
+          <a:ln>
+            <a:noFill/>
+          </a:ln>
+        </p:spPr>
+        <p:style>
+          <a:lnRef idx="1">
+            <a:schemeClr val="accent1"/>
+          </a:lnRef>
+          <a:fillRef idx="3">
+            <a:schemeClr val="accent1"/>
+          </a:fillRef>
+          <a:effectRef idx="2">
+            <a:schemeClr val="accent1"/>
+          </a:effectRef>
+          <a:fontRef idx="minor">
+            <a:schemeClr val="lt1"/>
+          </a:fontRef>
+        </p:style>
+        <p:txBody>
+          <a:bodyPr rtlCol="0" anchor="ctr"/>
+          <a:lstStyle/>
+          <a:p>
+            <a:pPr algn="ctr"/>
+          </a:p>
+        </p:txBody>
+      </p:sp>
+      <p:sp>
+        <p:nvSpPr>
+          <p:cNvPr id="11" name="Rectangle 10"/>
+          <p:cNvSpPr/>
+          <p:nvPr/>
+        </p:nvSpPr>
+        <p:spPr>
+          <a:xfrm>
+            <a:off x="9588500" y="6604000"/>
+            <a:ext cx="139700" cy="25400"/>
+          </a:xfrm>
+          <a:prstGeom prst="rect">
+            <a:avLst/>
+          </a:prstGeom>
+          <a:solidFill>
+            <a:srgbClr val="D9E2ED"/>
+          </a:solidFill>
+          <a:ln>
+            <a:noFill/>
+          </a:ln>
+        </p:spPr>
+        <p:style>
+          <a:lnRef idx="1">
+            <a:schemeClr val="accent1"/>
+          </a:lnRef>
+          <a:fillRef idx="3">
+            <a:schemeClr val="accent1"/>
+          </a:fillRef>
+          <a:effectRef idx="2">
+            <a:schemeClr val="accent1"/>
+          </a:effectRef>
+          <a:fontRef idx="minor">
+            <a:schemeClr val="lt1"/>
+          </a:fontRef>
+        </p:style>
+        <p:txBody>
+          <a:bodyPr rtlCol="0" anchor="ctr"/>
+          <a:lstStyle/>
+          <a:p>
+            <a:pPr algn="ctr"/>
+          </a:p>
+        </p:txBody>
+      </p:sp>
+      <p:sp>
+        <p:nvSpPr>
+          <p:cNvPr id="12" name="Rectangle 11"/>
+          <p:cNvSpPr/>
+          <p:nvPr/>
+        </p:nvSpPr>
+        <p:spPr>
+          <a:xfrm>
+            <a:off x="9804400" y="6604000"/>
+            <a:ext cx="139700" cy="25400"/>
+          </a:xfrm>
+          <a:prstGeom prst="rect">
+            <a:avLst/>
+          </a:prstGeom>
+          <a:solidFill>
+            <a:srgbClr val="D9E2ED"/>
+          </a:solidFill>
+          <a:ln>
+            <a:noFill/>
+          </a:ln>
+        </p:spPr>
+        <p:style>
+          <a:lnRef idx="1">
+            <a:schemeClr val="accent1"/>
+          </a:lnRef>
+          <a:fillRef idx="3">
+            <a:schemeClr val="accent1"/>
+          </a:fillRef>
+          <a:effectRef idx="2">
+            <a:schemeClr val="accent1"/>
+          </a:effectRef>
+          <a:fontRef idx="minor">
+            <a:schemeClr val="lt1"/>
+          </a:fontRef>
+        </p:style>
+        <p:txBody>
+          <a:bodyPr rtlCol="0" anchor="ctr"/>
+          <a:lstStyle/>
+          <a:p>
+            <a:pPr algn="ctr"/>
+          </a:p>
+        </p:txBody>
+      </p:sp>
+      <p:sp>
+        <p:nvSpPr>
+          <p:cNvPr id="13" name="Rectangle 12"/>
+          <p:cNvSpPr/>
+          <p:nvPr/>
+        </p:nvSpPr>
+        <p:spPr>
+          <a:xfrm>
+            <a:off x="10020300" y="6604000"/>
+            <a:ext cx="139700" cy="25400"/>
+          </a:xfrm>
+          <a:prstGeom prst="rect">
+            <a:avLst/>
+          </a:prstGeom>
+          <a:solidFill>
+            <a:srgbClr val="D9E2ED"/>
+          </a:solidFill>
+          <a:ln>
+            <a:noFill/>
+          </a:ln>
+        </p:spPr>
+        <p:style>
+          <a:lnRef idx="1">
+            <a:schemeClr val="accent1"/>
+          </a:lnRef>
+          <a:fillRef idx="3">
+            <a:schemeClr val="accent1"/>
+          </a:fillRef>
+          <a:effectRef idx="2">
+            <a:schemeClr val="accent1"/>
+          </a:effectRef>
+          <a:fontRef idx="minor">
+            <a:schemeClr val="lt1"/>
+          </a:fontRef>
+        </p:style>
+        <p:txBody>
+          <a:bodyPr rtlCol="0" anchor="ctr"/>
+          <a:lstStyle/>
+          <a:p>
+            <a:pPr algn="ctr"/>
+          </a:p>
+        </p:txBody>
+      </p:sp>
+      <p:sp>
+        <p:nvSpPr>
+          <p:cNvPr id="14" name="Rectangle 13"/>
+          <p:cNvSpPr/>
+          <p:nvPr/>
+        </p:nvSpPr>
+        <p:spPr>
+          <a:xfrm>
+            <a:off x="10236200" y="6604000"/>
+            <a:ext cx="139700" cy="25400"/>
+          </a:xfrm>
+          <a:prstGeom prst="rect">
+            <a:avLst/>
+          </a:prstGeom>
+          <a:solidFill>
+            <a:srgbClr val="D9E2ED"/>
+          </a:solidFill>
+          <a:ln>
+            <a:noFill/>
+          </a:ln>
+        </p:spPr>
+        <p:style>
+          <a:lnRef idx="1">
+            <a:schemeClr val="accent1"/>
+          </a:lnRef>
+          <a:fillRef idx="3">
+            <a:schemeClr val="accent1"/>
+          </a:fillRef>
+          <a:effectRef idx="2">
+            <a:schemeClr val="accent1"/>
+          </a:effectRef>
+          <a:fontRef idx="minor">
+            <a:schemeClr val="lt1"/>
+          </a:fontRef>
+        </p:style>
+        <p:txBody>
+          <a:bodyPr rtlCol="0" anchor="ctr"/>
+          <a:lstStyle/>
+          <a:p>
+            <a:pPr algn="ctr"/>
+          </a:p>
+        </p:txBody>
+      </p:sp>
+      <p:sp>
+        <p:nvSpPr>
+          <p:cNvPr id="15" name="Rectangle 14"/>
+          <p:cNvSpPr/>
+          <p:nvPr/>
+        </p:nvSpPr>
+        <p:spPr>
+          <a:xfrm>
+            <a:off x="10452100" y="6604000"/>
+            <a:ext cx="139700" cy="25400"/>
+          </a:xfrm>
+          <a:prstGeom prst="rect">
+            <a:avLst/>
+          </a:prstGeom>
+          <a:solidFill>
+            <a:srgbClr val="245CDE"/>
+          </a:solidFill>
+          <a:ln>
+            <a:noFill/>
+          </a:ln>
+        </p:spPr>
+        <p:style>
+          <a:lnRef idx="1">
+            <a:schemeClr val="accent1"/>
+          </a:lnRef>
+          <a:fillRef idx="3">
+            <a:schemeClr val="accent1"/>
+          </a:fillRef>
+          <a:effectRef idx="2">
+            <a:schemeClr val="accent1"/>
+          </a:effectRef>
+          <a:fontRef idx="minor">
+            <a:schemeClr val="lt1"/>
+          </a:fontRef>
+        </p:style>
+        <p:txBody>
+          <a:bodyPr rtlCol="0" anchor="ctr"/>
+          <a:lstStyle/>
+          <a:p>
+            <a:pPr algn="ctr"/>
+          </a:p>
+        </p:txBody>
+      </p:sp>
+      <p:sp>
+        <p:nvSpPr>
+          <p:cNvPr id="16" name="TextBox 15"/>
           <p:cNvSpPr txBox="1"/>
           <p:nvPr/>
         </p:nvSpPr>
@@ -12686,7 +15197,7 @@
       </p:sp>
       <p:sp>
         <p:nvSpPr>
-          <p:cNvPr id="11" name="TextBox 10"/>
+          <p:cNvPr id="17" name="TextBox 16"/>
           <p:cNvSpPr txBox="1"/>
           <p:nvPr/>
         </p:nvSpPr>
@@ -12731,7 +15242,7 @@
       </p:sp>
       <p:cxnSp>
         <p:nvCxnSpPr>
-          <p:cNvPr id="12" name="Connector 11"/>
+          <p:cNvPr id="18" name="Connector 17"/>
           <p:cNvCxnSpPr/>
           <p:nvPr/>
         </p:nvCxnSpPr>
@@ -12767,7 +15278,7 @@
       </p:cxnSp>
       <p:sp>
         <p:nvSpPr>
-          <p:cNvPr id="13" name="TextBox 12"/>
+          <p:cNvPr id="19" name="TextBox 18"/>
           <p:cNvSpPr txBox="1"/>
           <p:nvPr/>
         </p:nvSpPr>
@@ -12813,7 +15324,7 @@
       </p:sp>
       <p:sp>
         <p:nvSpPr>
-          <p:cNvPr id="14" name="TextBox 13"/>
+          <p:cNvPr id="20" name="TextBox 19"/>
           <p:cNvSpPr txBox="1"/>
           <p:nvPr/>
         </p:nvSpPr>
@@ -12859,7 +15370,7 @@
       </p:sp>
       <p:cxnSp>
         <p:nvCxnSpPr>
-          <p:cNvPr id="15" name="Connector 14"/>
+          <p:cNvPr id="21" name="Connector 20"/>
           <p:cNvCxnSpPr/>
           <p:nvPr/>
         </p:nvCxnSpPr>
@@ -12894,7 +15405,7 @@
       </p:cxnSp>
       <p:sp>
         <p:nvSpPr>
-          <p:cNvPr id="16" name="TextBox 15"/>
+          <p:cNvPr id="22" name="TextBox 21"/>
           <p:cNvSpPr txBox="1"/>
           <p:nvPr/>
         </p:nvSpPr>
@@ -12939,7 +15450,7 @@
       </p:sp>
       <p:sp>
         <p:nvSpPr>
-          <p:cNvPr id="17" name="TextBox 16"/>
+          <p:cNvPr id="23" name="TextBox 22"/>
           <p:cNvSpPr txBox="1"/>
           <p:nvPr/>
         </p:nvSpPr>
@@ -12984,7 +15495,7 @@
       </p:sp>
       <p:cxnSp>
         <p:nvCxnSpPr>
-          <p:cNvPr id="18" name="Connector 17"/>
+          <p:cNvPr id="24" name="Connector 23"/>
           <p:cNvCxnSpPr/>
           <p:nvPr/>
         </p:nvCxnSpPr>
@@ -13020,7 +15531,7 @@
       </p:cxnSp>
       <p:sp>
         <p:nvSpPr>
-          <p:cNvPr id="19" name="TextBox 18"/>
+          <p:cNvPr id="25" name="TextBox 24"/>
           <p:cNvSpPr txBox="1"/>
           <p:nvPr/>
         </p:nvSpPr>
@@ -13066,7 +15577,7 @@
       </p:sp>
       <p:sp>
         <p:nvSpPr>
-          <p:cNvPr id="20" name="TextBox 19"/>
+          <p:cNvPr id="26" name="TextBox 25"/>
           <p:cNvSpPr txBox="1"/>
           <p:nvPr/>
         </p:nvSpPr>
@@ -13112,7 +15623,7 @@
       </p:sp>
       <p:cxnSp>
         <p:nvCxnSpPr>
-          <p:cNvPr id="21" name="Connector 20"/>
+          <p:cNvPr id="27" name="Connector 26"/>
           <p:cNvCxnSpPr/>
           <p:nvPr/>
         </p:nvCxnSpPr>
@@ -13147,7 +15658,7 @@
       </p:cxnSp>
       <p:sp>
         <p:nvSpPr>
-          <p:cNvPr id="22" name="TextBox 21"/>
+          <p:cNvPr id="28" name="TextBox 27"/>
           <p:cNvSpPr txBox="1"/>
           <p:nvPr/>
         </p:nvSpPr>
@@ -13192,7 +15703,7 @@
       </p:sp>
       <p:sp>
         <p:nvSpPr>
-          <p:cNvPr id="23" name="TextBox 22"/>
+          <p:cNvPr id="29" name="TextBox 28"/>
           <p:cNvSpPr txBox="1"/>
           <p:nvPr/>
         </p:nvSpPr>
@@ -13237,7 +15748,7 @@
       </p:sp>
       <p:cxnSp>
         <p:nvCxnSpPr>
-          <p:cNvPr id="24" name="Connector 23"/>
+          <p:cNvPr id="30" name="Connector 29"/>
           <p:cNvCxnSpPr/>
           <p:nvPr/>
         </p:nvCxnSpPr>
@@ -13273,7 +15784,7 @@
       </p:cxnSp>
       <p:sp>
         <p:nvSpPr>
-          <p:cNvPr id="25" name="TextBox 24"/>
+          <p:cNvPr id="31" name="TextBox 30"/>
           <p:cNvSpPr txBox="1"/>
           <p:nvPr/>
         </p:nvSpPr>
@@ -13319,7 +15830,7 @@
       </p:sp>
       <p:sp>
         <p:nvSpPr>
-          <p:cNvPr id="26" name="TextBox 25"/>
+          <p:cNvPr id="32" name="TextBox 31"/>
           <p:cNvSpPr txBox="1"/>
           <p:nvPr/>
         </p:nvSpPr>
@@ -13365,7 +15876,7 @@
       </p:sp>
       <p:sp>
         <p:nvSpPr>
-          <p:cNvPr id="27" name="TextBox 26"/>
+          <p:cNvPr id="33" name="TextBox 32"/>
           <p:cNvSpPr txBox="1"/>
           <p:nvPr/>
         </p:nvSpPr>

</xml_diff>